<commit_message>
Add time function locations to the reference appendix
New appendix slide maps class02's time APIs (time, clock_gettime,
clock_getres, localtime/gmtime, mktime, strftime, difftime) to their
headers, glibc files, and kernel implementations, verified on
kernel.org stable linux-7.2.y: time/gettimeofday in kernel/time/time.c,
clock_* syscalls in kernel/time/posix-stubs.c, vDSO fast path in
lib/vdso/gettimeofday.c
</commit_message>
<xml_diff>
--- a/Presentations/class05-01-code.pptx
+++ b/Presentations/class05-01-code.pptx
@@ -2,44 +2,45 @@
 <file path=ppt/presentation.xml><?xml version="1.0" encoding="utf-8"?>
 <p:presentation xmlns:p="http://schemas.openxmlformats.org/presentationml/2006/main">
   <p:sldMasterIdLst>
-    <p:sldMasterId xmlns:r="http://schemas.openxmlformats.org/officeDocument/2006/relationships" id="2147483648" r:id="R88f7b790023d4811"/>
+    <p:sldMasterId xmlns:r="http://schemas.openxmlformats.org/officeDocument/2006/relationships" id="2147483648" r:id="R95df60c0968d4ade"/>
   </p:sldMasterIdLst>
   <p:notesMasterIdLst>
-    <p:notesMasterId xmlns:r="http://schemas.openxmlformats.org/officeDocument/2006/relationships" r:id="R0290f0c2180b4c1c"/>
+    <p:notesMasterId xmlns:r="http://schemas.openxmlformats.org/officeDocument/2006/relationships" r:id="Re0c7af80e3f34d9d"/>
   </p:notesMasterIdLst>
   <p:sldIdLst>
-    <p:sldId xmlns:r="http://schemas.openxmlformats.org/officeDocument/2006/relationships" id="256" r:id="R408949d90eba4a2c"/>
-    <p:sldId xmlns:r="http://schemas.openxmlformats.org/officeDocument/2006/relationships" id="257" r:id="R68cff528ed8246df"/>
-    <p:sldId xmlns:r="http://schemas.openxmlformats.org/officeDocument/2006/relationships" id="258" r:id="R98763b1cc8ab4983"/>
-    <p:sldId xmlns:r="http://schemas.openxmlformats.org/officeDocument/2006/relationships" id="259" r:id="R72ece38bac86452a"/>
-    <p:sldId xmlns:r="http://schemas.openxmlformats.org/officeDocument/2006/relationships" id="260" r:id="Rc65c4903f4ef4071"/>
-    <p:sldId xmlns:r="http://schemas.openxmlformats.org/officeDocument/2006/relationships" id="261" r:id="Rb8f703190680412f"/>
-    <p:sldId xmlns:r="http://schemas.openxmlformats.org/officeDocument/2006/relationships" id="262" r:id="R49761534116d4b3f"/>
-    <p:sldId xmlns:r="http://schemas.openxmlformats.org/officeDocument/2006/relationships" id="263" r:id="R20c331bb687141ad"/>
-    <p:sldId xmlns:r="http://schemas.openxmlformats.org/officeDocument/2006/relationships" id="264" r:id="R5062b8fcff2a42dd"/>
-    <p:sldId xmlns:r="http://schemas.openxmlformats.org/officeDocument/2006/relationships" id="265" r:id="Rafedb135b014404f"/>
-    <p:sldId xmlns:r="http://schemas.openxmlformats.org/officeDocument/2006/relationships" id="266" r:id="Ra9243296ba134255"/>
-    <p:sldId xmlns:r="http://schemas.openxmlformats.org/officeDocument/2006/relationships" id="267" r:id="R1d253160a3694242"/>
-    <p:sldId xmlns:r="http://schemas.openxmlformats.org/officeDocument/2006/relationships" id="268" r:id="Rc35cef7e94314dd0"/>
-    <p:sldId xmlns:r="http://schemas.openxmlformats.org/officeDocument/2006/relationships" id="269" r:id="R157ba3d87799466b"/>
-    <p:sldId xmlns:r="http://schemas.openxmlformats.org/officeDocument/2006/relationships" id="270" r:id="Rf149eb6985b9433d"/>
-    <p:sldId xmlns:r="http://schemas.openxmlformats.org/officeDocument/2006/relationships" id="271" r:id="Rf3d621226df64cc6"/>
-    <p:sldId xmlns:r="http://schemas.openxmlformats.org/officeDocument/2006/relationships" id="272" r:id="R449bd2caa89245f4"/>
-    <p:sldId xmlns:r="http://schemas.openxmlformats.org/officeDocument/2006/relationships" id="273" r:id="R836bff608a2a4b87"/>
-    <p:sldId xmlns:r="http://schemas.openxmlformats.org/officeDocument/2006/relationships" id="274" r:id="Rd1194349deda4f01"/>
-    <p:sldId xmlns:r="http://schemas.openxmlformats.org/officeDocument/2006/relationships" id="275" r:id="Ra8bae9bac4ed45b1"/>
-    <p:sldId xmlns:r="http://schemas.openxmlformats.org/officeDocument/2006/relationships" id="276" r:id="Ra44173a159e6416d"/>
-    <p:sldId xmlns:r="http://schemas.openxmlformats.org/officeDocument/2006/relationships" id="277" r:id="Rf50438bc98bc427e"/>
-    <p:sldId xmlns:r="http://schemas.openxmlformats.org/officeDocument/2006/relationships" id="278" r:id="R0b93a0c620694233"/>
-    <p:sldId xmlns:r="http://schemas.openxmlformats.org/officeDocument/2006/relationships" id="279" r:id="Rf987b4bfd7964ddf"/>
-    <p:sldId xmlns:r="http://schemas.openxmlformats.org/officeDocument/2006/relationships" id="280" r:id="R709555147df3428c"/>
-    <p:sldId xmlns:r="http://schemas.openxmlformats.org/officeDocument/2006/relationships" id="281" r:id="R8ebbafcd03ee4787"/>
-    <p:sldId xmlns:r="http://schemas.openxmlformats.org/officeDocument/2006/relationships" id="282" r:id="R40fe0ea323224805"/>
-    <p:sldId xmlns:r="http://schemas.openxmlformats.org/officeDocument/2006/relationships" id="283" r:id="R1a80f2b44c504719"/>
-    <p:sldId xmlns:r="http://schemas.openxmlformats.org/officeDocument/2006/relationships" id="284" r:id="R216119bd4f634375"/>
-    <p:sldId xmlns:r="http://schemas.openxmlformats.org/officeDocument/2006/relationships" id="285" r:id="R0e0dc1b2ad054c19"/>
-    <p:sldId xmlns:r="http://schemas.openxmlformats.org/officeDocument/2006/relationships" id="286" r:id="R22238ae4a6c54bac"/>
-    <p:sldId xmlns:r="http://schemas.openxmlformats.org/officeDocument/2006/relationships" id="287" r:id="R64558257973a426e"/>
+    <p:sldId xmlns:r="http://schemas.openxmlformats.org/officeDocument/2006/relationships" id="256" r:id="R85d74801a8da43e1"/>
+    <p:sldId xmlns:r="http://schemas.openxmlformats.org/officeDocument/2006/relationships" id="257" r:id="Re13f81caf8304f03"/>
+    <p:sldId xmlns:r="http://schemas.openxmlformats.org/officeDocument/2006/relationships" id="258" r:id="Ra14fe9fc2dc0409a"/>
+    <p:sldId xmlns:r="http://schemas.openxmlformats.org/officeDocument/2006/relationships" id="259" r:id="Red41552d15be450b"/>
+    <p:sldId xmlns:r="http://schemas.openxmlformats.org/officeDocument/2006/relationships" id="260" r:id="R81c659a46dfd44a8"/>
+    <p:sldId xmlns:r="http://schemas.openxmlformats.org/officeDocument/2006/relationships" id="261" r:id="Rc4f705cd050e4886"/>
+    <p:sldId xmlns:r="http://schemas.openxmlformats.org/officeDocument/2006/relationships" id="262" r:id="R3a0885b0561d4d36"/>
+    <p:sldId xmlns:r="http://schemas.openxmlformats.org/officeDocument/2006/relationships" id="263" r:id="Ra91ca645b7ac4a19"/>
+    <p:sldId xmlns:r="http://schemas.openxmlformats.org/officeDocument/2006/relationships" id="264" r:id="R88cb7ccb9b7a4fad"/>
+    <p:sldId xmlns:r="http://schemas.openxmlformats.org/officeDocument/2006/relationships" id="265" r:id="R59c7e68228c84a6e"/>
+    <p:sldId xmlns:r="http://schemas.openxmlformats.org/officeDocument/2006/relationships" id="266" r:id="R4eb0c292dd8c4ca7"/>
+    <p:sldId xmlns:r="http://schemas.openxmlformats.org/officeDocument/2006/relationships" id="267" r:id="Rfaedd58cce024c64"/>
+    <p:sldId xmlns:r="http://schemas.openxmlformats.org/officeDocument/2006/relationships" id="268" r:id="R99dd1b442d3342fa"/>
+    <p:sldId xmlns:r="http://schemas.openxmlformats.org/officeDocument/2006/relationships" id="269" r:id="Rd85f4f5f1f1c4de8"/>
+    <p:sldId xmlns:r="http://schemas.openxmlformats.org/officeDocument/2006/relationships" id="270" r:id="Rba9aa7264ce642d8"/>
+    <p:sldId xmlns:r="http://schemas.openxmlformats.org/officeDocument/2006/relationships" id="271" r:id="Rf1ca7ad4e33b4439"/>
+    <p:sldId xmlns:r="http://schemas.openxmlformats.org/officeDocument/2006/relationships" id="272" r:id="Rd212de6150fa4d1d"/>
+    <p:sldId xmlns:r="http://schemas.openxmlformats.org/officeDocument/2006/relationships" id="273" r:id="R769a692c90bd4c4e"/>
+    <p:sldId xmlns:r="http://schemas.openxmlformats.org/officeDocument/2006/relationships" id="274" r:id="R5075f6aae4b24c59"/>
+    <p:sldId xmlns:r="http://schemas.openxmlformats.org/officeDocument/2006/relationships" id="275" r:id="R426c9ebedb7b4c20"/>
+    <p:sldId xmlns:r="http://schemas.openxmlformats.org/officeDocument/2006/relationships" id="276" r:id="R6f388e5d8c34471f"/>
+    <p:sldId xmlns:r="http://schemas.openxmlformats.org/officeDocument/2006/relationships" id="277" r:id="R3b6b313050e145ac"/>
+    <p:sldId xmlns:r="http://schemas.openxmlformats.org/officeDocument/2006/relationships" id="278" r:id="R589db840305045b8"/>
+    <p:sldId xmlns:r="http://schemas.openxmlformats.org/officeDocument/2006/relationships" id="279" r:id="R3bc8c8bb710540d4"/>
+    <p:sldId xmlns:r="http://schemas.openxmlformats.org/officeDocument/2006/relationships" id="280" r:id="R899da088e71a4b6e"/>
+    <p:sldId xmlns:r="http://schemas.openxmlformats.org/officeDocument/2006/relationships" id="281" r:id="Rfbc77012632f4947"/>
+    <p:sldId xmlns:r="http://schemas.openxmlformats.org/officeDocument/2006/relationships" id="282" r:id="Re120705d414b4fde"/>
+    <p:sldId xmlns:r="http://schemas.openxmlformats.org/officeDocument/2006/relationships" id="283" r:id="R491461b3a782442b"/>
+    <p:sldId xmlns:r="http://schemas.openxmlformats.org/officeDocument/2006/relationships" id="284" r:id="R8d7a4a6e26cd4d28"/>
+    <p:sldId xmlns:r="http://schemas.openxmlformats.org/officeDocument/2006/relationships" id="285" r:id="R6a3de331db5f492a"/>
+    <p:sldId xmlns:r="http://schemas.openxmlformats.org/officeDocument/2006/relationships" id="286" r:id="R1f4f69b0387c41cb"/>
+    <p:sldId xmlns:r="http://schemas.openxmlformats.org/officeDocument/2006/relationships" id="287" r:id="R3cf515ddead849e7"/>
+    <p:sldId xmlns:r="http://schemas.openxmlformats.org/officeDocument/2006/relationships" id="288" r:id="R4b2160a6f2084c1a"/>
   </p:sldIdLst>
   <p:sldSz cx="12192000" cy="6858000"/>
   <p:notesSz cx="6858000" cy="9144000"/>
@@ -10432,6 +10433,125 @@
 </p:notes>
 </file>
 
+<file path=ppt/notesSlides/notesSlide33.xml><?xml version="1.0" encoding="utf-8"?>
+<p:notes xmlns:p="http://schemas.openxmlformats.org/presentationml/2006/main">
+  <p:cSld>
+    <p:spTree>
+      <p:nvGrpSpPr>
+        <p:cNvPr id="1" name=""/>
+        <p:cNvGrpSpPr/>
+        <p:nvPr/>
+      </p:nvGrpSpPr>
+      <p:grpSpPr>
+        <a:xfrm xmlns:a="http://schemas.openxmlformats.org/drawingml/2006/main"/>
+      </p:grpSpPr>
+      <p:sp>
+        <p:nvSpPr>
+          <p:cNvPr id="2" name="Slide Image Placeholder 1"/>
+          <p:cNvSpPr>
+            <a:spLocks xmlns:a="http://schemas.openxmlformats.org/drawingml/2006/main" noGrp="1"/>
+          </p:cNvSpPr>
+          <p:nvPr>
+            <p:ph type="sldImg" idx="0"/>
+          </p:nvPr>
+        </p:nvSpPr>
+        <p:spPr/>
+      </p:sp>
+      <p:sp>
+        <p:nvSpPr>
+          <p:cNvPr id="3" name="Notes Placeholder 2"/>
+          <p:cNvSpPr>
+            <a:spLocks xmlns:a="http://schemas.openxmlformats.org/drawingml/2006/main" noGrp="1"/>
+          </p:cNvSpPr>
+          <p:nvPr>
+            <p:ph type="body" idx="1"/>
+          </p:nvPr>
+        </p:nvSpPr>
+        <p:spPr/>
+        <p:txBody>
+          <a:bodyPr xmlns:a="http://schemas.openxmlformats.org/drawingml/2006/main"/>
+          <a:lstStyle xmlns:a="http://schemas.openxmlformats.org/drawingml/2006/main"/>
+          <a:p xmlns:a="http://schemas.openxmlformats.org/drawingml/2006/main">
+            <a:pPr indent="0" algn="l">
+              <a:lnSpc>
+                <a:spcPct val="100000"/>
+              </a:lnSpc>
+              <a:buNone/>
+            </a:pPr>
+            <a:r>
+              <a:rPr sz="2000" b="0" u="none">
+                <a:solidFill>
+                  <a:srgbClr val="000000"/>
+                </a:solidFill>
+                <a:latin typeface="Arial"/>
+                <a:ea typeface="Arial"/>
+                <a:cs typeface="Arial"/>
+              </a:rPr>
+              <a:t>시간 함수의 위치 · kernel.org</a:t>
+            </a:r>
+            <a:endParaRPr sz="2000" b="0" u="none">
+              <a:solidFill>
+                <a:srgbClr val="000000"/>
+              </a:solidFill>
+              <a:latin typeface="Arial"/>
+              <a:ea typeface="Arial"/>
+              <a:cs typeface="Arial"/>
+            </a:endParaRPr>
+          </a:p>
+          <a:p xmlns:a="http://schemas.openxmlformats.org/drawingml/2006/main">
+            <a:pPr indent="0" algn="l">
+              <a:lnSpc>
+                <a:spcPct val="100000"/>
+              </a:lnSpc>
+              <a:buNone/>
+            </a:pPr>
+            <a:r>
+              <a:rPr sz="2000" b="0" u="none">
+                <a:solidFill>
+                  <a:srgbClr val="000000"/>
+                </a:solidFill>
+                <a:latin typeface="Arial"/>
+                <a:ea typeface="Arial"/>
+                <a:cs typeface="Arial"/>
+              </a:rPr>
+              <a:t>class02의 calendar_demo·clock_show·elapsed_demo·tm_normalize·tslog가 사용하는 함수다. glibc: time는 sysdeps/unix/sysv/linux/time.c(clock_gettime 기반), clock_gettime·clock_getres는 sysdeps/unix/clock_gettime.c·clock_getres.c(vDSO 우선), localtime·gmtime는 time/localtime.c·gmtime.c(TZ와 /etc/localtime 해석), mktime은 time/mktime.c, strftime은 time/strftime-l.c, difftime은 time/difftime.c. kernel.org 링크(stable linux-7.2.y, 2026-09-28 확인): [kernel/time/time.c](https://git.kernel.org/pub/scm/linux/kernel/git/stable/linux.git/tree/kernel/time/time.c?h=linux-7.2.y) — time·gettimeofday 시스템 호출, [kernel/time/posix-stubs.c](https://git.kernel.org/pub/scm/linux/kernel/git/stable/linux.git/tree/kernel/time/posix-stubs.c?h=linux-7.2.y) — clock_gettime·clock_getres 시스템 호출(약 52·68행), [lib/vdso/gettimeofday.c](https://git.kernel.org/pub/scm/linux/kernel/git/stable/linux.git/tree/lib/vdso/gettimeofday.c?h=linux-7.2.y) — __cvdso_clock_gettime 등 vDSO 빠른 경로. vDSO 경로는 시스템 호출 없이 사용자 공간에서 값을 돌려주므로 strace에 잡히지 않는다.</a:t>
+            </a:r>
+            <a:endParaRPr sz="2000" b="0" u="none">
+              <a:solidFill>
+                <a:srgbClr val="000000"/>
+              </a:solidFill>
+              <a:latin typeface="Arial"/>
+              <a:ea typeface="Arial"/>
+              <a:cs typeface="Arial"/>
+            </a:endParaRPr>
+          </a:p>
+        </p:txBody>
+      </p:sp>
+      <p:sp>
+        <p:nvSpPr>
+          <p:cNvPr id="4" name="Slide Number Placeholder 3"/>
+          <p:cNvSpPr>
+            <a:spLocks xmlns:a="http://schemas.openxmlformats.org/drawingml/2006/main" noGrp="1"/>
+          </p:cNvSpPr>
+          <p:nvPr>
+            <p:ph type="sldNum" idx="5"/>
+          </p:nvPr>
+        </p:nvSpPr>
+        <p:spPr/>
+        <p:txBody>
+          <a:bodyPr xmlns:a="http://schemas.openxmlformats.org/drawingml/2006/main"/>
+          <a:lstStyle xmlns:a="http://schemas.openxmlformats.org/drawingml/2006/main"/>
+          <a:p xmlns:a="http://schemas.openxmlformats.org/drawingml/2006/main"/>
+        </p:txBody>
+      </p:sp>
+    </p:spTree>
+  </p:cSld>
+  <p:clrMapOvr>
+    <a:masterClrMapping xmlns:a="http://schemas.openxmlformats.org/drawingml/2006/main"/>
+  </p:clrMapOvr>
+</p:notes>
+</file>
+
 <file path=ppt/notesSlides/notesSlide4.xml><?xml version="1.0" encoding="utf-8"?>
 <p:notes xmlns:p="http://schemas.openxmlformats.org/presentationml/2006/main">
   <p:cSld>
@@ -12945,7 +13065,7 @@
           <p:cNvPr id="4" name="PlaceHolder 1">
             <a:extLst xmlns:a="http://schemas.openxmlformats.org/drawingml/2006/main">
               <a:ext uri="{FF2B5EF4-FFF2-40B4-BE49-F238E27FC236}">
-                <a16:creationId xmlns:a16="http://schemas.microsoft.com/office/drawing/2014/main" id="{C7D956D0-7475-454F-86AC-5AA23C258566}"/>
+                <a16:creationId xmlns:a16="http://schemas.microsoft.com/office/drawing/2014/main" id="{F3DFBB04-74AE-4FC6-AAB2-B212943BFD52}"/>
               </a:ext>
             </a:extLst>
           </p:cNvPr>
@@ -12997,7 +13117,7 @@
           <p:cNvPr id="5" name="PlaceHolder 2">
             <a:extLst xmlns:a="http://schemas.openxmlformats.org/drawingml/2006/main">
               <a:ext uri="{FF2B5EF4-FFF2-40B4-BE49-F238E27FC236}">
-                <a16:creationId xmlns:a16="http://schemas.microsoft.com/office/drawing/2014/main" id="{5988A0B7-CD5B-4BEE-9064-2D02BB988D3F}"/>
+                <a16:creationId xmlns:a16="http://schemas.microsoft.com/office/drawing/2014/main" id="{A995D4B4-10CA-46F1-8B76-89C1866BD6DA}"/>
               </a:ext>
             </a:extLst>
           </p:cNvPr>
@@ -13070,7 +13190,7 @@
           <p:cNvPr id="2" name="PlaceHolder 1">
             <a:extLst xmlns:a="http://schemas.openxmlformats.org/drawingml/2006/main">
               <a:ext uri="{FF2B5EF4-FFF2-40B4-BE49-F238E27FC236}">
-                <a16:creationId xmlns:a16="http://schemas.microsoft.com/office/drawing/2014/main" id="{C964615C-0043-4573-A6D9-98F48FF96CBB}"/>
+                <a16:creationId xmlns:a16="http://schemas.microsoft.com/office/drawing/2014/main" id="{7DF3662C-4C00-4C6A-B7D7-D5338FDC2F46}"/>
               </a:ext>
             </a:extLst>
           </p:cNvPr>
@@ -13148,7 +13268,7 @@
           <p:cNvPr id="3" name="PlaceHolder 2">
             <a:extLst xmlns:a="http://schemas.openxmlformats.org/drawingml/2006/main">
               <a:ext uri="{FF2B5EF4-FFF2-40B4-BE49-F238E27FC236}">
-                <a16:creationId xmlns:a16="http://schemas.microsoft.com/office/drawing/2014/main" id="{AA4D9D10-AD53-479E-B03C-AA833C8722AA}"/>
+                <a16:creationId xmlns:a16="http://schemas.microsoft.com/office/drawing/2014/main" id="{9B6748E9-EFE3-4A38-9EFE-4B6309250BDA}"/>
               </a:ext>
             </a:extLst>
           </p:cNvPr>
@@ -13583,7 +13703,7 @@
   </p:cSld>
   <p:clrMap bg1="lt1" tx1="dk1" bg2="lt2" tx2="dk2" accent1="accent1" accent2="accent2" accent3="accent3" accent4="accent4" accent5="accent5" accent6="accent6" hlink="hlink" folHlink="folHlink"/>
   <p:sldLayoutIdLst>
-    <p:sldLayoutId xmlns:r="http://schemas.openxmlformats.org/officeDocument/2006/relationships" id="2147483649" r:id="R87c69779dfa44bcf"/>
+    <p:sldLayoutId xmlns:r="http://schemas.openxmlformats.org/officeDocument/2006/relationships" id="2147483649" r:id="R9be62b406a1942a1"/>
   </p:sldLayoutIdLst>
 </p:sldMaster>
 </file>
@@ -13715,7 +13835,7 @@
           <p:cNvPr id="11" name="">
             <a:extLst xmlns:a="http://schemas.openxmlformats.org/drawingml/2006/main">
               <a:ext uri="{FF2B5EF4-FFF2-40B4-BE49-F238E27FC236}">
-                <a16:creationId xmlns:a16="http://schemas.microsoft.com/office/drawing/2014/main" id="{60595A45-5F7F-4160-BB81-0A557E67FB57}"/>
+                <a16:creationId xmlns:a16="http://schemas.microsoft.com/office/drawing/2014/main" id="{889C1B93-8085-4EE9-ABD1-694B9E6A73E7}"/>
               </a:ext>
             </a:extLst>
           </p:cNvPr>
@@ -13770,7 +13890,7 @@
           <p:cNvPr id="12" name="">
             <a:extLst xmlns:a="http://schemas.openxmlformats.org/drawingml/2006/main">
               <a:ext uri="{FF2B5EF4-FFF2-40B4-BE49-F238E27FC236}">
-                <a16:creationId xmlns:a16="http://schemas.microsoft.com/office/drawing/2014/main" id="{BD31DA41-B75E-4BDD-919F-1036F6E4E360}"/>
+                <a16:creationId xmlns:a16="http://schemas.microsoft.com/office/drawing/2014/main" id="{115AAA27-FDB4-4F96-8F90-5806725C9935}"/>
               </a:ext>
             </a:extLst>
           </p:cNvPr>
@@ -13881,7 +14001,7 @@
           <p:cNvPr id="13" name="">
             <a:extLst xmlns:a="http://schemas.openxmlformats.org/drawingml/2006/main">
               <a:ext uri="{FF2B5EF4-FFF2-40B4-BE49-F238E27FC236}">
-                <a16:creationId xmlns:a16="http://schemas.microsoft.com/office/drawing/2014/main" id="{2B174666-6F19-4E72-84D3-5F3C14A383C1}"/>
+                <a16:creationId xmlns:a16="http://schemas.microsoft.com/office/drawing/2014/main" id="{A35F123B-C060-4AA8-B71B-B3116B631E31}"/>
               </a:ext>
             </a:extLst>
           </p:cNvPr>
@@ -13948,7 +14068,7 @@
           <p:cNvPr id="14" name="">
             <a:extLst xmlns:a="http://schemas.openxmlformats.org/drawingml/2006/main">
               <a:ext uri="{FF2B5EF4-FFF2-40B4-BE49-F238E27FC236}">
-                <a16:creationId xmlns:a16="http://schemas.microsoft.com/office/drawing/2014/main" id="{7279D028-C48A-4B9C-9B57-9208B3680258}"/>
+                <a16:creationId xmlns:a16="http://schemas.microsoft.com/office/drawing/2014/main" id="{014F8288-5948-4809-AA39-7ACA95D0595F}"/>
               </a:ext>
             </a:extLst>
           </p:cNvPr>
@@ -14042,7 +14162,7 @@
           <p:cNvPr id="15" name="">
             <a:extLst xmlns:a="http://schemas.openxmlformats.org/drawingml/2006/main">
               <a:ext uri="{FF2B5EF4-FFF2-40B4-BE49-F238E27FC236}">
-                <a16:creationId xmlns:a16="http://schemas.microsoft.com/office/drawing/2014/main" id="{32B83DAD-0FAD-4EE5-BB14-6338F9974E37}"/>
+                <a16:creationId xmlns:a16="http://schemas.microsoft.com/office/drawing/2014/main" id="{4DAF4627-DC8E-4F5B-A9C8-8A9E3F825469}"/>
               </a:ext>
             </a:extLst>
           </p:cNvPr>
@@ -14109,7 +14229,7 @@
           <p:cNvPr id="16" name="">
             <a:extLst xmlns:a="http://schemas.openxmlformats.org/drawingml/2006/main">
               <a:ext uri="{FF2B5EF4-FFF2-40B4-BE49-F238E27FC236}">
-                <a16:creationId xmlns:a16="http://schemas.microsoft.com/office/drawing/2014/main" id="{A807D3A0-819B-43AA-A749-216DE887E0BB}"/>
+                <a16:creationId xmlns:a16="http://schemas.microsoft.com/office/drawing/2014/main" id="{3162170D-1782-4631-AFB8-9114318FB6BD}"/>
               </a:ext>
             </a:extLst>
           </p:cNvPr>
@@ -14166,7 +14286,7 @@
           <p:nvPr/>
         </p:nvPicPr>
         <p:blipFill>
-          <a:blip xmlns:r="http://schemas.openxmlformats.org/officeDocument/2006/relationships" xmlns:a="http://schemas.openxmlformats.org/drawingml/2006/main" r:embed="Rd1da1c14c95b4be6"/>
+          <a:blip xmlns:r="http://schemas.openxmlformats.org/officeDocument/2006/relationships" xmlns:a="http://schemas.openxmlformats.org/drawingml/2006/main" r:embed="R6cdea6b9ba5a4c06"/>
           <a:stretch xmlns:a="http://schemas.openxmlformats.org/drawingml/2006/main"/>
         </p:blipFill>
         <p:spPr>
@@ -14185,7 +14305,7 @@
     </p:spTree>
     <p:extLst>
       <p:ext uri="{BB962C8B-B14F-4D97-AF65-F5344CB8AC3E}">
-        <p14:creationId xmlns:p14="http://schemas.microsoft.com/office/powerpoint/2010/main" val="1826427089"/>
+        <p14:creationId xmlns:p14="http://schemas.microsoft.com/office/powerpoint/2010/main" val="781092819"/>
       </p:ext>
     </p:extLst>
   </p:cSld>
@@ -14209,7 +14329,7 @@
           <p:cNvPr id="120" name="">
             <a:extLst xmlns:a="http://schemas.openxmlformats.org/drawingml/2006/main">
               <a:ext uri="{FF2B5EF4-FFF2-40B4-BE49-F238E27FC236}">
-                <a16:creationId xmlns:a16="http://schemas.microsoft.com/office/drawing/2014/main" id="{BD919CFC-680A-4ED7-B654-0E0FF1B76715}"/>
+                <a16:creationId xmlns:a16="http://schemas.microsoft.com/office/drawing/2014/main" id="{8B8127A3-0CB8-4ECA-AAD1-5D5C7FE20989}"/>
               </a:ext>
             </a:extLst>
           </p:cNvPr>
@@ -14263,7 +14383,7 @@
           <p:cNvPr id="121" name="">
             <a:extLst xmlns:a="http://schemas.openxmlformats.org/drawingml/2006/main">
               <a:ext uri="{FF2B5EF4-FFF2-40B4-BE49-F238E27FC236}">
-                <a16:creationId xmlns:a16="http://schemas.microsoft.com/office/drawing/2014/main" id="{D4E2E49E-43A3-4331-818B-A89B369568F1}"/>
+                <a16:creationId xmlns:a16="http://schemas.microsoft.com/office/drawing/2014/main" id="{40E8F94A-D3EB-4F23-9BF9-F86B3D5276A6}"/>
               </a:ext>
             </a:extLst>
           </p:cNvPr>
@@ -14330,7 +14450,7 @@
           <p:cNvPr id="122" name="">
             <a:extLst xmlns:a="http://schemas.openxmlformats.org/drawingml/2006/main">
               <a:ext uri="{FF2B5EF4-FFF2-40B4-BE49-F238E27FC236}">
-                <a16:creationId xmlns:a16="http://schemas.microsoft.com/office/drawing/2014/main" id="{6ECF7E94-23CC-4344-A401-08C1B59BF937}"/>
+                <a16:creationId xmlns:a16="http://schemas.microsoft.com/office/drawing/2014/main" id="{54AA50D7-D24F-435B-B675-FD0F868F1B59}"/>
               </a:ext>
             </a:extLst>
           </p:cNvPr>
@@ -14757,7 +14877,7 @@
           <p:cNvPr id="123" name="">
             <a:extLst xmlns:a="http://schemas.openxmlformats.org/drawingml/2006/main">
               <a:ext uri="{FF2B5EF4-FFF2-40B4-BE49-F238E27FC236}">
-                <a16:creationId xmlns:a16="http://schemas.microsoft.com/office/drawing/2014/main" id="{C62D0D0A-0C2C-40F8-B02C-FD51CFB42E0A}"/>
+                <a16:creationId xmlns:a16="http://schemas.microsoft.com/office/drawing/2014/main" id="{14827209-21E1-4842-927C-D4A1A4016104}"/>
               </a:ext>
             </a:extLst>
           </p:cNvPr>
@@ -14832,7 +14952,7 @@
           <p:cNvPr id="124" name="">
             <a:extLst xmlns:a="http://schemas.openxmlformats.org/drawingml/2006/main">
               <a:ext uri="{FF2B5EF4-FFF2-40B4-BE49-F238E27FC236}">
-                <a16:creationId xmlns:a16="http://schemas.microsoft.com/office/drawing/2014/main" id="{71415566-453B-4DFD-99EF-C2F5720ED1AB}"/>
+                <a16:creationId xmlns:a16="http://schemas.microsoft.com/office/drawing/2014/main" id="{7B593D54-FB77-422A-B262-F18A03539D87}"/>
               </a:ext>
             </a:extLst>
           </p:cNvPr>
@@ -14942,7 +15062,7 @@
           <p:cNvPr id="125" name="">
             <a:extLst xmlns:a="http://schemas.openxmlformats.org/drawingml/2006/main">
               <a:ext uri="{FF2B5EF4-FFF2-40B4-BE49-F238E27FC236}">
-                <a16:creationId xmlns:a16="http://schemas.microsoft.com/office/drawing/2014/main" id="{5BAA69F5-116D-4B32-AC07-F3C642D0B2D3}"/>
+                <a16:creationId xmlns:a16="http://schemas.microsoft.com/office/drawing/2014/main" id="{A7959816-73EA-49D2-BCB2-F50515F535CF}"/>
               </a:ext>
             </a:extLst>
           </p:cNvPr>
@@ -15017,7 +15137,7 @@
           <p:cNvPr id="126" name="">
             <a:extLst xmlns:a="http://schemas.openxmlformats.org/drawingml/2006/main">
               <a:ext uri="{FF2B5EF4-FFF2-40B4-BE49-F238E27FC236}">
-                <a16:creationId xmlns:a16="http://schemas.microsoft.com/office/drawing/2014/main" id="{E68C548A-13C2-4939-B3BF-BB44B61F8F32}"/>
+                <a16:creationId xmlns:a16="http://schemas.microsoft.com/office/drawing/2014/main" id="{2162145B-3F9E-40E4-9EAF-31021B17E9AA}"/>
               </a:ext>
             </a:extLst>
           </p:cNvPr>
@@ -15127,7 +15247,7 @@
           <p:cNvPr id="127" name="">
             <a:extLst xmlns:a="http://schemas.openxmlformats.org/drawingml/2006/main">
               <a:ext uri="{FF2B5EF4-FFF2-40B4-BE49-F238E27FC236}">
-                <a16:creationId xmlns:a16="http://schemas.microsoft.com/office/drawing/2014/main" id="{21F524E0-2EED-4D18-931C-220020F33DE9}"/>
+                <a16:creationId xmlns:a16="http://schemas.microsoft.com/office/drawing/2014/main" id="{FABD9BB6-4FA1-4911-B03D-BEEBE352FF93}"/>
               </a:ext>
             </a:extLst>
           </p:cNvPr>
@@ -15202,7 +15322,7 @@
           <p:cNvPr id="128" name="">
             <a:extLst xmlns:a="http://schemas.openxmlformats.org/drawingml/2006/main">
               <a:ext uri="{FF2B5EF4-FFF2-40B4-BE49-F238E27FC236}">
-                <a16:creationId xmlns:a16="http://schemas.microsoft.com/office/drawing/2014/main" id="{8B5E0EA7-381E-48B0-9DF7-DF5A40F7B7A5}"/>
+                <a16:creationId xmlns:a16="http://schemas.microsoft.com/office/drawing/2014/main" id="{C09CBB75-8392-4D1D-B1D3-189A0615B830}"/>
               </a:ext>
             </a:extLst>
           </p:cNvPr>
@@ -15312,7 +15432,7 @@
           <p:cNvPr id="129" name="">
             <a:extLst xmlns:a="http://schemas.openxmlformats.org/drawingml/2006/main">
               <a:ext uri="{FF2B5EF4-FFF2-40B4-BE49-F238E27FC236}">
-                <a16:creationId xmlns:a16="http://schemas.microsoft.com/office/drawing/2014/main" id="{DBB90792-BEF2-4906-9F4D-5CC4447462A9}"/>
+                <a16:creationId xmlns:a16="http://schemas.microsoft.com/office/drawing/2014/main" id="{6CD1CB88-1DD8-4791-932F-BC6B1B21C308}"/>
               </a:ext>
             </a:extLst>
           </p:cNvPr>
@@ -15377,7 +15497,7 @@
     </p:spTree>
     <p:extLst>
       <p:ext uri="{BB962C8B-B14F-4D97-AF65-F5344CB8AC3E}">
-        <p14:creationId xmlns:p14="http://schemas.microsoft.com/office/powerpoint/2010/main" val="2112704824"/>
+        <p14:creationId xmlns:p14="http://schemas.microsoft.com/office/powerpoint/2010/main" val="71809283"/>
       </p:ext>
     </p:extLst>
   </p:cSld>
@@ -15401,7 +15521,7 @@
           <p:cNvPr id="120" name="">
             <a:extLst xmlns:a="http://schemas.openxmlformats.org/drawingml/2006/main">
               <a:ext uri="{FF2B5EF4-FFF2-40B4-BE49-F238E27FC236}">
-                <a16:creationId xmlns:a16="http://schemas.microsoft.com/office/drawing/2014/main" id="{BD919CFC-680A-4ED7-B654-0E0FF1B76715}"/>
+                <a16:creationId xmlns:a16="http://schemas.microsoft.com/office/drawing/2014/main" id="{8B8127A3-0CB8-4ECA-AAD1-5D5C7FE20989}"/>
               </a:ext>
             </a:extLst>
           </p:cNvPr>
@@ -15455,7 +15575,7 @@
           <p:cNvPr id="121" name="">
             <a:extLst xmlns:a="http://schemas.openxmlformats.org/drawingml/2006/main">
               <a:ext uri="{FF2B5EF4-FFF2-40B4-BE49-F238E27FC236}">
-                <a16:creationId xmlns:a16="http://schemas.microsoft.com/office/drawing/2014/main" id="{D4E2E49E-43A3-4331-818B-A89B369568F1}"/>
+                <a16:creationId xmlns:a16="http://schemas.microsoft.com/office/drawing/2014/main" id="{40E8F94A-D3EB-4F23-9BF9-F86B3D5276A6}"/>
               </a:ext>
             </a:extLst>
           </p:cNvPr>
@@ -15522,7 +15642,7 @@
           <p:cNvPr id="122" name="">
             <a:extLst xmlns:a="http://schemas.openxmlformats.org/drawingml/2006/main">
               <a:ext uri="{FF2B5EF4-FFF2-40B4-BE49-F238E27FC236}">
-                <a16:creationId xmlns:a16="http://schemas.microsoft.com/office/drawing/2014/main" id="{6ECF7E94-23CC-4344-A401-08C1B59BF937}"/>
+                <a16:creationId xmlns:a16="http://schemas.microsoft.com/office/drawing/2014/main" id="{54AA50D7-D24F-435B-B675-FD0F868F1B59}"/>
               </a:ext>
             </a:extLst>
           </p:cNvPr>
@@ -15984,7 +16104,7 @@
           <p:cNvPr id="123" name="">
             <a:extLst xmlns:a="http://schemas.openxmlformats.org/drawingml/2006/main">
               <a:ext uri="{FF2B5EF4-FFF2-40B4-BE49-F238E27FC236}">
-                <a16:creationId xmlns:a16="http://schemas.microsoft.com/office/drawing/2014/main" id="{C62D0D0A-0C2C-40F8-B02C-FD51CFB42E0A}"/>
+                <a16:creationId xmlns:a16="http://schemas.microsoft.com/office/drawing/2014/main" id="{14827209-21E1-4842-927C-D4A1A4016104}"/>
               </a:ext>
             </a:extLst>
           </p:cNvPr>
@@ -16059,7 +16179,7 @@
           <p:cNvPr id="124" name="">
             <a:extLst xmlns:a="http://schemas.openxmlformats.org/drawingml/2006/main">
               <a:ext uri="{FF2B5EF4-FFF2-40B4-BE49-F238E27FC236}">
-                <a16:creationId xmlns:a16="http://schemas.microsoft.com/office/drawing/2014/main" id="{71415566-453B-4DFD-99EF-C2F5720ED1AB}"/>
+                <a16:creationId xmlns:a16="http://schemas.microsoft.com/office/drawing/2014/main" id="{7B593D54-FB77-422A-B262-F18A03539D87}"/>
               </a:ext>
             </a:extLst>
           </p:cNvPr>
@@ -16169,7 +16289,7 @@
           <p:cNvPr id="125" name="">
             <a:extLst xmlns:a="http://schemas.openxmlformats.org/drawingml/2006/main">
               <a:ext uri="{FF2B5EF4-FFF2-40B4-BE49-F238E27FC236}">
-                <a16:creationId xmlns:a16="http://schemas.microsoft.com/office/drawing/2014/main" id="{5BAA69F5-116D-4B32-AC07-F3C642D0B2D3}"/>
+                <a16:creationId xmlns:a16="http://schemas.microsoft.com/office/drawing/2014/main" id="{A7959816-73EA-49D2-BCB2-F50515F535CF}"/>
               </a:ext>
             </a:extLst>
           </p:cNvPr>
@@ -16244,7 +16364,7 @@
           <p:cNvPr id="126" name="">
             <a:extLst xmlns:a="http://schemas.openxmlformats.org/drawingml/2006/main">
               <a:ext uri="{FF2B5EF4-FFF2-40B4-BE49-F238E27FC236}">
-                <a16:creationId xmlns:a16="http://schemas.microsoft.com/office/drawing/2014/main" id="{E68C548A-13C2-4939-B3BF-BB44B61F8F32}"/>
+                <a16:creationId xmlns:a16="http://schemas.microsoft.com/office/drawing/2014/main" id="{2162145B-3F9E-40E4-9EAF-31021B17E9AA}"/>
               </a:ext>
             </a:extLst>
           </p:cNvPr>
@@ -16354,7 +16474,7 @@
           <p:cNvPr id="127" name="">
             <a:extLst xmlns:a="http://schemas.openxmlformats.org/drawingml/2006/main">
               <a:ext uri="{FF2B5EF4-FFF2-40B4-BE49-F238E27FC236}">
-                <a16:creationId xmlns:a16="http://schemas.microsoft.com/office/drawing/2014/main" id="{21F524E0-2EED-4D18-931C-220020F33DE9}"/>
+                <a16:creationId xmlns:a16="http://schemas.microsoft.com/office/drawing/2014/main" id="{FABD9BB6-4FA1-4911-B03D-BEEBE352FF93}"/>
               </a:ext>
             </a:extLst>
           </p:cNvPr>
@@ -16429,7 +16549,7 @@
           <p:cNvPr id="128" name="">
             <a:extLst xmlns:a="http://schemas.openxmlformats.org/drawingml/2006/main">
               <a:ext uri="{FF2B5EF4-FFF2-40B4-BE49-F238E27FC236}">
-                <a16:creationId xmlns:a16="http://schemas.microsoft.com/office/drawing/2014/main" id="{8B5E0EA7-381E-48B0-9DF7-DF5A40F7B7A5}"/>
+                <a16:creationId xmlns:a16="http://schemas.microsoft.com/office/drawing/2014/main" id="{C09CBB75-8392-4D1D-B1D3-189A0615B830}"/>
               </a:ext>
             </a:extLst>
           </p:cNvPr>
@@ -16539,7 +16659,7 @@
           <p:cNvPr id="129" name="">
             <a:extLst xmlns:a="http://schemas.openxmlformats.org/drawingml/2006/main">
               <a:ext uri="{FF2B5EF4-FFF2-40B4-BE49-F238E27FC236}">
-                <a16:creationId xmlns:a16="http://schemas.microsoft.com/office/drawing/2014/main" id="{DBB90792-BEF2-4906-9F4D-5CC4447462A9}"/>
+                <a16:creationId xmlns:a16="http://schemas.microsoft.com/office/drawing/2014/main" id="{6CD1CB88-1DD8-4791-932F-BC6B1B21C308}"/>
               </a:ext>
             </a:extLst>
           </p:cNvPr>
@@ -16604,7 +16724,7 @@
     </p:spTree>
     <p:extLst>
       <p:ext uri="{BB962C8B-B14F-4D97-AF65-F5344CB8AC3E}">
-        <p14:creationId xmlns:p14="http://schemas.microsoft.com/office/powerpoint/2010/main" val="2112704824"/>
+        <p14:creationId xmlns:p14="http://schemas.microsoft.com/office/powerpoint/2010/main" val="71809283"/>
       </p:ext>
     </p:extLst>
   </p:cSld>
@@ -16635,7 +16755,7 @@
           <p:cNvPr id="26" name="">
             <a:extLst xmlns:a="http://schemas.openxmlformats.org/drawingml/2006/main">
               <a:ext uri="{FF2B5EF4-FFF2-40B4-BE49-F238E27FC236}">
-                <a16:creationId xmlns:a16="http://schemas.microsoft.com/office/drawing/2014/main" id="{CA0DC302-95CB-4BAD-AE2A-FCD32EEDDE73}"/>
+                <a16:creationId xmlns:a16="http://schemas.microsoft.com/office/drawing/2014/main" id="{1C5FD675-F338-4922-A4E9-88624148F862}"/>
               </a:ext>
             </a:extLst>
           </p:cNvPr>
@@ -16688,7 +16808,7 @@
           <p:cNvPr id="27" name="">
             <a:extLst xmlns:a="http://schemas.openxmlformats.org/drawingml/2006/main">
               <a:ext uri="{FF2B5EF4-FFF2-40B4-BE49-F238E27FC236}">
-                <a16:creationId xmlns:a16="http://schemas.microsoft.com/office/drawing/2014/main" id="{37E02159-8A9B-46C9-90D2-DA6DD62FD5A0}"/>
+                <a16:creationId xmlns:a16="http://schemas.microsoft.com/office/drawing/2014/main" id="{E235729A-8179-455E-AE97-E7669A11C106}"/>
               </a:ext>
             </a:extLst>
           </p:cNvPr>
@@ -16782,7 +16902,7 @@
           <p:cNvPr id="28" name="">
             <a:extLst xmlns:a="http://schemas.openxmlformats.org/drawingml/2006/main">
               <a:ext uri="{FF2B5EF4-FFF2-40B4-BE49-F238E27FC236}">
-                <a16:creationId xmlns:a16="http://schemas.microsoft.com/office/drawing/2014/main" id="{2F73CF55-F52D-48D6-B78A-5492562654B2}"/>
+                <a16:creationId xmlns:a16="http://schemas.microsoft.com/office/drawing/2014/main" id="{EDA8B2AE-A3AB-4B1C-8765-24524BE82A9E}"/>
               </a:ext>
             </a:extLst>
           </p:cNvPr>
@@ -16835,7 +16955,7 @@
           <p:cNvPr id="29" name="">
             <a:extLst xmlns:a="http://schemas.openxmlformats.org/drawingml/2006/main">
               <a:ext uri="{FF2B5EF4-FFF2-40B4-BE49-F238E27FC236}">
-                <a16:creationId xmlns:a16="http://schemas.microsoft.com/office/drawing/2014/main" id="{61BEA18A-3BE7-43A1-A769-B23089910F68}"/>
+                <a16:creationId xmlns:a16="http://schemas.microsoft.com/office/drawing/2014/main" id="{756C492C-5C59-4A26-B631-0520249CAC37}"/>
               </a:ext>
             </a:extLst>
           </p:cNvPr>
@@ -16900,7 +17020,7 @@
     </p:spTree>
     <p:extLst>
       <p:ext uri="{BB962C8B-B14F-4D97-AF65-F5344CB8AC3E}">
-        <p14:creationId xmlns:p14="http://schemas.microsoft.com/office/powerpoint/2010/main" val="1242354970"/>
+        <p14:creationId xmlns:p14="http://schemas.microsoft.com/office/powerpoint/2010/main" val="402919761"/>
       </p:ext>
     </p:extLst>
   </p:cSld>
@@ -16924,7 +17044,7 @@
           <p:cNvPr id="120" name="">
             <a:extLst xmlns:a="http://schemas.openxmlformats.org/drawingml/2006/main">
               <a:ext uri="{FF2B5EF4-FFF2-40B4-BE49-F238E27FC236}">
-                <a16:creationId xmlns:a16="http://schemas.microsoft.com/office/drawing/2014/main" id="{BD919CFC-680A-4ED7-B654-0E0FF1B76715}"/>
+                <a16:creationId xmlns:a16="http://schemas.microsoft.com/office/drawing/2014/main" id="{8B8127A3-0CB8-4ECA-AAD1-5D5C7FE20989}"/>
               </a:ext>
             </a:extLst>
           </p:cNvPr>
@@ -16978,7 +17098,7 @@
           <p:cNvPr id="121" name="">
             <a:extLst xmlns:a="http://schemas.openxmlformats.org/drawingml/2006/main">
               <a:ext uri="{FF2B5EF4-FFF2-40B4-BE49-F238E27FC236}">
-                <a16:creationId xmlns:a16="http://schemas.microsoft.com/office/drawing/2014/main" id="{D4E2E49E-43A3-4331-818B-A89B369568F1}"/>
+                <a16:creationId xmlns:a16="http://schemas.microsoft.com/office/drawing/2014/main" id="{40E8F94A-D3EB-4F23-9BF9-F86B3D5276A6}"/>
               </a:ext>
             </a:extLst>
           </p:cNvPr>
@@ -17045,7 +17165,7 @@
           <p:cNvPr id="122" name="">
             <a:extLst xmlns:a="http://schemas.openxmlformats.org/drawingml/2006/main">
               <a:ext uri="{FF2B5EF4-FFF2-40B4-BE49-F238E27FC236}">
-                <a16:creationId xmlns:a16="http://schemas.microsoft.com/office/drawing/2014/main" id="{6ECF7E94-23CC-4344-A401-08C1B59BF937}"/>
+                <a16:creationId xmlns:a16="http://schemas.microsoft.com/office/drawing/2014/main" id="{54AA50D7-D24F-435B-B675-FD0F868F1B59}"/>
               </a:ext>
             </a:extLst>
           </p:cNvPr>
@@ -17647,7 +17767,7 @@
           <p:cNvPr id="123" name="">
             <a:extLst xmlns:a="http://schemas.openxmlformats.org/drawingml/2006/main">
               <a:ext uri="{FF2B5EF4-FFF2-40B4-BE49-F238E27FC236}">
-                <a16:creationId xmlns:a16="http://schemas.microsoft.com/office/drawing/2014/main" id="{C62D0D0A-0C2C-40F8-B02C-FD51CFB42E0A}"/>
+                <a16:creationId xmlns:a16="http://schemas.microsoft.com/office/drawing/2014/main" id="{14827209-21E1-4842-927C-D4A1A4016104}"/>
               </a:ext>
             </a:extLst>
           </p:cNvPr>
@@ -17722,7 +17842,7 @@
           <p:cNvPr id="124" name="">
             <a:extLst xmlns:a="http://schemas.openxmlformats.org/drawingml/2006/main">
               <a:ext uri="{FF2B5EF4-FFF2-40B4-BE49-F238E27FC236}">
-                <a16:creationId xmlns:a16="http://schemas.microsoft.com/office/drawing/2014/main" id="{71415566-453B-4DFD-99EF-C2F5720ED1AB}"/>
+                <a16:creationId xmlns:a16="http://schemas.microsoft.com/office/drawing/2014/main" id="{7B593D54-FB77-422A-B262-F18A03539D87}"/>
               </a:ext>
             </a:extLst>
           </p:cNvPr>
@@ -17832,7 +17952,7 @@
           <p:cNvPr id="125" name="">
             <a:extLst xmlns:a="http://schemas.openxmlformats.org/drawingml/2006/main">
               <a:ext uri="{FF2B5EF4-FFF2-40B4-BE49-F238E27FC236}">
-                <a16:creationId xmlns:a16="http://schemas.microsoft.com/office/drawing/2014/main" id="{5BAA69F5-116D-4B32-AC07-F3C642D0B2D3}"/>
+                <a16:creationId xmlns:a16="http://schemas.microsoft.com/office/drawing/2014/main" id="{A7959816-73EA-49D2-BCB2-F50515F535CF}"/>
               </a:ext>
             </a:extLst>
           </p:cNvPr>
@@ -17907,7 +18027,7 @@
           <p:cNvPr id="126" name="">
             <a:extLst xmlns:a="http://schemas.openxmlformats.org/drawingml/2006/main">
               <a:ext uri="{FF2B5EF4-FFF2-40B4-BE49-F238E27FC236}">
-                <a16:creationId xmlns:a16="http://schemas.microsoft.com/office/drawing/2014/main" id="{E68C548A-13C2-4939-B3BF-BB44B61F8F32}"/>
+                <a16:creationId xmlns:a16="http://schemas.microsoft.com/office/drawing/2014/main" id="{2162145B-3F9E-40E4-9EAF-31021B17E9AA}"/>
               </a:ext>
             </a:extLst>
           </p:cNvPr>
@@ -18017,7 +18137,7 @@
           <p:cNvPr id="127" name="">
             <a:extLst xmlns:a="http://schemas.openxmlformats.org/drawingml/2006/main">
               <a:ext uri="{FF2B5EF4-FFF2-40B4-BE49-F238E27FC236}">
-                <a16:creationId xmlns:a16="http://schemas.microsoft.com/office/drawing/2014/main" id="{21F524E0-2EED-4D18-931C-220020F33DE9}"/>
+                <a16:creationId xmlns:a16="http://schemas.microsoft.com/office/drawing/2014/main" id="{FABD9BB6-4FA1-4911-B03D-BEEBE352FF93}"/>
               </a:ext>
             </a:extLst>
           </p:cNvPr>
@@ -18092,7 +18212,7 @@
           <p:cNvPr id="128" name="">
             <a:extLst xmlns:a="http://schemas.openxmlformats.org/drawingml/2006/main">
               <a:ext uri="{FF2B5EF4-FFF2-40B4-BE49-F238E27FC236}">
-                <a16:creationId xmlns:a16="http://schemas.microsoft.com/office/drawing/2014/main" id="{8B5E0EA7-381E-48B0-9DF7-DF5A40F7B7A5}"/>
+                <a16:creationId xmlns:a16="http://schemas.microsoft.com/office/drawing/2014/main" id="{C09CBB75-8392-4D1D-B1D3-189A0615B830}"/>
               </a:ext>
             </a:extLst>
           </p:cNvPr>
@@ -18202,7 +18322,7 @@
           <p:cNvPr id="129" name="">
             <a:extLst xmlns:a="http://schemas.openxmlformats.org/drawingml/2006/main">
               <a:ext uri="{FF2B5EF4-FFF2-40B4-BE49-F238E27FC236}">
-                <a16:creationId xmlns:a16="http://schemas.microsoft.com/office/drawing/2014/main" id="{DBB90792-BEF2-4906-9F4D-5CC4447462A9}"/>
+                <a16:creationId xmlns:a16="http://schemas.microsoft.com/office/drawing/2014/main" id="{6CD1CB88-1DD8-4791-932F-BC6B1B21C308}"/>
               </a:ext>
             </a:extLst>
           </p:cNvPr>
@@ -18267,7 +18387,7 @@
     </p:spTree>
     <p:extLst>
       <p:ext uri="{BB962C8B-B14F-4D97-AF65-F5344CB8AC3E}">
-        <p14:creationId xmlns:p14="http://schemas.microsoft.com/office/powerpoint/2010/main" val="2112704824"/>
+        <p14:creationId xmlns:p14="http://schemas.microsoft.com/office/powerpoint/2010/main" val="71809283"/>
       </p:ext>
     </p:extLst>
   </p:cSld>
@@ -18291,7 +18411,7 @@
           <p:cNvPr id="120" name="">
             <a:extLst xmlns:a="http://schemas.openxmlformats.org/drawingml/2006/main">
               <a:ext uri="{FF2B5EF4-FFF2-40B4-BE49-F238E27FC236}">
-                <a16:creationId xmlns:a16="http://schemas.microsoft.com/office/drawing/2014/main" id="{BD919CFC-680A-4ED7-B654-0E0FF1B76715}"/>
+                <a16:creationId xmlns:a16="http://schemas.microsoft.com/office/drawing/2014/main" id="{8B8127A3-0CB8-4ECA-AAD1-5D5C7FE20989}"/>
               </a:ext>
             </a:extLst>
           </p:cNvPr>
@@ -18345,7 +18465,7 @@
           <p:cNvPr id="121" name="">
             <a:extLst xmlns:a="http://schemas.openxmlformats.org/drawingml/2006/main">
               <a:ext uri="{FF2B5EF4-FFF2-40B4-BE49-F238E27FC236}">
-                <a16:creationId xmlns:a16="http://schemas.microsoft.com/office/drawing/2014/main" id="{D4E2E49E-43A3-4331-818B-A89B369568F1}"/>
+                <a16:creationId xmlns:a16="http://schemas.microsoft.com/office/drawing/2014/main" id="{40E8F94A-D3EB-4F23-9BF9-F86B3D5276A6}"/>
               </a:ext>
             </a:extLst>
           </p:cNvPr>
@@ -18412,7 +18532,7 @@
           <p:cNvPr id="122" name="">
             <a:extLst xmlns:a="http://schemas.openxmlformats.org/drawingml/2006/main">
               <a:ext uri="{FF2B5EF4-FFF2-40B4-BE49-F238E27FC236}">
-                <a16:creationId xmlns:a16="http://schemas.microsoft.com/office/drawing/2014/main" id="{6ECF7E94-23CC-4344-A401-08C1B59BF937}"/>
+                <a16:creationId xmlns:a16="http://schemas.microsoft.com/office/drawing/2014/main" id="{54AA50D7-D24F-435B-B675-FD0F868F1B59}"/>
               </a:ext>
             </a:extLst>
           </p:cNvPr>
@@ -18874,7 +18994,7 @@
           <p:cNvPr id="123" name="">
             <a:extLst xmlns:a="http://schemas.openxmlformats.org/drawingml/2006/main">
               <a:ext uri="{FF2B5EF4-FFF2-40B4-BE49-F238E27FC236}">
-                <a16:creationId xmlns:a16="http://schemas.microsoft.com/office/drawing/2014/main" id="{C62D0D0A-0C2C-40F8-B02C-FD51CFB42E0A}"/>
+                <a16:creationId xmlns:a16="http://schemas.microsoft.com/office/drawing/2014/main" id="{14827209-21E1-4842-927C-D4A1A4016104}"/>
               </a:ext>
             </a:extLst>
           </p:cNvPr>
@@ -18949,7 +19069,7 @@
           <p:cNvPr id="124" name="">
             <a:extLst xmlns:a="http://schemas.openxmlformats.org/drawingml/2006/main">
               <a:ext uri="{FF2B5EF4-FFF2-40B4-BE49-F238E27FC236}">
-                <a16:creationId xmlns:a16="http://schemas.microsoft.com/office/drawing/2014/main" id="{71415566-453B-4DFD-99EF-C2F5720ED1AB}"/>
+                <a16:creationId xmlns:a16="http://schemas.microsoft.com/office/drawing/2014/main" id="{7B593D54-FB77-422A-B262-F18A03539D87}"/>
               </a:ext>
             </a:extLst>
           </p:cNvPr>
@@ -19059,7 +19179,7 @@
           <p:cNvPr id="125" name="">
             <a:extLst xmlns:a="http://schemas.openxmlformats.org/drawingml/2006/main">
               <a:ext uri="{FF2B5EF4-FFF2-40B4-BE49-F238E27FC236}">
-                <a16:creationId xmlns:a16="http://schemas.microsoft.com/office/drawing/2014/main" id="{5BAA69F5-116D-4B32-AC07-F3C642D0B2D3}"/>
+                <a16:creationId xmlns:a16="http://schemas.microsoft.com/office/drawing/2014/main" id="{A7959816-73EA-49D2-BCB2-F50515F535CF}"/>
               </a:ext>
             </a:extLst>
           </p:cNvPr>
@@ -19134,7 +19254,7 @@
           <p:cNvPr id="126" name="">
             <a:extLst xmlns:a="http://schemas.openxmlformats.org/drawingml/2006/main">
               <a:ext uri="{FF2B5EF4-FFF2-40B4-BE49-F238E27FC236}">
-                <a16:creationId xmlns:a16="http://schemas.microsoft.com/office/drawing/2014/main" id="{E68C548A-13C2-4939-B3BF-BB44B61F8F32}"/>
+                <a16:creationId xmlns:a16="http://schemas.microsoft.com/office/drawing/2014/main" id="{2162145B-3F9E-40E4-9EAF-31021B17E9AA}"/>
               </a:ext>
             </a:extLst>
           </p:cNvPr>
@@ -19244,7 +19364,7 @@
           <p:cNvPr id="127" name="">
             <a:extLst xmlns:a="http://schemas.openxmlformats.org/drawingml/2006/main">
               <a:ext uri="{FF2B5EF4-FFF2-40B4-BE49-F238E27FC236}">
-                <a16:creationId xmlns:a16="http://schemas.microsoft.com/office/drawing/2014/main" id="{21F524E0-2EED-4D18-931C-220020F33DE9}"/>
+                <a16:creationId xmlns:a16="http://schemas.microsoft.com/office/drawing/2014/main" id="{FABD9BB6-4FA1-4911-B03D-BEEBE352FF93}"/>
               </a:ext>
             </a:extLst>
           </p:cNvPr>
@@ -19319,7 +19439,7 @@
           <p:cNvPr id="128" name="">
             <a:extLst xmlns:a="http://schemas.openxmlformats.org/drawingml/2006/main">
               <a:ext uri="{FF2B5EF4-FFF2-40B4-BE49-F238E27FC236}">
-                <a16:creationId xmlns:a16="http://schemas.microsoft.com/office/drawing/2014/main" id="{8B5E0EA7-381E-48B0-9DF7-DF5A40F7B7A5}"/>
+                <a16:creationId xmlns:a16="http://schemas.microsoft.com/office/drawing/2014/main" id="{C09CBB75-8392-4D1D-B1D3-189A0615B830}"/>
               </a:ext>
             </a:extLst>
           </p:cNvPr>
@@ -19429,7 +19549,7 @@
           <p:cNvPr id="129" name="">
             <a:extLst xmlns:a="http://schemas.openxmlformats.org/drawingml/2006/main">
               <a:ext uri="{FF2B5EF4-FFF2-40B4-BE49-F238E27FC236}">
-                <a16:creationId xmlns:a16="http://schemas.microsoft.com/office/drawing/2014/main" id="{DBB90792-BEF2-4906-9F4D-5CC4447462A9}"/>
+                <a16:creationId xmlns:a16="http://schemas.microsoft.com/office/drawing/2014/main" id="{6CD1CB88-1DD8-4791-932F-BC6B1B21C308}"/>
               </a:ext>
             </a:extLst>
           </p:cNvPr>
@@ -19494,7 +19614,7 @@
     </p:spTree>
     <p:extLst>
       <p:ext uri="{BB962C8B-B14F-4D97-AF65-F5344CB8AC3E}">
-        <p14:creationId xmlns:p14="http://schemas.microsoft.com/office/powerpoint/2010/main" val="2112704824"/>
+        <p14:creationId xmlns:p14="http://schemas.microsoft.com/office/powerpoint/2010/main" val="71809283"/>
       </p:ext>
     </p:extLst>
   </p:cSld>
@@ -19518,7 +19638,7 @@
           <p:cNvPr id="120" name="">
             <a:extLst xmlns:a="http://schemas.openxmlformats.org/drawingml/2006/main">
               <a:ext uri="{FF2B5EF4-FFF2-40B4-BE49-F238E27FC236}">
-                <a16:creationId xmlns:a16="http://schemas.microsoft.com/office/drawing/2014/main" id="{BD919CFC-680A-4ED7-B654-0E0FF1B76715}"/>
+                <a16:creationId xmlns:a16="http://schemas.microsoft.com/office/drawing/2014/main" id="{8B8127A3-0CB8-4ECA-AAD1-5D5C7FE20989}"/>
               </a:ext>
             </a:extLst>
           </p:cNvPr>
@@ -19572,7 +19692,7 @@
           <p:cNvPr id="121" name="">
             <a:extLst xmlns:a="http://schemas.openxmlformats.org/drawingml/2006/main">
               <a:ext uri="{FF2B5EF4-FFF2-40B4-BE49-F238E27FC236}">
-                <a16:creationId xmlns:a16="http://schemas.microsoft.com/office/drawing/2014/main" id="{D4E2E49E-43A3-4331-818B-A89B369568F1}"/>
+                <a16:creationId xmlns:a16="http://schemas.microsoft.com/office/drawing/2014/main" id="{40E8F94A-D3EB-4F23-9BF9-F86B3D5276A6}"/>
               </a:ext>
             </a:extLst>
           </p:cNvPr>
@@ -19639,7 +19759,7 @@
           <p:cNvPr id="122" name="">
             <a:extLst xmlns:a="http://schemas.openxmlformats.org/drawingml/2006/main">
               <a:ext uri="{FF2B5EF4-FFF2-40B4-BE49-F238E27FC236}">
-                <a16:creationId xmlns:a16="http://schemas.microsoft.com/office/drawing/2014/main" id="{6ECF7E94-23CC-4344-A401-08C1B59BF937}"/>
+                <a16:creationId xmlns:a16="http://schemas.microsoft.com/office/drawing/2014/main" id="{54AA50D7-D24F-435B-B675-FD0F868F1B59}"/>
               </a:ext>
             </a:extLst>
           </p:cNvPr>
@@ -20381,7 +20501,7 @@
           <p:cNvPr id="123" name="">
             <a:extLst xmlns:a="http://schemas.openxmlformats.org/drawingml/2006/main">
               <a:ext uri="{FF2B5EF4-FFF2-40B4-BE49-F238E27FC236}">
-                <a16:creationId xmlns:a16="http://schemas.microsoft.com/office/drawing/2014/main" id="{C62D0D0A-0C2C-40F8-B02C-FD51CFB42E0A}"/>
+                <a16:creationId xmlns:a16="http://schemas.microsoft.com/office/drawing/2014/main" id="{14827209-21E1-4842-927C-D4A1A4016104}"/>
               </a:ext>
             </a:extLst>
           </p:cNvPr>
@@ -20456,7 +20576,7 @@
           <p:cNvPr id="124" name="">
             <a:extLst xmlns:a="http://schemas.openxmlformats.org/drawingml/2006/main">
               <a:ext uri="{FF2B5EF4-FFF2-40B4-BE49-F238E27FC236}">
-                <a16:creationId xmlns:a16="http://schemas.microsoft.com/office/drawing/2014/main" id="{71415566-453B-4DFD-99EF-C2F5720ED1AB}"/>
+                <a16:creationId xmlns:a16="http://schemas.microsoft.com/office/drawing/2014/main" id="{7B593D54-FB77-422A-B262-F18A03539D87}"/>
               </a:ext>
             </a:extLst>
           </p:cNvPr>
@@ -20566,7 +20686,7 @@
           <p:cNvPr id="125" name="">
             <a:extLst xmlns:a="http://schemas.openxmlformats.org/drawingml/2006/main">
               <a:ext uri="{FF2B5EF4-FFF2-40B4-BE49-F238E27FC236}">
-                <a16:creationId xmlns:a16="http://schemas.microsoft.com/office/drawing/2014/main" id="{5BAA69F5-116D-4B32-AC07-F3C642D0B2D3}"/>
+                <a16:creationId xmlns:a16="http://schemas.microsoft.com/office/drawing/2014/main" id="{A7959816-73EA-49D2-BCB2-F50515F535CF}"/>
               </a:ext>
             </a:extLst>
           </p:cNvPr>
@@ -20641,7 +20761,7 @@
           <p:cNvPr id="126" name="">
             <a:extLst xmlns:a="http://schemas.openxmlformats.org/drawingml/2006/main">
               <a:ext uri="{FF2B5EF4-FFF2-40B4-BE49-F238E27FC236}">
-                <a16:creationId xmlns:a16="http://schemas.microsoft.com/office/drawing/2014/main" id="{E68C548A-13C2-4939-B3BF-BB44B61F8F32}"/>
+                <a16:creationId xmlns:a16="http://schemas.microsoft.com/office/drawing/2014/main" id="{2162145B-3F9E-40E4-9EAF-31021B17E9AA}"/>
               </a:ext>
             </a:extLst>
           </p:cNvPr>
@@ -20751,7 +20871,7 @@
           <p:cNvPr id="127" name="">
             <a:extLst xmlns:a="http://schemas.openxmlformats.org/drawingml/2006/main">
               <a:ext uri="{FF2B5EF4-FFF2-40B4-BE49-F238E27FC236}">
-                <a16:creationId xmlns:a16="http://schemas.microsoft.com/office/drawing/2014/main" id="{21F524E0-2EED-4D18-931C-220020F33DE9}"/>
+                <a16:creationId xmlns:a16="http://schemas.microsoft.com/office/drawing/2014/main" id="{FABD9BB6-4FA1-4911-B03D-BEEBE352FF93}"/>
               </a:ext>
             </a:extLst>
           </p:cNvPr>
@@ -20826,7 +20946,7 @@
           <p:cNvPr id="128" name="">
             <a:extLst xmlns:a="http://schemas.openxmlformats.org/drawingml/2006/main">
               <a:ext uri="{FF2B5EF4-FFF2-40B4-BE49-F238E27FC236}">
-                <a16:creationId xmlns:a16="http://schemas.microsoft.com/office/drawing/2014/main" id="{8B5E0EA7-381E-48B0-9DF7-DF5A40F7B7A5}"/>
+                <a16:creationId xmlns:a16="http://schemas.microsoft.com/office/drawing/2014/main" id="{C09CBB75-8392-4D1D-B1D3-189A0615B830}"/>
               </a:ext>
             </a:extLst>
           </p:cNvPr>
@@ -20936,7 +21056,7 @@
           <p:cNvPr id="129" name="">
             <a:extLst xmlns:a="http://schemas.openxmlformats.org/drawingml/2006/main">
               <a:ext uri="{FF2B5EF4-FFF2-40B4-BE49-F238E27FC236}">
-                <a16:creationId xmlns:a16="http://schemas.microsoft.com/office/drawing/2014/main" id="{DBB90792-BEF2-4906-9F4D-5CC4447462A9}"/>
+                <a16:creationId xmlns:a16="http://schemas.microsoft.com/office/drawing/2014/main" id="{6CD1CB88-1DD8-4791-932F-BC6B1B21C308}"/>
               </a:ext>
             </a:extLst>
           </p:cNvPr>
@@ -21001,7 +21121,7 @@
     </p:spTree>
     <p:extLst>
       <p:ext uri="{BB962C8B-B14F-4D97-AF65-F5344CB8AC3E}">
-        <p14:creationId xmlns:p14="http://schemas.microsoft.com/office/powerpoint/2010/main" val="2112704824"/>
+        <p14:creationId xmlns:p14="http://schemas.microsoft.com/office/powerpoint/2010/main" val="71809283"/>
       </p:ext>
     </p:extLst>
   </p:cSld>
@@ -21025,7 +21145,7 @@
           <p:cNvPr id="120" name="">
             <a:extLst xmlns:a="http://schemas.openxmlformats.org/drawingml/2006/main">
               <a:ext uri="{FF2B5EF4-FFF2-40B4-BE49-F238E27FC236}">
-                <a16:creationId xmlns:a16="http://schemas.microsoft.com/office/drawing/2014/main" id="{BD919CFC-680A-4ED7-B654-0E0FF1B76715}"/>
+                <a16:creationId xmlns:a16="http://schemas.microsoft.com/office/drawing/2014/main" id="{8B8127A3-0CB8-4ECA-AAD1-5D5C7FE20989}"/>
               </a:ext>
             </a:extLst>
           </p:cNvPr>
@@ -21079,7 +21199,7 @@
           <p:cNvPr id="121" name="">
             <a:extLst xmlns:a="http://schemas.openxmlformats.org/drawingml/2006/main">
               <a:ext uri="{FF2B5EF4-FFF2-40B4-BE49-F238E27FC236}">
-                <a16:creationId xmlns:a16="http://schemas.microsoft.com/office/drawing/2014/main" id="{D4E2E49E-43A3-4331-818B-A89B369568F1}"/>
+                <a16:creationId xmlns:a16="http://schemas.microsoft.com/office/drawing/2014/main" id="{40E8F94A-D3EB-4F23-9BF9-F86B3D5276A6}"/>
               </a:ext>
             </a:extLst>
           </p:cNvPr>
@@ -21146,7 +21266,7 @@
           <p:cNvPr id="122" name="">
             <a:extLst xmlns:a="http://schemas.openxmlformats.org/drawingml/2006/main">
               <a:ext uri="{FF2B5EF4-FFF2-40B4-BE49-F238E27FC236}">
-                <a16:creationId xmlns:a16="http://schemas.microsoft.com/office/drawing/2014/main" id="{6ECF7E94-23CC-4344-A401-08C1B59BF937}"/>
+                <a16:creationId xmlns:a16="http://schemas.microsoft.com/office/drawing/2014/main" id="{54AA50D7-D24F-435B-B675-FD0F868F1B59}"/>
               </a:ext>
             </a:extLst>
           </p:cNvPr>
@@ -21713,7 +21833,7 @@
           <p:cNvPr id="123" name="">
             <a:extLst xmlns:a="http://schemas.openxmlformats.org/drawingml/2006/main">
               <a:ext uri="{FF2B5EF4-FFF2-40B4-BE49-F238E27FC236}">
-                <a16:creationId xmlns:a16="http://schemas.microsoft.com/office/drawing/2014/main" id="{C62D0D0A-0C2C-40F8-B02C-FD51CFB42E0A}"/>
+                <a16:creationId xmlns:a16="http://schemas.microsoft.com/office/drawing/2014/main" id="{14827209-21E1-4842-927C-D4A1A4016104}"/>
               </a:ext>
             </a:extLst>
           </p:cNvPr>
@@ -21788,7 +21908,7 @@
           <p:cNvPr id="124" name="">
             <a:extLst xmlns:a="http://schemas.openxmlformats.org/drawingml/2006/main">
               <a:ext uri="{FF2B5EF4-FFF2-40B4-BE49-F238E27FC236}">
-                <a16:creationId xmlns:a16="http://schemas.microsoft.com/office/drawing/2014/main" id="{71415566-453B-4DFD-99EF-C2F5720ED1AB}"/>
+                <a16:creationId xmlns:a16="http://schemas.microsoft.com/office/drawing/2014/main" id="{7B593D54-FB77-422A-B262-F18A03539D87}"/>
               </a:ext>
             </a:extLst>
           </p:cNvPr>
@@ -21898,7 +22018,7 @@
           <p:cNvPr id="125" name="">
             <a:extLst xmlns:a="http://schemas.openxmlformats.org/drawingml/2006/main">
               <a:ext uri="{FF2B5EF4-FFF2-40B4-BE49-F238E27FC236}">
-                <a16:creationId xmlns:a16="http://schemas.microsoft.com/office/drawing/2014/main" id="{5BAA69F5-116D-4B32-AC07-F3C642D0B2D3}"/>
+                <a16:creationId xmlns:a16="http://schemas.microsoft.com/office/drawing/2014/main" id="{A7959816-73EA-49D2-BCB2-F50515F535CF}"/>
               </a:ext>
             </a:extLst>
           </p:cNvPr>
@@ -21973,7 +22093,7 @@
           <p:cNvPr id="126" name="">
             <a:extLst xmlns:a="http://schemas.openxmlformats.org/drawingml/2006/main">
               <a:ext uri="{FF2B5EF4-FFF2-40B4-BE49-F238E27FC236}">
-                <a16:creationId xmlns:a16="http://schemas.microsoft.com/office/drawing/2014/main" id="{E68C548A-13C2-4939-B3BF-BB44B61F8F32}"/>
+                <a16:creationId xmlns:a16="http://schemas.microsoft.com/office/drawing/2014/main" id="{2162145B-3F9E-40E4-9EAF-31021B17E9AA}"/>
               </a:ext>
             </a:extLst>
           </p:cNvPr>
@@ -22083,7 +22203,7 @@
           <p:cNvPr id="127" name="">
             <a:extLst xmlns:a="http://schemas.openxmlformats.org/drawingml/2006/main">
               <a:ext uri="{FF2B5EF4-FFF2-40B4-BE49-F238E27FC236}">
-                <a16:creationId xmlns:a16="http://schemas.microsoft.com/office/drawing/2014/main" id="{21F524E0-2EED-4D18-931C-220020F33DE9}"/>
+                <a16:creationId xmlns:a16="http://schemas.microsoft.com/office/drawing/2014/main" id="{FABD9BB6-4FA1-4911-B03D-BEEBE352FF93}"/>
               </a:ext>
             </a:extLst>
           </p:cNvPr>
@@ -22158,7 +22278,7 @@
           <p:cNvPr id="128" name="">
             <a:extLst xmlns:a="http://schemas.openxmlformats.org/drawingml/2006/main">
               <a:ext uri="{FF2B5EF4-FFF2-40B4-BE49-F238E27FC236}">
-                <a16:creationId xmlns:a16="http://schemas.microsoft.com/office/drawing/2014/main" id="{8B5E0EA7-381E-48B0-9DF7-DF5A40F7B7A5}"/>
+                <a16:creationId xmlns:a16="http://schemas.microsoft.com/office/drawing/2014/main" id="{C09CBB75-8392-4D1D-B1D3-189A0615B830}"/>
               </a:ext>
             </a:extLst>
           </p:cNvPr>
@@ -22268,7 +22388,7 @@
           <p:cNvPr id="129" name="">
             <a:extLst xmlns:a="http://schemas.openxmlformats.org/drawingml/2006/main">
               <a:ext uri="{FF2B5EF4-FFF2-40B4-BE49-F238E27FC236}">
-                <a16:creationId xmlns:a16="http://schemas.microsoft.com/office/drawing/2014/main" id="{DBB90792-BEF2-4906-9F4D-5CC4447462A9}"/>
+                <a16:creationId xmlns:a16="http://schemas.microsoft.com/office/drawing/2014/main" id="{6CD1CB88-1DD8-4791-932F-BC6B1B21C308}"/>
               </a:ext>
             </a:extLst>
           </p:cNvPr>
@@ -22333,7 +22453,7 @@
     </p:spTree>
     <p:extLst>
       <p:ext uri="{BB962C8B-B14F-4D97-AF65-F5344CB8AC3E}">
-        <p14:creationId xmlns:p14="http://schemas.microsoft.com/office/powerpoint/2010/main" val="2112704824"/>
+        <p14:creationId xmlns:p14="http://schemas.microsoft.com/office/powerpoint/2010/main" val="71809283"/>
       </p:ext>
     </p:extLst>
   </p:cSld>
@@ -22357,7 +22477,7 @@
           <p:cNvPr id="120" name="">
             <a:extLst xmlns:a="http://schemas.openxmlformats.org/drawingml/2006/main">
               <a:ext uri="{FF2B5EF4-FFF2-40B4-BE49-F238E27FC236}">
-                <a16:creationId xmlns:a16="http://schemas.microsoft.com/office/drawing/2014/main" id="{BD919CFC-680A-4ED7-B654-0E0FF1B76715}"/>
+                <a16:creationId xmlns:a16="http://schemas.microsoft.com/office/drawing/2014/main" id="{8B8127A3-0CB8-4ECA-AAD1-5D5C7FE20989}"/>
               </a:ext>
             </a:extLst>
           </p:cNvPr>
@@ -22411,7 +22531,7 @@
           <p:cNvPr id="121" name="">
             <a:extLst xmlns:a="http://schemas.openxmlformats.org/drawingml/2006/main">
               <a:ext uri="{FF2B5EF4-FFF2-40B4-BE49-F238E27FC236}">
-                <a16:creationId xmlns:a16="http://schemas.microsoft.com/office/drawing/2014/main" id="{D4E2E49E-43A3-4331-818B-A89B369568F1}"/>
+                <a16:creationId xmlns:a16="http://schemas.microsoft.com/office/drawing/2014/main" id="{40E8F94A-D3EB-4F23-9BF9-F86B3D5276A6}"/>
               </a:ext>
             </a:extLst>
           </p:cNvPr>
@@ -22478,7 +22598,7 @@
           <p:cNvPr id="122" name="">
             <a:extLst xmlns:a="http://schemas.openxmlformats.org/drawingml/2006/main">
               <a:ext uri="{FF2B5EF4-FFF2-40B4-BE49-F238E27FC236}">
-                <a16:creationId xmlns:a16="http://schemas.microsoft.com/office/drawing/2014/main" id="{6ECF7E94-23CC-4344-A401-08C1B59BF937}"/>
+                <a16:creationId xmlns:a16="http://schemas.microsoft.com/office/drawing/2014/main" id="{54AA50D7-D24F-435B-B675-FD0F868F1B59}"/>
               </a:ext>
             </a:extLst>
           </p:cNvPr>
@@ -23220,7 +23340,7 @@
           <p:cNvPr id="123" name="">
             <a:extLst xmlns:a="http://schemas.openxmlformats.org/drawingml/2006/main">
               <a:ext uri="{FF2B5EF4-FFF2-40B4-BE49-F238E27FC236}">
-                <a16:creationId xmlns:a16="http://schemas.microsoft.com/office/drawing/2014/main" id="{C62D0D0A-0C2C-40F8-B02C-FD51CFB42E0A}"/>
+                <a16:creationId xmlns:a16="http://schemas.microsoft.com/office/drawing/2014/main" id="{14827209-21E1-4842-927C-D4A1A4016104}"/>
               </a:ext>
             </a:extLst>
           </p:cNvPr>
@@ -23295,7 +23415,7 @@
           <p:cNvPr id="124" name="">
             <a:extLst xmlns:a="http://schemas.openxmlformats.org/drawingml/2006/main">
               <a:ext uri="{FF2B5EF4-FFF2-40B4-BE49-F238E27FC236}">
-                <a16:creationId xmlns:a16="http://schemas.microsoft.com/office/drawing/2014/main" id="{71415566-453B-4DFD-99EF-C2F5720ED1AB}"/>
+                <a16:creationId xmlns:a16="http://schemas.microsoft.com/office/drawing/2014/main" id="{7B593D54-FB77-422A-B262-F18A03539D87}"/>
               </a:ext>
             </a:extLst>
           </p:cNvPr>
@@ -23405,7 +23525,7 @@
           <p:cNvPr id="125" name="">
             <a:extLst xmlns:a="http://schemas.openxmlformats.org/drawingml/2006/main">
               <a:ext uri="{FF2B5EF4-FFF2-40B4-BE49-F238E27FC236}">
-                <a16:creationId xmlns:a16="http://schemas.microsoft.com/office/drawing/2014/main" id="{5BAA69F5-116D-4B32-AC07-F3C642D0B2D3}"/>
+                <a16:creationId xmlns:a16="http://schemas.microsoft.com/office/drawing/2014/main" id="{A7959816-73EA-49D2-BCB2-F50515F535CF}"/>
               </a:ext>
             </a:extLst>
           </p:cNvPr>
@@ -23480,7 +23600,7 @@
           <p:cNvPr id="126" name="">
             <a:extLst xmlns:a="http://schemas.openxmlformats.org/drawingml/2006/main">
               <a:ext uri="{FF2B5EF4-FFF2-40B4-BE49-F238E27FC236}">
-                <a16:creationId xmlns:a16="http://schemas.microsoft.com/office/drawing/2014/main" id="{E68C548A-13C2-4939-B3BF-BB44B61F8F32}"/>
+                <a16:creationId xmlns:a16="http://schemas.microsoft.com/office/drawing/2014/main" id="{2162145B-3F9E-40E4-9EAF-31021B17E9AA}"/>
               </a:ext>
             </a:extLst>
           </p:cNvPr>
@@ -23590,7 +23710,7 @@
           <p:cNvPr id="127" name="">
             <a:extLst xmlns:a="http://schemas.openxmlformats.org/drawingml/2006/main">
               <a:ext uri="{FF2B5EF4-FFF2-40B4-BE49-F238E27FC236}">
-                <a16:creationId xmlns:a16="http://schemas.microsoft.com/office/drawing/2014/main" id="{21F524E0-2EED-4D18-931C-220020F33DE9}"/>
+                <a16:creationId xmlns:a16="http://schemas.microsoft.com/office/drawing/2014/main" id="{FABD9BB6-4FA1-4911-B03D-BEEBE352FF93}"/>
               </a:ext>
             </a:extLst>
           </p:cNvPr>
@@ -23665,7 +23785,7 @@
           <p:cNvPr id="128" name="">
             <a:extLst xmlns:a="http://schemas.openxmlformats.org/drawingml/2006/main">
               <a:ext uri="{FF2B5EF4-FFF2-40B4-BE49-F238E27FC236}">
-                <a16:creationId xmlns:a16="http://schemas.microsoft.com/office/drawing/2014/main" id="{8B5E0EA7-381E-48B0-9DF7-DF5A40F7B7A5}"/>
+                <a16:creationId xmlns:a16="http://schemas.microsoft.com/office/drawing/2014/main" id="{C09CBB75-8392-4D1D-B1D3-189A0615B830}"/>
               </a:ext>
             </a:extLst>
           </p:cNvPr>
@@ -23775,7 +23895,7 @@
           <p:cNvPr id="129" name="">
             <a:extLst xmlns:a="http://schemas.openxmlformats.org/drawingml/2006/main">
               <a:ext uri="{FF2B5EF4-FFF2-40B4-BE49-F238E27FC236}">
-                <a16:creationId xmlns:a16="http://schemas.microsoft.com/office/drawing/2014/main" id="{DBB90792-BEF2-4906-9F4D-5CC4447462A9}"/>
+                <a16:creationId xmlns:a16="http://schemas.microsoft.com/office/drawing/2014/main" id="{6CD1CB88-1DD8-4791-932F-BC6B1B21C308}"/>
               </a:ext>
             </a:extLst>
           </p:cNvPr>
@@ -23840,7 +23960,7 @@
     </p:spTree>
     <p:extLst>
       <p:ext uri="{BB962C8B-B14F-4D97-AF65-F5344CB8AC3E}">
-        <p14:creationId xmlns:p14="http://schemas.microsoft.com/office/powerpoint/2010/main" val="2112704824"/>
+        <p14:creationId xmlns:p14="http://schemas.microsoft.com/office/powerpoint/2010/main" val="71809283"/>
       </p:ext>
     </p:extLst>
   </p:cSld>
@@ -23864,7 +23984,7 @@
           <p:cNvPr id="120" name="">
             <a:extLst xmlns:a="http://schemas.openxmlformats.org/drawingml/2006/main">
               <a:ext uri="{FF2B5EF4-FFF2-40B4-BE49-F238E27FC236}">
-                <a16:creationId xmlns:a16="http://schemas.microsoft.com/office/drawing/2014/main" id="{BD919CFC-680A-4ED7-B654-0E0FF1B76715}"/>
+                <a16:creationId xmlns:a16="http://schemas.microsoft.com/office/drawing/2014/main" id="{8B8127A3-0CB8-4ECA-AAD1-5D5C7FE20989}"/>
               </a:ext>
             </a:extLst>
           </p:cNvPr>
@@ -23918,7 +24038,7 @@
           <p:cNvPr id="121" name="">
             <a:extLst xmlns:a="http://schemas.openxmlformats.org/drawingml/2006/main">
               <a:ext uri="{FF2B5EF4-FFF2-40B4-BE49-F238E27FC236}">
-                <a16:creationId xmlns:a16="http://schemas.microsoft.com/office/drawing/2014/main" id="{D4E2E49E-43A3-4331-818B-A89B369568F1}"/>
+                <a16:creationId xmlns:a16="http://schemas.microsoft.com/office/drawing/2014/main" id="{40E8F94A-D3EB-4F23-9BF9-F86B3D5276A6}"/>
               </a:ext>
             </a:extLst>
           </p:cNvPr>
@@ -23985,7 +24105,7 @@
           <p:cNvPr id="122" name="">
             <a:extLst xmlns:a="http://schemas.openxmlformats.org/drawingml/2006/main">
               <a:ext uri="{FF2B5EF4-FFF2-40B4-BE49-F238E27FC236}">
-                <a16:creationId xmlns:a16="http://schemas.microsoft.com/office/drawing/2014/main" id="{6ECF7E94-23CC-4344-A401-08C1B59BF937}"/>
+                <a16:creationId xmlns:a16="http://schemas.microsoft.com/office/drawing/2014/main" id="{54AA50D7-D24F-435B-B675-FD0F868F1B59}"/>
               </a:ext>
             </a:extLst>
           </p:cNvPr>
@@ -24657,7 +24777,7 @@
           <p:cNvPr id="123" name="">
             <a:extLst xmlns:a="http://schemas.openxmlformats.org/drawingml/2006/main">
               <a:ext uri="{FF2B5EF4-FFF2-40B4-BE49-F238E27FC236}">
-                <a16:creationId xmlns:a16="http://schemas.microsoft.com/office/drawing/2014/main" id="{C62D0D0A-0C2C-40F8-B02C-FD51CFB42E0A}"/>
+                <a16:creationId xmlns:a16="http://schemas.microsoft.com/office/drawing/2014/main" id="{14827209-21E1-4842-927C-D4A1A4016104}"/>
               </a:ext>
             </a:extLst>
           </p:cNvPr>
@@ -24732,7 +24852,7 @@
           <p:cNvPr id="124" name="">
             <a:extLst xmlns:a="http://schemas.openxmlformats.org/drawingml/2006/main">
               <a:ext uri="{FF2B5EF4-FFF2-40B4-BE49-F238E27FC236}">
-                <a16:creationId xmlns:a16="http://schemas.microsoft.com/office/drawing/2014/main" id="{71415566-453B-4DFD-99EF-C2F5720ED1AB}"/>
+                <a16:creationId xmlns:a16="http://schemas.microsoft.com/office/drawing/2014/main" id="{7B593D54-FB77-422A-B262-F18A03539D87}"/>
               </a:ext>
             </a:extLst>
           </p:cNvPr>
@@ -24842,7 +24962,7 @@
           <p:cNvPr id="125" name="">
             <a:extLst xmlns:a="http://schemas.openxmlformats.org/drawingml/2006/main">
               <a:ext uri="{FF2B5EF4-FFF2-40B4-BE49-F238E27FC236}">
-                <a16:creationId xmlns:a16="http://schemas.microsoft.com/office/drawing/2014/main" id="{5BAA69F5-116D-4B32-AC07-F3C642D0B2D3}"/>
+                <a16:creationId xmlns:a16="http://schemas.microsoft.com/office/drawing/2014/main" id="{A7959816-73EA-49D2-BCB2-F50515F535CF}"/>
               </a:ext>
             </a:extLst>
           </p:cNvPr>
@@ -24917,7 +25037,7 @@
           <p:cNvPr id="126" name="">
             <a:extLst xmlns:a="http://schemas.openxmlformats.org/drawingml/2006/main">
               <a:ext uri="{FF2B5EF4-FFF2-40B4-BE49-F238E27FC236}">
-                <a16:creationId xmlns:a16="http://schemas.microsoft.com/office/drawing/2014/main" id="{E68C548A-13C2-4939-B3BF-BB44B61F8F32}"/>
+                <a16:creationId xmlns:a16="http://schemas.microsoft.com/office/drawing/2014/main" id="{2162145B-3F9E-40E4-9EAF-31021B17E9AA}"/>
               </a:ext>
             </a:extLst>
           </p:cNvPr>
@@ -25027,7 +25147,7 @@
           <p:cNvPr id="127" name="">
             <a:extLst xmlns:a="http://schemas.openxmlformats.org/drawingml/2006/main">
               <a:ext uri="{FF2B5EF4-FFF2-40B4-BE49-F238E27FC236}">
-                <a16:creationId xmlns:a16="http://schemas.microsoft.com/office/drawing/2014/main" id="{21F524E0-2EED-4D18-931C-220020F33DE9}"/>
+                <a16:creationId xmlns:a16="http://schemas.microsoft.com/office/drawing/2014/main" id="{FABD9BB6-4FA1-4911-B03D-BEEBE352FF93}"/>
               </a:ext>
             </a:extLst>
           </p:cNvPr>
@@ -25102,7 +25222,7 @@
           <p:cNvPr id="128" name="">
             <a:extLst xmlns:a="http://schemas.openxmlformats.org/drawingml/2006/main">
               <a:ext uri="{FF2B5EF4-FFF2-40B4-BE49-F238E27FC236}">
-                <a16:creationId xmlns:a16="http://schemas.microsoft.com/office/drawing/2014/main" id="{8B5E0EA7-381E-48B0-9DF7-DF5A40F7B7A5}"/>
+                <a16:creationId xmlns:a16="http://schemas.microsoft.com/office/drawing/2014/main" id="{C09CBB75-8392-4D1D-B1D3-189A0615B830}"/>
               </a:ext>
             </a:extLst>
           </p:cNvPr>
@@ -25212,7 +25332,7 @@
           <p:cNvPr id="129" name="">
             <a:extLst xmlns:a="http://schemas.openxmlformats.org/drawingml/2006/main">
               <a:ext uri="{FF2B5EF4-FFF2-40B4-BE49-F238E27FC236}">
-                <a16:creationId xmlns:a16="http://schemas.microsoft.com/office/drawing/2014/main" id="{DBB90792-BEF2-4906-9F4D-5CC4447462A9}"/>
+                <a16:creationId xmlns:a16="http://schemas.microsoft.com/office/drawing/2014/main" id="{6CD1CB88-1DD8-4791-932F-BC6B1B21C308}"/>
               </a:ext>
             </a:extLst>
           </p:cNvPr>
@@ -25277,7 +25397,7 @@
     </p:spTree>
     <p:extLst>
       <p:ext uri="{BB962C8B-B14F-4D97-AF65-F5344CB8AC3E}">
-        <p14:creationId xmlns:p14="http://schemas.microsoft.com/office/powerpoint/2010/main" val="2112704824"/>
+        <p14:creationId xmlns:p14="http://schemas.microsoft.com/office/powerpoint/2010/main" val="71809283"/>
       </p:ext>
     </p:extLst>
   </p:cSld>
@@ -25301,7 +25421,7 @@
           <p:cNvPr id="120" name="">
             <a:extLst xmlns:a="http://schemas.openxmlformats.org/drawingml/2006/main">
               <a:ext uri="{FF2B5EF4-FFF2-40B4-BE49-F238E27FC236}">
-                <a16:creationId xmlns:a16="http://schemas.microsoft.com/office/drawing/2014/main" id="{BD919CFC-680A-4ED7-B654-0E0FF1B76715}"/>
+                <a16:creationId xmlns:a16="http://schemas.microsoft.com/office/drawing/2014/main" id="{8B8127A3-0CB8-4ECA-AAD1-5D5C7FE20989}"/>
               </a:ext>
             </a:extLst>
           </p:cNvPr>
@@ -25355,7 +25475,7 @@
           <p:cNvPr id="121" name="">
             <a:extLst xmlns:a="http://schemas.openxmlformats.org/drawingml/2006/main">
               <a:ext uri="{FF2B5EF4-FFF2-40B4-BE49-F238E27FC236}">
-                <a16:creationId xmlns:a16="http://schemas.microsoft.com/office/drawing/2014/main" id="{D4E2E49E-43A3-4331-818B-A89B369568F1}"/>
+                <a16:creationId xmlns:a16="http://schemas.microsoft.com/office/drawing/2014/main" id="{40E8F94A-D3EB-4F23-9BF9-F86B3D5276A6}"/>
               </a:ext>
             </a:extLst>
           </p:cNvPr>
@@ -25422,7 +25542,7 @@
           <p:cNvPr id="122" name="">
             <a:extLst xmlns:a="http://schemas.openxmlformats.org/drawingml/2006/main">
               <a:ext uri="{FF2B5EF4-FFF2-40B4-BE49-F238E27FC236}">
-                <a16:creationId xmlns:a16="http://schemas.microsoft.com/office/drawing/2014/main" id="{6ECF7E94-23CC-4344-A401-08C1B59BF937}"/>
+                <a16:creationId xmlns:a16="http://schemas.microsoft.com/office/drawing/2014/main" id="{54AA50D7-D24F-435B-B675-FD0F868F1B59}"/>
               </a:ext>
             </a:extLst>
           </p:cNvPr>
@@ -26164,7 +26284,7 @@
           <p:cNvPr id="123" name="">
             <a:extLst xmlns:a="http://schemas.openxmlformats.org/drawingml/2006/main">
               <a:ext uri="{FF2B5EF4-FFF2-40B4-BE49-F238E27FC236}">
-                <a16:creationId xmlns:a16="http://schemas.microsoft.com/office/drawing/2014/main" id="{C62D0D0A-0C2C-40F8-B02C-FD51CFB42E0A}"/>
+                <a16:creationId xmlns:a16="http://schemas.microsoft.com/office/drawing/2014/main" id="{14827209-21E1-4842-927C-D4A1A4016104}"/>
               </a:ext>
             </a:extLst>
           </p:cNvPr>
@@ -26239,7 +26359,7 @@
           <p:cNvPr id="124" name="">
             <a:extLst xmlns:a="http://schemas.openxmlformats.org/drawingml/2006/main">
               <a:ext uri="{FF2B5EF4-FFF2-40B4-BE49-F238E27FC236}">
-                <a16:creationId xmlns:a16="http://schemas.microsoft.com/office/drawing/2014/main" id="{71415566-453B-4DFD-99EF-C2F5720ED1AB}"/>
+                <a16:creationId xmlns:a16="http://schemas.microsoft.com/office/drawing/2014/main" id="{7B593D54-FB77-422A-B262-F18A03539D87}"/>
               </a:ext>
             </a:extLst>
           </p:cNvPr>
@@ -26349,7 +26469,7 @@
           <p:cNvPr id="125" name="">
             <a:extLst xmlns:a="http://schemas.openxmlformats.org/drawingml/2006/main">
               <a:ext uri="{FF2B5EF4-FFF2-40B4-BE49-F238E27FC236}">
-                <a16:creationId xmlns:a16="http://schemas.microsoft.com/office/drawing/2014/main" id="{5BAA69F5-116D-4B32-AC07-F3C642D0B2D3}"/>
+                <a16:creationId xmlns:a16="http://schemas.microsoft.com/office/drawing/2014/main" id="{A7959816-73EA-49D2-BCB2-F50515F535CF}"/>
               </a:ext>
             </a:extLst>
           </p:cNvPr>
@@ -26424,7 +26544,7 @@
           <p:cNvPr id="126" name="">
             <a:extLst xmlns:a="http://schemas.openxmlformats.org/drawingml/2006/main">
               <a:ext uri="{FF2B5EF4-FFF2-40B4-BE49-F238E27FC236}">
-                <a16:creationId xmlns:a16="http://schemas.microsoft.com/office/drawing/2014/main" id="{E68C548A-13C2-4939-B3BF-BB44B61F8F32}"/>
+                <a16:creationId xmlns:a16="http://schemas.microsoft.com/office/drawing/2014/main" id="{2162145B-3F9E-40E4-9EAF-31021B17E9AA}"/>
               </a:ext>
             </a:extLst>
           </p:cNvPr>
@@ -26534,7 +26654,7 @@
           <p:cNvPr id="127" name="">
             <a:extLst xmlns:a="http://schemas.openxmlformats.org/drawingml/2006/main">
               <a:ext uri="{FF2B5EF4-FFF2-40B4-BE49-F238E27FC236}">
-                <a16:creationId xmlns:a16="http://schemas.microsoft.com/office/drawing/2014/main" id="{21F524E0-2EED-4D18-931C-220020F33DE9}"/>
+                <a16:creationId xmlns:a16="http://schemas.microsoft.com/office/drawing/2014/main" id="{FABD9BB6-4FA1-4911-B03D-BEEBE352FF93}"/>
               </a:ext>
             </a:extLst>
           </p:cNvPr>
@@ -26609,7 +26729,7 @@
           <p:cNvPr id="128" name="">
             <a:extLst xmlns:a="http://schemas.openxmlformats.org/drawingml/2006/main">
               <a:ext uri="{FF2B5EF4-FFF2-40B4-BE49-F238E27FC236}">
-                <a16:creationId xmlns:a16="http://schemas.microsoft.com/office/drawing/2014/main" id="{8B5E0EA7-381E-48B0-9DF7-DF5A40F7B7A5}"/>
+                <a16:creationId xmlns:a16="http://schemas.microsoft.com/office/drawing/2014/main" id="{C09CBB75-8392-4D1D-B1D3-189A0615B830}"/>
               </a:ext>
             </a:extLst>
           </p:cNvPr>
@@ -26719,7 +26839,7 @@
           <p:cNvPr id="129" name="">
             <a:extLst xmlns:a="http://schemas.openxmlformats.org/drawingml/2006/main">
               <a:ext uri="{FF2B5EF4-FFF2-40B4-BE49-F238E27FC236}">
-                <a16:creationId xmlns:a16="http://schemas.microsoft.com/office/drawing/2014/main" id="{DBB90792-BEF2-4906-9F4D-5CC4447462A9}"/>
+                <a16:creationId xmlns:a16="http://schemas.microsoft.com/office/drawing/2014/main" id="{6CD1CB88-1DD8-4791-932F-BC6B1B21C308}"/>
               </a:ext>
             </a:extLst>
           </p:cNvPr>
@@ -26784,7 +26904,7 @@
     </p:spTree>
     <p:extLst>
       <p:ext uri="{BB962C8B-B14F-4D97-AF65-F5344CB8AC3E}">
-        <p14:creationId xmlns:p14="http://schemas.microsoft.com/office/powerpoint/2010/main" val="2112704824"/>
+        <p14:creationId xmlns:p14="http://schemas.microsoft.com/office/powerpoint/2010/main" val="71809283"/>
       </p:ext>
     </p:extLst>
   </p:cSld>
@@ -26808,7 +26928,7 @@
           <p:cNvPr id="18" name="">
             <a:extLst xmlns:a="http://schemas.openxmlformats.org/drawingml/2006/main">
               <a:ext uri="{FF2B5EF4-FFF2-40B4-BE49-F238E27FC236}">
-                <a16:creationId xmlns:a16="http://schemas.microsoft.com/office/drawing/2014/main" id="{DB3468CF-76F2-433C-933D-C68C5A750ED4}"/>
+                <a16:creationId xmlns:a16="http://schemas.microsoft.com/office/drawing/2014/main" id="{48F7A261-E298-43B3-B7BE-2BC96C8FFFFE}"/>
               </a:ext>
             </a:extLst>
           </p:cNvPr>
@@ -26875,7 +26995,7 @@
           <p:cNvPr id="19" name="">
             <a:extLst xmlns:a="http://schemas.openxmlformats.org/drawingml/2006/main">
               <a:ext uri="{FF2B5EF4-FFF2-40B4-BE49-F238E27FC236}">
-                <a16:creationId xmlns:a16="http://schemas.microsoft.com/office/drawing/2014/main" id="{5BB074AA-DC89-43AB-B7D9-3ED093C9EC11}"/>
+                <a16:creationId xmlns:a16="http://schemas.microsoft.com/office/drawing/2014/main" id="{1A3B046C-F112-4063-9FD4-F3C5D2405852}"/>
               </a:ext>
             </a:extLst>
           </p:cNvPr>
@@ -26929,7 +27049,7 @@
           <p:cNvPr id="20" name="">
             <a:extLst xmlns:a="http://schemas.openxmlformats.org/drawingml/2006/main">
               <a:ext uri="{FF2B5EF4-FFF2-40B4-BE49-F238E27FC236}">
-                <a16:creationId xmlns:a16="http://schemas.microsoft.com/office/drawing/2014/main" id="{E60F0BB6-4136-4B6E-A0B9-09FB881DA509}"/>
+                <a16:creationId xmlns:a16="http://schemas.microsoft.com/office/drawing/2014/main" id="{338CD07F-42F7-4855-AA4C-4C684D7A5989}"/>
               </a:ext>
             </a:extLst>
           </p:cNvPr>
@@ -26996,7 +27116,7 @@
           <p:cNvPr id="21" name="">
             <a:extLst xmlns:a="http://schemas.openxmlformats.org/drawingml/2006/main">
               <a:ext uri="{FF2B5EF4-FFF2-40B4-BE49-F238E27FC236}">
-                <a16:creationId xmlns:a16="http://schemas.microsoft.com/office/drawing/2014/main" id="{590E161F-0F0C-40D8-B968-0AADECF44A12}"/>
+                <a16:creationId xmlns:a16="http://schemas.microsoft.com/office/drawing/2014/main" id="{AF6ABAC4-816A-4305-91CF-0EAB70AFC761}"/>
               </a:ext>
             </a:extLst>
           </p:cNvPr>
@@ -27063,7 +27183,7 @@
           <p:cNvPr id="22" name="">
             <a:extLst xmlns:a="http://schemas.openxmlformats.org/drawingml/2006/main">
               <a:ext uri="{FF2B5EF4-FFF2-40B4-BE49-F238E27FC236}">
-                <a16:creationId xmlns:a16="http://schemas.microsoft.com/office/drawing/2014/main" id="{A66EF35C-267A-4A2D-982E-8D307FBEF297}"/>
+                <a16:creationId xmlns:a16="http://schemas.microsoft.com/office/drawing/2014/main" id="{58F5FDB8-1994-442F-92B9-A2DCEF70836D}"/>
               </a:ext>
             </a:extLst>
           </p:cNvPr>
@@ -27130,7 +27250,7 @@
           <p:cNvPr id="23" name="">
             <a:extLst xmlns:a="http://schemas.openxmlformats.org/drawingml/2006/main">
               <a:ext uri="{FF2B5EF4-FFF2-40B4-BE49-F238E27FC236}">
-                <a16:creationId xmlns:a16="http://schemas.microsoft.com/office/drawing/2014/main" id="{AE372E29-AE30-4906-8909-70720AC41F24}"/>
+                <a16:creationId xmlns:a16="http://schemas.microsoft.com/office/drawing/2014/main" id="{6543A099-3097-47CB-A71E-15F350A5A379}"/>
               </a:ext>
             </a:extLst>
           </p:cNvPr>
@@ -27197,7 +27317,7 @@
           <p:cNvPr id="24" name="">
             <a:extLst xmlns:a="http://schemas.openxmlformats.org/drawingml/2006/main">
               <a:ext uri="{FF2B5EF4-FFF2-40B4-BE49-F238E27FC236}">
-                <a16:creationId xmlns:a16="http://schemas.microsoft.com/office/drawing/2014/main" id="{AC6163D7-4642-470C-A375-0AFEF395E5AC}"/>
+                <a16:creationId xmlns:a16="http://schemas.microsoft.com/office/drawing/2014/main" id="{30CFD0DA-D46C-4C74-98F5-C6480075FDB8}"/>
               </a:ext>
             </a:extLst>
           </p:cNvPr>
@@ -27264,7 +27384,7 @@
           <p:cNvPr id="25" name="">
             <a:extLst xmlns:a="http://schemas.openxmlformats.org/drawingml/2006/main">
               <a:ext uri="{FF2B5EF4-FFF2-40B4-BE49-F238E27FC236}">
-                <a16:creationId xmlns:a16="http://schemas.microsoft.com/office/drawing/2014/main" id="{92A3EAD1-7BBD-4822-83AF-20329F2A57B0}"/>
+                <a16:creationId xmlns:a16="http://schemas.microsoft.com/office/drawing/2014/main" id="{7CA8B79F-14CD-490E-B34C-64DBAAF84715}"/>
               </a:ext>
             </a:extLst>
           </p:cNvPr>
@@ -27329,7 +27449,7 @@
     </p:spTree>
     <p:extLst>
       <p:ext uri="{BB962C8B-B14F-4D97-AF65-F5344CB8AC3E}">
-        <p14:creationId xmlns:p14="http://schemas.microsoft.com/office/powerpoint/2010/main" val="757323168"/>
+        <p14:creationId xmlns:p14="http://schemas.microsoft.com/office/powerpoint/2010/main" val="1340780982"/>
       </p:ext>
     </p:extLst>
   </p:cSld>
@@ -27353,7 +27473,7 @@
           <p:cNvPr id="120" name="">
             <a:extLst xmlns:a="http://schemas.openxmlformats.org/drawingml/2006/main">
               <a:ext uri="{FF2B5EF4-FFF2-40B4-BE49-F238E27FC236}">
-                <a16:creationId xmlns:a16="http://schemas.microsoft.com/office/drawing/2014/main" id="{BD919CFC-680A-4ED7-B654-0E0FF1B76715}"/>
+                <a16:creationId xmlns:a16="http://schemas.microsoft.com/office/drawing/2014/main" id="{8B8127A3-0CB8-4ECA-AAD1-5D5C7FE20989}"/>
               </a:ext>
             </a:extLst>
           </p:cNvPr>
@@ -27407,7 +27527,7 @@
           <p:cNvPr id="121" name="">
             <a:extLst xmlns:a="http://schemas.openxmlformats.org/drawingml/2006/main">
               <a:ext uri="{FF2B5EF4-FFF2-40B4-BE49-F238E27FC236}">
-                <a16:creationId xmlns:a16="http://schemas.microsoft.com/office/drawing/2014/main" id="{D4E2E49E-43A3-4331-818B-A89B369568F1}"/>
+                <a16:creationId xmlns:a16="http://schemas.microsoft.com/office/drawing/2014/main" id="{40E8F94A-D3EB-4F23-9BF9-F86B3D5276A6}"/>
               </a:ext>
             </a:extLst>
           </p:cNvPr>
@@ -27474,7 +27594,7 @@
           <p:cNvPr id="122" name="">
             <a:extLst xmlns:a="http://schemas.openxmlformats.org/drawingml/2006/main">
               <a:ext uri="{FF2B5EF4-FFF2-40B4-BE49-F238E27FC236}">
-                <a16:creationId xmlns:a16="http://schemas.microsoft.com/office/drawing/2014/main" id="{6ECF7E94-23CC-4344-A401-08C1B59BF937}"/>
+                <a16:creationId xmlns:a16="http://schemas.microsoft.com/office/drawing/2014/main" id="{54AA50D7-D24F-435B-B675-FD0F868F1B59}"/>
               </a:ext>
             </a:extLst>
           </p:cNvPr>
@@ -28146,7 +28266,7 @@
           <p:cNvPr id="123" name="">
             <a:extLst xmlns:a="http://schemas.openxmlformats.org/drawingml/2006/main">
               <a:ext uri="{FF2B5EF4-FFF2-40B4-BE49-F238E27FC236}">
-                <a16:creationId xmlns:a16="http://schemas.microsoft.com/office/drawing/2014/main" id="{C62D0D0A-0C2C-40F8-B02C-FD51CFB42E0A}"/>
+                <a16:creationId xmlns:a16="http://schemas.microsoft.com/office/drawing/2014/main" id="{14827209-21E1-4842-927C-D4A1A4016104}"/>
               </a:ext>
             </a:extLst>
           </p:cNvPr>
@@ -28221,7 +28341,7 @@
           <p:cNvPr id="124" name="">
             <a:extLst xmlns:a="http://schemas.openxmlformats.org/drawingml/2006/main">
               <a:ext uri="{FF2B5EF4-FFF2-40B4-BE49-F238E27FC236}">
-                <a16:creationId xmlns:a16="http://schemas.microsoft.com/office/drawing/2014/main" id="{71415566-453B-4DFD-99EF-C2F5720ED1AB}"/>
+                <a16:creationId xmlns:a16="http://schemas.microsoft.com/office/drawing/2014/main" id="{7B593D54-FB77-422A-B262-F18A03539D87}"/>
               </a:ext>
             </a:extLst>
           </p:cNvPr>
@@ -28331,7 +28451,7 @@
           <p:cNvPr id="125" name="">
             <a:extLst xmlns:a="http://schemas.openxmlformats.org/drawingml/2006/main">
               <a:ext uri="{FF2B5EF4-FFF2-40B4-BE49-F238E27FC236}">
-                <a16:creationId xmlns:a16="http://schemas.microsoft.com/office/drawing/2014/main" id="{5BAA69F5-116D-4B32-AC07-F3C642D0B2D3}"/>
+                <a16:creationId xmlns:a16="http://schemas.microsoft.com/office/drawing/2014/main" id="{A7959816-73EA-49D2-BCB2-F50515F535CF}"/>
               </a:ext>
             </a:extLst>
           </p:cNvPr>
@@ -28406,7 +28526,7 @@
           <p:cNvPr id="126" name="">
             <a:extLst xmlns:a="http://schemas.openxmlformats.org/drawingml/2006/main">
               <a:ext uri="{FF2B5EF4-FFF2-40B4-BE49-F238E27FC236}">
-                <a16:creationId xmlns:a16="http://schemas.microsoft.com/office/drawing/2014/main" id="{E68C548A-13C2-4939-B3BF-BB44B61F8F32}"/>
+                <a16:creationId xmlns:a16="http://schemas.microsoft.com/office/drawing/2014/main" id="{2162145B-3F9E-40E4-9EAF-31021B17E9AA}"/>
               </a:ext>
             </a:extLst>
           </p:cNvPr>
@@ -28516,7 +28636,7 @@
           <p:cNvPr id="127" name="">
             <a:extLst xmlns:a="http://schemas.openxmlformats.org/drawingml/2006/main">
               <a:ext uri="{FF2B5EF4-FFF2-40B4-BE49-F238E27FC236}">
-                <a16:creationId xmlns:a16="http://schemas.microsoft.com/office/drawing/2014/main" id="{21F524E0-2EED-4D18-931C-220020F33DE9}"/>
+                <a16:creationId xmlns:a16="http://schemas.microsoft.com/office/drawing/2014/main" id="{FABD9BB6-4FA1-4911-B03D-BEEBE352FF93}"/>
               </a:ext>
             </a:extLst>
           </p:cNvPr>
@@ -28591,7 +28711,7 @@
           <p:cNvPr id="128" name="">
             <a:extLst xmlns:a="http://schemas.openxmlformats.org/drawingml/2006/main">
               <a:ext uri="{FF2B5EF4-FFF2-40B4-BE49-F238E27FC236}">
-                <a16:creationId xmlns:a16="http://schemas.microsoft.com/office/drawing/2014/main" id="{8B5E0EA7-381E-48B0-9DF7-DF5A40F7B7A5}"/>
+                <a16:creationId xmlns:a16="http://schemas.microsoft.com/office/drawing/2014/main" id="{C09CBB75-8392-4D1D-B1D3-189A0615B830}"/>
               </a:ext>
             </a:extLst>
           </p:cNvPr>
@@ -28701,7 +28821,7 @@
           <p:cNvPr id="129" name="">
             <a:extLst xmlns:a="http://schemas.openxmlformats.org/drawingml/2006/main">
               <a:ext uri="{FF2B5EF4-FFF2-40B4-BE49-F238E27FC236}">
-                <a16:creationId xmlns:a16="http://schemas.microsoft.com/office/drawing/2014/main" id="{DBB90792-BEF2-4906-9F4D-5CC4447462A9}"/>
+                <a16:creationId xmlns:a16="http://schemas.microsoft.com/office/drawing/2014/main" id="{6CD1CB88-1DD8-4791-932F-BC6B1B21C308}"/>
               </a:ext>
             </a:extLst>
           </p:cNvPr>
@@ -28766,7 +28886,7 @@
     </p:spTree>
     <p:extLst>
       <p:ext uri="{BB962C8B-B14F-4D97-AF65-F5344CB8AC3E}">
-        <p14:creationId xmlns:p14="http://schemas.microsoft.com/office/powerpoint/2010/main" val="2112704824"/>
+        <p14:creationId xmlns:p14="http://schemas.microsoft.com/office/powerpoint/2010/main" val="71809283"/>
       </p:ext>
     </p:extLst>
   </p:cSld>
@@ -28790,7 +28910,7 @@
           <p:cNvPr id="120" name="">
             <a:extLst xmlns:a="http://schemas.openxmlformats.org/drawingml/2006/main">
               <a:ext uri="{FF2B5EF4-FFF2-40B4-BE49-F238E27FC236}">
-                <a16:creationId xmlns:a16="http://schemas.microsoft.com/office/drawing/2014/main" id="{BD919CFC-680A-4ED7-B654-0E0FF1B76715}"/>
+                <a16:creationId xmlns:a16="http://schemas.microsoft.com/office/drawing/2014/main" id="{8B8127A3-0CB8-4ECA-AAD1-5D5C7FE20989}"/>
               </a:ext>
             </a:extLst>
           </p:cNvPr>
@@ -28844,7 +28964,7 @@
           <p:cNvPr id="121" name="">
             <a:extLst xmlns:a="http://schemas.openxmlformats.org/drawingml/2006/main">
               <a:ext uri="{FF2B5EF4-FFF2-40B4-BE49-F238E27FC236}">
-                <a16:creationId xmlns:a16="http://schemas.microsoft.com/office/drawing/2014/main" id="{D4E2E49E-43A3-4331-818B-A89B369568F1}"/>
+                <a16:creationId xmlns:a16="http://schemas.microsoft.com/office/drawing/2014/main" id="{40E8F94A-D3EB-4F23-9BF9-F86B3D5276A6}"/>
               </a:ext>
             </a:extLst>
           </p:cNvPr>
@@ -28911,7 +29031,7 @@
           <p:cNvPr id="122" name="">
             <a:extLst xmlns:a="http://schemas.openxmlformats.org/drawingml/2006/main">
               <a:ext uri="{FF2B5EF4-FFF2-40B4-BE49-F238E27FC236}">
-                <a16:creationId xmlns:a16="http://schemas.microsoft.com/office/drawing/2014/main" id="{6ECF7E94-23CC-4344-A401-08C1B59BF937}"/>
+                <a16:creationId xmlns:a16="http://schemas.microsoft.com/office/drawing/2014/main" id="{54AA50D7-D24F-435B-B675-FD0F868F1B59}"/>
               </a:ext>
             </a:extLst>
           </p:cNvPr>
@@ -29513,7 +29633,7 @@
           <p:cNvPr id="123" name="">
             <a:extLst xmlns:a="http://schemas.openxmlformats.org/drawingml/2006/main">
               <a:ext uri="{FF2B5EF4-FFF2-40B4-BE49-F238E27FC236}">
-                <a16:creationId xmlns:a16="http://schemas.microsoft.com/office/drawing/2014/main" id="{C62D0D0A-0C2C-40F8-B02C-FD51CFB42E0A}"/>
+                <a16:creationId xmlns:a16="http://schemas.microsoft.com/office/drawing/2014/main" id="{14827209-21E1-4842-927C-D4A1A4016104}"/>
               </a:ext>
             </a:extLst>
           </p:cNvPr>
@@ -29588,7 +29708,7 @@
           <p:cNvPr id="124" name="">
             <a:extLst xmlns:a="http://schemas.openxmlformats.org/drawingml/2006/main">
               <a:ext uri="{FF2B5EF4-FFF2-40B4-BE49-F238E27FC236}">
-                <a16:creationId xmlns:a16="http://schemas.microsoft.com/office/drawing/2014/main" id="{71415566-453B-4DFD-99EF-C2F5720ED1AB}"/>
+                <a16:creationId xmlns:a16="http://schemas.microsoft.com/office/drawing/2014/main" id="{7B593D54-FB77-422A-B262-F18A03539D87}"/>
               </a:ext>
             </a:extLst>
           </p:cNvPr>
@@ -29698,7 +29818,7 @@
           <p:cNvPr id="125" name="">
             <a:extLst xmlns:a="http://schemas.openxmlformats.org/drawingml/2006/main">
               <a:ext uri="{FF2B5EF4-FFF2-40B4-BE49-F238E27FC236}">
-                <a16:creationId xmlns:a16="http://schemas.microsoft.com/office/drawing/2014/main" id="{5BAA69F5-116D-4B32-AC07-F3C642D0B2D3}"/>
+                <a16:creationId xmlns:a16="http://schemas.microsoft.com/office/drawing/2014/main" id="{A7959816-73EA-49D2-BCB2-F50515F535CF}"/>
               </a:ext>
             </a:extLst>
           </p:cNvPr>
@@ -29773,7 +29893,7 @@
           <p:cNvPr id="126" name="">
             <a:extLst xmlns:a="http://schemas.openxmlformats.org/drawingml/2006/main">
               <a:ext uri="{FF2B5EF4-FFF2-40B4-BE49-F238E27FC236}">
-                <a16:creationId xmlns:a16="http://schemas.microsoft.com/office/drawing/2014/main" id="{E68C548A-13C2-4939-B3BF-BB44B61F8F32}"/>
+                <a16:creationId xmlns:a16="http://schemas.microsoft.com/office/drawing/2014/main" id="{2162145B-3F9E-40E4-9EAF-31021B17E9AA}"/>
               </a:ext>
             </a:extLst>
           </p:cNvPr>
@@ -29883,7 +30003,7 @@
           <p:cNvPr id="127" name="">
             <a:extLst xmlns:a="http://schemas.openxmlformats.org/drawingml/2006/main">
               <a:ext uri="{FF2B5EF4-FFF2-40B4-BE49-F238E27FC236}">
-                <a16:creationId xmlns:a16="http://schemas.microsoft.com/office/drawing/2014/main" id="{21F524E0-2EED-4D18-931C-220020F33DE9}"/>
+                <a16:creationId xmlns:a16="http://schemas.microsoft.com/office/drawing/2014/main" id="{FABD9BB6-4FA1-4911-B03D-BEEBE352FF93}"/>
               </a:ext>
             </a:extLst>
           </p:cNvPr>
@@ -29958,7 +30078,7 @@
           <p:cNvPr id="128" name="">
             <a:extLst xmlns:a="http://schemas.openxmlformats.org/drawingml/2006/main">
               <a:ext uri="{FF2B5EF4-FFF2-40B4-BE49-F238E27FC236}">
-                <a16:creationId xmlns:a16="http://schemas.microsoft.com/office/drawing/2014/main" id="{8B5E0EA7-381E-48B0-9DF7-DF5A40F7B7A5}"/>
+                <a16:creationId xmlns:a16="http://schemas.microsoft.com/office/drawing/2014/main" id="{C09CBB75-8392-4D1D-B1D3-189A0615B830}"/>
               </a:ext>
             </a:extLst>
           </p:cNvPr>
@@ -30068,7 +30188,7 @@
           <p:cNvPr id="129" name="">
             <a:extLst xmlns:a="http://schemas.openxmlformats.org/drawingml/2006/main">
               <a:ext uri="{FF2B5EF4-FFF2-40B4-BE49-F238E27FC236}">
-                <a16:creationId xmlns:a16="http://schemas.microsoft.com/office/drawing/2014/main" id="{DBB90792-BEF2-4906-9F4D-5CC4447462A9}"/>
+                <a16:creationId xmlns:a16="http://schemas.microsoft.com/office/drawing/2014/main" id="{6CD1CB88-1DD8-4791-932F-BC6B1B21C308}"/>
               </a:ext>
             </a:extLst>
           </p:cNvPr>
@@ -30133,7 +30253,7 @@
     </p:spTree>
     <p:extLst>
       <p:ext uri="{BB962C8B-B14F-4D97-AF65-F5344CB8AC3E}">
-        <p14:creationId xmlns:p14="http://schemas.microsoft.com/office/powerpoint/2010/main" val="2112704824"/>
+        <p14:creationId xmlns:p14="http://schemas.microsoft.com/office/powerpoint/2010/main" val="71809283"/>
       </p:ext>
     </p:extLst>
   </p:cSld>
@@ -30164,7 +30284,7 @@
           <p:cNvPr id="26" name="">
             <a:extLst xmlns:a="http://schemas.openxmlformats.org/drawingml/2006/main">
               <a:ext uri="{FF2B5EF4-FFF2-40B4-BE49-F238E27FC236}">
-                <a16:creationId xmlns:a16="http://schemas.microsoft.com/office/drawing/2014/main" id="{CA0DC302-95CB-4BAD-AE2A-FCD32EEDDE73}"/>
+                <a16:creationId xmlns:a16="http://schemas.microsoft.com/office/drawing/2014/main" id="{1C5FD675-F338-4922-A4E9-88624148F862}"/>
               </a:ext>
             </a:extLst>
           </p:cNvPr>
@@ -30217,7 +30337,7 @@
           <p:cNvPr id="27" name="">
             <a:extLst xmlns:a="http://schemas.openxmlformats.org/drawingml/2006/main">
               <a:ext uri="{FF2B5EF4-FFF2-40B4-BE49-F238E27FC236}">
-                <a16:creationId xmlns:a16="http://schemas.microsoft.com/office/drawing/2014/main" id="{37E02159-8A9B-46C9-90D2-DA6DD62FD5A0}"/>
+                <a16:creationId xmlns:a16="http://schemas.microsoft.com/office/drawing/2014/main" id="{E235729A-8179-455E-AE97-E7669A11C106}"/>
               </a:ext>
             </a:extLst>
           </p:cNvPr>
@@ -30311,7 +30431,7 @@
           <p:cNvPr id="28" name="">
             <a:extLst xmlns:a="http://schemas.openxmlformats.org/drawingml/2006/main">
               <a:ext uri="{FF2B5EF4-FFF2-40B4-BE49-F238E27FC236}">
-                <a16:creationId xmlns:a16="http://schemas.microsoft.com/office/drawing/2014/main" id="{2F73CF55-F52D-48D6-B78A-5492562654B2}"/>
+                <a16:creationId xmlns:a16="http://schemas.microsoft.com/office/drawing/2014/main" id="{EDA8B2AE-A3AB-4B1C-8765-24524BE82A9E}"/>
               </a:ext>
             </a:extLst>
           </p:cNvPr>
@@ -30364,7 +30484,7 @@
           <p:cNvPr id="29" name="">
             <a:extLst xmlns:a="http://schemas.openxmlformats.org/drawingml/2006/main">
               <a:ext uri="{FF2B5EF4-FFF2-40B4-BE49-F238E27FC236}">
-                <a16:creationId xmlns:a16="http://schemas.microsoft.com/office/drawing/2014/main" id="{61BEA18A-3BE7-43A1-A769-B23089910F68}"/>
+                <a16:creationId xmlns:a16="http://schemas.microsoft.com/office/drawing/2014/main" id="{756C492C-5C59-4A26-B631-0520249CAC37}"/>
               </a:ext>
             </a:extLst>
           </p:cNvPr>
@@ -30429,7 +30549,7 @@
     </p:spTree>
     <p:extLst>
       <p:ext uri="{BB962C8B-B14F-4D97-AF65-F5344CB8AC3E}">
-        <p14:creationId xmlns:p14="http://schemas.microsoft.com/office/powerpoint/2010/main" val="1242354970"/>
+        <p14:creationId xmlns:p14="http://schemas.microsoft.com/office/powerpoint/2010/main" val="402919761"/>
       </p:ext>
     </p:extLst>
   </p:cSld>
@@ -30453,7 +30573,7 @@
           <p:cNvPr id="120" name="">
             <a:extLst xmlns:a="http://schemas.openxmlformats.org/drawingml/2006/main">
               <a:ext uri="{FF2B5EF4-FFF2-40B4-BE49-F238E27FC236}">
-                <a16:creationId xmlns:a16="http://schemas.microsoft.com/office/drawing/2014/main" id="{BD919CFC-680A-4ED7-B654-0E0FF1B76715}"/>
+                <a16:creationId xmlns:a16="http://schemas.microsoft.com/office/drawing/2014/main" id="{8B8127A3-0CB8-4ECA-AAD1-5D5C7FE20989}"/>
               </a:ext>
             </a:extLst>
           </p:cNvPr>
@@ -30507,7 +30627,7 @@
           <p:cNvPr id="121" name="">
             <a:extLst xmlns:a="http://schemas.openxmlformats.org/drawingml/2006/main">
               <a:ext uri="{FF2B5EF4-FFF2-40B4-BE49-F238E27FC236}">
-                <a16:creationId xmlns:a16="http://schemas.microsoft.com/office/drawing/2014/main" id="{D4E2E49E-43A3-4331-818B-A89B369568F1}"/>
+                <a16:creationId xmlns:a16="http://schemas.microsoft.com/office/drawing/2014/main" id="{40E8F94A-D3EB-4F23-9BF9-F86B3D5276A6}"/>
               </a:ext>
             </a:extLst>
           </p:cNvPr>
@@ -30574,7 +30694,7 @@
           <p:cNvPr id="122" name="">
             <a:extLst xmlns:a="http://schemas.openxmlformats.org/drawingml/2006/main">
               <a:ext uri="{FF2B5EF4-FFF2-40B4-BE49-F238E27FC236}">
-                <a16:creationId xmlns:a16="http://schemas.microsoft.com/office/drawing/2014/main" id="{6ECF7E94-23CC-4344-A401-08C1B59BF937}"/>
+                <a16:creationId xmlns:a16="http://schemas.microsoft.com/office/drawing/2014/main" id="{54AA50D7-D24F-435B-B675-FD0F868F1B59}"/>
               </a:ext>
             </a:extLst>
           </p:cNvPr>
@@ -31351,7 +31471,7 @@
           <p:cNvPr id="123" name="">
             <a:extLst xmlns:a="http://schemas.openxmlformats.org/drawingml/2006/main">
               <a:ext uri="{FF2B5EF4-FFF2-40B4-BE49-F238E27FC236}">
-                <a16:creationId xmlns:a16="http://schemas.microsoft.com/office/drawing/2014/main" id="{C62D0D0A-0C2C-40F8-B02C-FD51CFB42E0A}"/>
+                <a16:creationId xmlns:a16="http://schemas.microsoft.com/office/drawing/2014/main" id="{14827209-21E1-4842-927C-D4A1A4016104}"/>
               </a:ext>
             </a:extLst>
           </p:cNvPr>
@@ -31426,7 +31546,7 @@
           <p:cNvPr id="124" name="">
             <a:extLst xmlns:a="http://schemas.openxmlformats.org/drawingml/2006/main">
               <a:ext uri="{FF2B5EF4-FFF2-40B4-BE49-F238E27FC236}">
-                <a16:creationId xmlns:a16="http://schemas.microsoft.com/office/drawing/2014/main" id="{71415566-453B-4DFD-99EF-C2F5720ED1AB}"/>
+                <a16:creationId xmlns:a16="http://schemas.microsoft.com/office/drawing/2014/main" id="{7B593D54-FB77-422A-B262-F18A03539D87}"/>
               </a:ext>
             </a:extLst>
           </p:cNvPr>
@@ -31536,7 +31656,7 @@
           <p:cNvPr id="125" name="">
             <a:extLst xmlns:a="http://schemas.openxmlformats.org/drawingml/2006/main">
               <a:ext uri="{FF2B5EF4-FFF2-40B4-BE49-F238E27FC236}">
-                <a16:creationId xmlns:a16="http://schemas.microsoft.com/office/drawing/2014/main" id="{5BAA69F5-116D-4B32-AC07-F3C642D0B2D3}"/>
+                <a16:creationId xmlns:a16="http://schemas.microsoft.com/office/drawing/2014/main" id="{A7959816-73EA-49D2-BCB2-F50515F535CF}"/>
               </a:ext>
             </a:extLst>
           </p:cNvPr>
@@ -31611,7 +31731,7 @@
           <p:cNvPr id="126" name="">
             <a:extLst xmlns:a="http://schemas.openxmlformats.org/drawingml/2006/main">
               <a:ext uri="{FF2B5EF4-FFF2-40B4-BE49-F238E27FC236}">
-                <a16:creationId xmlns:a16="http://schemas.microsoft.com/office/drawing/2014/main" id="{E68C548A-13C2-4939-B3BF-BB44B61F8F32}"/>
+                <a16:creationId xmlns:a16="http://schemas.microsoft.com/office/drawing/2014/main" id="{2162145B-3F9E-40E4-9EAF-31021B17E9AA}"/>
               </a:ext>
             </a:extLst>
           </p:cNvPr>
@@ -31721,7 +31841,7 @@
           <p:cNvPr id="127" name="">
             <a:extLst xmlns:a="http://schemas.openxmlformats.org/drawingml/2006/main">
               <a:ext uri="{FF2B5EF4-FFF2-40B4-BE49-F238E27FC236}">
-                <a16:creationId xmlns:a16="http://schemas.microsoft.com/office/drawing/2014/main" id="{21F524E0-2EED-4D18-931C-220020F33DE9}"/>
+                <a16:creationId xmlns:a16="http://schemas.microsoft.com/office/drawing/2014/main" id="{FABD9BB6-4FA1-4911-B03D-BEEBE352FF93}"/>
               </a:ext>
             </a:extLst>
           </p:cNvPr>
@@ -31796,7 +31916,7 @@
           <p:cNvPr id="128" name="">
             <a:extLst xmlns:a="http://schemas.openxmlformats.org/drawingml/2006/main">
               <a:ext uri="{FF2B5EF4-FFF2-40B4-BE49-F238E27FC236}">
-                <a16:creationId xmlns:a16="http://schemas.microsoft.com/office/drawing/2014/main" id="{8B5E0EA7-381E-48B0-9DF7-DF5A40F7B7A5}"/>
+                <a16:creationId xmlns:a16="http://schemas.microsoft.com/office/drawing/2014/main" id="{C09CBB75-8392-4D1D-B1D3-189A0615B830}"/>
               </a:ext>
             </a:extLst>
           </p:cNvPr>
@@ -31906,7 +32026,7 @@
           <p:cNvPr id="129" name="">
             <a:extLst xmlns:a="http://schemas.openxmlformats.org/drawingml/2006/main">
               <a:ext uri="{FF2B5EF4-FFF2-40B4-BE49-F238E27FC236}">
-                <a16:creationId xmlns:a16="http://schemas.microsoft.com/office/drawing/2014/main" id="{DBB90792-BEF2-4906-9F4D-5CC4447462A9}"/>
+                <a16:creationId xmlns:a16="http://schemas.microsoft.com/office/drawing/2014/main" id="{6CD1CB88-1DD8-4791-932F-BC6B1B21C308}"/>
               </a:ext>
             </a:extLst>
           </p:cNvPr>
@@ -31971,7 +32091,7 @@
     </p:spTree>
     <p:extLst>
       <p:ext uri="{BB962C8B-B14F-4D97-AF65-F5344CB8AC3E}">
-        <p14:creationId xmlns:p14="http://schemas.microsoft.com/office/powerpoint/2010/main" val="2112704824"/>
+        <p14:creationId xmlns:p14="http://schemas.microsoft.com/office/powerpoint/2010/main" val="71809283"/>
       </p:ext>
     </p:extLst>
   </p:cSld>
@@ -31995,7 +32115,7 @@
           <p:cNvPr id="120" name="">
             <a:extLst xmlns:a="http://schemas.openxmlformats.org/drawingml/2006/main">
               <a:ext uri="{FF2B5EF4-FFF2-40B4-BE49-F238E27FC236}">
-                <a16:creationId xmlns:a16="http://schemas.microsoft.com/office/drawing/2014/main" id="{BD919CFC-680A-4ED7-B654-0E0FF1B76715}"/>
+                <a16:creationId xmlns:a16="http://schemas.microsoft.com/office/drawing/2014/main" id="{8B8127A3-0CB8-4ECA-AAD1-5D5C7FE20989}"/>
               </a:ext>
             </a:extLst>
           </p:cNvPr>
@@ -32049,7 +32169,7 @@
           <p:cNvPr id="121" name="">
             <a:extLst xmlns:a="http://schemas.openxmlformats.org/drawingml/2006/main">
               <a:ext uri="{FF2B5EF4-FFF2-40B4-BE49-F238E27FC236}">
-                <a16:creationId xmlns:a16="http://schemas.microsoft.com/office/drawing/2014/main" id="{D4E2E49E-43A3-4331-818B-A89B369568F1}"/>
+                <a16:creationId xmlns:a16="http://schemas.microsoft.com/office/drawing/2014/main" id="{40E8F94A-D3EB-4F23-9BF9-F86B3D5276A6}"/>
               </a:ext>
             </a:extLst>
           </p:cNvPr>
@@ -32116,7 +32236,7 @@
           <p:cNvPr id="122" name="">
             <a:extLst xmlns:a="http://schemas.openxmlformats.org/drawingml/2006/main">
               <a:ext uri="{FF2B5EF4-FFF2-40B4-BE49-F238E27FC236}">
-                <a16:creationId xmlns:a16="http://schemas.microsoft.com/office/drawing/2014/main" id="{6ECF7E94-23CC-4344-A401-08C1B59BF937}"/>
+                <a16:creationId xmlns:a16="http://schemas.microsoft.com/office/drawing/2014/main" id="{54AA50D7-D24F-435B-B675-FD0F868F1B59}"/>
               </a:ext>
             </a:extLst>
           </p:cNvPr>
@@ -32648,7 +32768,7 @@
           <p:cNvPr id="123" name="">
             <a:extLst xmlns:a="http://schemas.openxmlformats.org/drawingml/2006/main">
               <a:ext uri="{FF2B5EF4-FFF2-40B4-BE49-F238E27FC236}">
-                <a16:creationId xmlns:a16="http://schemas.microsoft.com/office/drawing/2014/main" id="{C62D0D0A-0C2C-40F8-B02C-FD51CFB42E0A}"/>
+                <a16:creationId xmlns:a16="http://schemas.microsoft.com/office/drawing/2014/main" id="{14827209-21E1-4842-927C-D4A1A4016104}"/>
               </a:ext>
             </a:extLst>
           </p:cNvPr>
@@ -32723,7 +32843,7 @@
           <p:cNvPr id="124" name="">
             <a:extLst xmlns:a="http://schemas.openxmlformats.org/drawingml/2006/main">
               <a:ext uri="{FF2B5EF4-FFF2-40B4-BE49-F238E27FC236}">
-                <a16:creationId xmlns:a16="http://schemas.microsoft.com/office/drawing/2014/main" id="{71415566-453B-4DFD-99EF-C2F5720ED1AB}"/>
+                <a16:creationId xmlns:a16="http://schemas.microsoft.com/office/drawing/2014/main" id="{7B593D54-FB77-422A-B262-F18A03539D87}"/>
               </a:ext>
             </a:extLst>
           </p:cNvPr>
@@ -32833,7 +32953,7 @@
           <p:cNvPr id="125" name="">
             <a:extLst xmlns:a="http://schemas.openxmlformats.org/drawingml/2006/main">
               <a:ext uri="{FF2B5EF4-FFF2-40B4-BE49-F238E27FC236}">
-                <a16:creationId xmlns:a16="http://schemas.microsoft.com/office/drawing/2014/main" id="{5BAA69F5-116D-4B32-AC07-F3C642D0B2D3}"/>
+                <a16:creationId xmlns:a16="http://schemas.microsoft.com/office/drawing/2014/main" id="{A7959816-73EA-49D2-BCB2-F50515F535CF}"/>
               </a:ext>
             </a:extLst>
           </p:cNvPr>
@@ -32908,7 +33028,7 @@
           <p:cNvPr id="126" name="">
             <a:extLst xmlns:a="http://schemas.openxmlformats.org/drawingml/2006/main">
               <a:ext uri="{FF2B5EF4-FFF2-40B4-BE49-F238E27FC236}">
-                <a16:creationId xmlns:a16="http://schemas.microsoft.com/office/drawing/2014/main" id="{E68C548A-13C2-4939-B3BF-BB44B61F8F32}"/>
+                <a16:creationId xmlns:a16="http://schemas.microsoft.com/office/drawing/2014/main" id="{2162145B-3F9E-40E4-9EAF-31021B17E9AA}"/>
               </a:ext>
             </a:extLst>
           </p:cNvPr>
@@ -33018,7 +33138,7 @@
           <p:cNvPr id="127" name="">
             <a:extLst xmlns:a="http://schemas.openxmlformats.org/drawingml/2006/main">
               <a:ext uri="{FF2B5EF4-FFF2-40B4-BE49-F238E27FC236}">
-                <a16:creationId xmlns:a16="http://schemas.microsoft.com/office/drawing/2014/main" id="{21F524E0-2EED-4D18-931C-220020F33DE9}"/>
+                <a16:creationId xmlns:a16="http://schemas.microsoft.com/office/drawing/2014/main" id="{FABD9BB6-4FA1-4911-B03D-BEEBE352FF93}"/>
               </a:ext>
             </a:extLst>
           </p:cNvPr>
@@ -33093,7 +33213,7 @@
           <p:cNvPr id="128" name="">
             <a:extLst xmlns:a="http://schemas.openxmlformats.org/drawingml/2006/main">
               <a:ext uri="{FF2B5EF4-FFF2-40B4-BE49-F238E27FC236}">
-                <a16:creationId xmlns:a16="http://schemas.microsoft.com/office/drawing/2014/main" id="{8B5E0EA7-381E-48B0-9DF7-DF5A40F7B7A5}"/>
+                <a16:creationId xmlns:a16="http://schemas.microsoft.com/office/drawing/2014/main" id="{C09CBB75-8392-4D1D-B1D3-189A0615B830}"/>
               </a:ext>
             </a:extLst>
           </p:cNvPr>
@@ -33203,7 +33323,7 @@
           <p:cNvPr id="129" name="">
             <a:extLst xmlns:a="http://schemas.openxmlformats.org/drawingml/2006/main">
               <a:ext uri="{FF2B5EF4-FFF2-40B4-BE49-F238E27FC236}">
-                <a16:creationId xmlns:a16="http://schemas.microsoft.com/office/drawing/2014/main" id="{DBB90792-BEF2-4906-9F4D-5CC4447462A9}"/>
+                <a16:creationId xmlns:a16="http://schemas.microsoft.com/office/drawing/2014/main" id="{6CD1CB88-1DD8-4791-932F-BC6B1B21C308}"/>
               </a:ext>
             </a:extLst>
           </p:cNvPr>
@@ -33268,7 +33388,7 @@
     </p:spTree>
     <p:extLst>
       <p:ext uri="{BB962C8B-B14F-4D97-AF65-F5344CB8AC3E}">
-        <p14:creationId xmlns:p14="http://schemas.microsoft.com/office/powerpoint/2010/main" val="2112704824"/>
+        <p14:creationId xmlns:p14="http://schemas.microsoft.com/office/powerpoint/2010/main" val="71809283"/>
       </p:ext>
     </p:extLst>
   </p:cSld>
@@ -33292,7 +33412,7 @@
           <p:cNvPr id="120" name="">
             <a:extLst xmlns:a="http://schemas.openxmlformats.org/drawingml/2006/main">
               <a:ext uri="{FF2B5EF4-FFF2-40B4-BE49-F238E27FC236}">
-                <a16:creationId xmlns:a16="http://schemas.microsoft.com/office/drawing/2014/main" id="{BD919CFC-680A-4ED7-B654-0E0FF1B76715}"/>
+                <a16:creationId xmlns:a16="http://schemas.microsoft.com/office/drawing/2014/main" id="{8B8127A3-0CB8-4ECA-AAD1-5D5C7FE20989}"/>
               </a:ext>
             </a:extLst>
           </p:cNvPr>
@@ -33346,7 +33466,7 @@
           <p:cNvPr id="121" name="">
             <a:extLst xmlns:a="http://schemas.openxmlformats.org/drawingml/2006/main">
               <a:ext uri="{FF2B5EF4-FFF2-40B4-BE49-F238E27FC236}">
-                <a16:creationId xmlns:a16="http://schemas.microsoft.com/office/drawing/2014/main" id="{D4E2E49E-43A3-4331-818B-A89B369568F1}"/>
+                <a16:creationId xmlns:a16="http://schemas.microsoft.com/office/drawing/2014/main" id="{40E8F94A-D3EB-4F23-9BF9-F86B3D5276A6}"/>
               </a:ext>
             </a:extLst>
           </p:cNvPr>
@@ -33413,7 +33533,7 @@
           <p:cNvPr id="122" name="">
             <a:extLst xmlns:a="http://schemas.openxmlformats.org/drawingml/2006/main">
               <a:ext uri="{FF2B5EF4-FFF2-40B4-BE49-F238E27FC236}">
-                <a16:creationId xmlns:a16="http://schemas.microsoft.com/office/drawing/2014/main" id="{6ECF7E94-23CC-4344-A401-08C1B59BF937}"/>
+                <a16:creationId xmlns:a16="http://schemas.microsoft.com/office/drawing/2014/main" id="{54AA50D7-D24F-435B-B675-FD0F868F1B59}"/>
               </a:ext>
             </a:extLst>
           </p:cNvPr>
@@ -34190,7 +34310,7 @@
           <p:cNvPr id="123" name="">
             <a:extLst xmlns:a="http://schemas.openxmlformats.org/drawingml/2006/main">
               <a:ext uri="{FF2B5EF4-FFF2-40B4-BE49-F238E27FC236}">
-                <a16:creationId xmlns:a16="http://schemas.microsoft.com/office/drawing/2014/main" id="{C62D0D0A-0C2C-40F8-B02C-FD51CFB42E0A}"/>
+                <a16:creationId xmlns:a16="http://schemas.microsoft.com/office/drawing/2014/main" id="{14827209-21E1-4842-927C-D4A1A4016104}"/>
               </a:ext>
             </a:extLst>
           </p:cNvPr>
@@ -34265,7 +34385,7 @@
           <p:cNvPr id="124" name="">
             <a:extLst xmlns:a="http://schemas.openxmlformats.org/drawingml/2006/main">
               <a:ext uri="{FF2B5EF4-FFF2-40B4-BE49-F238E27FC236}">
-                <a16:creationId xmlns:a16="http://schemas.microsoft.com/office/drawing/2014/main" id="{71415566-453B-4DFD-99EF-C2F5720ED1AB}"/>
+                <a16:creationId xmlns:a16="http://schemas.microsoft.com/office/drawing/2014/main" id="{7B593D54-FB77-422A-B262-F18A03539D87}"/>
               </a:ext>
             </a:extLst>
           </p:cNvPr>
@@ -34375,7 +34495,7 @@
           <p:cNvPr id="125" name="">
             <a:extLst xmlns:a="http://schemas.openxmlformats.org/drawingml/2006/main">
               <a:ext uri="{FF2B5EF4-FFF2-40B4-BE49-F238E27FC236}">
-                <a16:creationId xmlns:a16="http://schemas.microsoft.com/office/drawing/2014/main" id="{5BAA69F5-116D-4B32-AC07-F3C642D0B2D3}"/>
+                <a16:creationId xmlns:a16="http://schemas.microsoft.com/office/drawing/2014/main" id="{A7959816-73EA-49D2-BCB2-F50515F535CF}"/>
               </a:ext>
             </a:extLst>
           </p:cNvPr>
@@ -34450,7 +34570,7 @@
           <p:cNvPr id="126" name="">
             <a:extLst xmlns:a="http://schemas.openxmlformats.org/drawingml/2006/main">
               <a:ext uri="{FF2B5EF4-FFF2-40B4-BE49-F238E27FC236}">
-                <a16:creationId xmlns:a16="http://schemas.microsoft.com/office/drawing/2014/main" id="{E68C548A-13C2-4939-B3BF-BB44B61F8F32}"/>
+                <a16:creationId xmlns:a16="http://schemas.microsoft.com/office/drawing/2014/main" id="{2162145B-3F9E-40E4-9EAF-31021B17E9AA}"/>
               </a:ext>
             </a:extLst>
           </p:cNvPr>
@@ -34560,7 +34680,7 @@
           <p:cNvPr id="127" name="">
             <a:extLst xmlns:a="http://schemas.openxmlformats.org/drawingml/2006/main">
               <a:ext uri="{FF2B5EF4-FFF2-40B4-BE49-F238E27FC236}">
-                <a16:creationId xmlns:a16="http://schemas.microsoft.com/office/drawing/2014/main" id="{21F524E0-2EED-4D18-931C-220020F33DE9}"/>
+                <a16:creationId xmlns:a16="http://schemas.microsoft.com/office/drawing/2014/main" id="{FABD9BB6-4FA1-4911-B03D-BEEBE352FF93}"/>
               </a:ext>
             </a:extLst>
           </p:cNvPr>
@@ -34635,7 +34755,7 @@
           <p:cNvPr id="128" name="">
             <a:extLst xmlns:a="http://schemas.openxmlformats.org/drawingml/2006/main">
               <a:ext uri="{FF2B5EF4-FFF2-40B4-BE49-F238E27FC236}">
-                <a16:creationId xmlns:a16="http://schemas.microsoft.com/office/drawing/2014/main" id="{8B5E0EA7-381E-48B0-9DF7-DF5A40F7B7A5}"/>
+                <a16:creationId xmlns:a16="http://schemas.microsoft.com/office/drawing/2014/main" id="{C09CBB75-8392-4D1D-B1D3-189A0615B830}"/>
               </a:ext>
             </a:extLst>
           </p:cNvPr>
@@ -34745,7 +34865,7 @@
           <p:cNvPr id="129" name="">
             <a:extLst xmlns:a="http://schemas.openxmlformats.org/drawingml/2006/main">
               <a:ext uri="{FF2B5EF4-FFF2-40B4-BE49-F238E27FC236}">
-                <a16:creationId xmlns:a16="http://schemas.microsoft.com/office/drawing/2014/main" id="{DBB90792-BEF2-4906-9F4D-5CC4447462A9}"/>
+                <a16:creationId xmlns:a16="http://schemas.microsoft.com/office/drawing/2014/main" id="{6CD1CB88-1DD8-4791-932F-BC6B1B21C308}"/>
               </a:ext>
             </a:extLst>
           </p:cNvPr>
@@ -34810,7 +34930,7 @@
     </p:spTree>
     <p:extLst>
       <p:ext uri="{BB962C8B-B14F-4D97-AF65-F5344CB8AC3E}">
-        <p14:creationId xmlns:p14="http://schemas.microsoft.com/office/powerpoint/2010/main" val="2112704824"/>
+        <p14:creationId xmlns:p14="http://schemas.microsoft.com/office/powerpoint/2010/main" val="71809283"/>
       </p:ext>
     </p:extLst>
   </p:cSld>
@@ -34834,7 +34954,7 @@
           <p:cNvPr id="120" name="">
             <a:extLst xmlns:a="http://schemas.openxmlformats.org/drawingml/2006/main">
               <a:ext uri="{FF2B5EF4-FFF2-40B4-BE49-F238E27FC236}">
-                <a16:creationId xmlns:a16="http://schemas.microsoft.com/office/drawing/2014/main" id="{BD919CFC-680A-4ED7-B654-0E0FF1B76715}"/>
+                <a16:creationId xmlns:a16="http://schemas.microsoft.com/office/drawing/2014/main" id="{8B8127A3-0CB8-4ECA-AAD1-5D5C7FE20989}"/>
               </a:ext>
             </a:extLst>
           </p:cNvPr>
@@ -34888,7 +35008,7 @@
           <p:cNvPr id="121" name="">
             <a:extLst xmlns:a="http://schemas.openxmlformats.org/drawingml/2006/main">
               <a:ext uri="{FF2B5EF4-FFF2-40B4-BE49-F238E27FC236}">
-                <a16:creationId xmlns:a16="http://schemas.microsoft.com/office/drawing/2014/main" id="{D4E2E49E-43A3-4331-818B-A89B369568F1}"/>
+                <a16:creationId xmlns:a16="http://schemas.microsoft.com/office/drawing/2014/main" id="{40E8F94A-D3EB-4F23-9BF9-F86B3D5276A6}"/>
               </a:ext>
             </a:extLst>
           </p:cNvPr>
@@ -34955,7 +35075,7 @@
           <p:cNvPr id="122" name="">
             <a:extLst xmlns:a="http://schemas.openxmlformats.org/drawingml/2006/main">
               <a:ext uri="{FF2B5EF4-FFF2-40B4-BE49-F238E27FC236}">
-                <a16:creationId xmlns:a16="http://schemas.microsoft.com/office/drawing/2014/main" id="{6ECF7E94-23CC-4344-A401-08C1B59BF937}"/>
+                <a16:creationId xmlns:a16="http://schemas.microsoft.com/office/drawing/2014/main" id="{54AA50D7-D24F-435B-B675-FD0F868F1B59}"/>
               </a:ext>
             </a:extLst>
           </p:cNvPr>
@@ -35732,7 +35852,7 @@
           <p:cNvPr id="123" name="">
             <a:extLst xmlns:a="http://schemas.openxmlformats.org/drawingml/2006/main">
               <a:ext uri="{FF2B5EF4-FFF2-40B4-BE49-F238E27FC236}">
-                <a16:creationId xmlns:a16="http://schemas.microsoft.com/office/drawing/2014/main" id="{C62D0D0A-0C2C-40F8-B02C-FD51CFB42E0A}"/>
+                <a16:creationId xmlns:a16="http://schemas.microsoft.com/office/drawing/2014/main" id="{14827209-21E1-4842-927C-D4A1A4016104}"/>
               </a:ext>
             </a:extLst>
           </p:cNvPr>
@@ -35807,7 +35927,7 @@
           <p:cNvPr id="124" name="">
             <a:extLst xmlns:a="http://schemas.openxmlformats.org/drawingml/2006/main">
               <a:ext uri="{FF2B5EF4-FFF2-40B4-BE49-F238E27FC236}">
-                <a16:creationId xmlns:a16="http://schemas.microsoft.com/office/drawing/2014/main" id="{71415566-453B-4DFD-99EF-C2F5720ED1AB}"/>
+                <a16:creationId xmlns:a16="http://schemas.microsoft.com/office/drawing/2014/main" id="{7B593D54-FB77-422A-B262-F18A03539D87}"/>
               </a:ext>
             </a:extLst>
           </p:cNvPr>
@@ -35917,7 +36037,7 @@
           <p:cNvPr id="125" name="">
             <a:extLst xmlns:a="http://schemas.openxmlformats.org/drawingml/2006/main">
               <a:ext uri="{FF2B5EF4-FFF2-40B4-BE49-F238E27FC236}">
-                <a16:creationId xmlns:a16="http://schemas.microsoft.com/office/drawing/2014/main" id="{5BAA69F5-116D-4B32-AC07-F3C642D0B2D3}"/>
+                <a16:creationId xmlns:a16="http://schemas.microsoft.com/office/drawing/2014/main" id="{A7959816-73EA-49D2-BCB2-F50515F535CF}"/>
               </a:ext>
             </a:extLst>
           </p:cNvPr>
@@ -35992,7 +36112,7 @@
           <p:cNvPr id="126" name="">
             <a:extLst xmlns:a="http://schemas.openxmlformats.org/drawingml/2006/main">
               <a:ext uri="{FF2B5EF4-FFF2-40B4-BE49-F238E27FC236}">
-                <a16:creationId xmlns:a16="http://schemas.microsoft.com/office/drawing/2014/main" id="{E68C548A-13C2-4939-B3BF-BB44B61F8F32}"/>
+                <a16:creationId xmlns:a16="http://schemas.microsoft.com/office/drawing/2014/main" id="{2162145B-3F9E-40E4-9EAF-31021B17E9AA}"/>
               </a:ext>
             </a:extLst>
           </p:cNvPr>
@@ -36102,7 +36222,7 @@
           <p:cNvPr id="127" name="">
             <a:extLst xmlns:a="http://schemas.openxmlformats.org/drawingml/2006/main">
               <a:ext uri="{FF2B5EF4-FFF2-40B4-BE49-F238E27FC236}">
-                <a16:creationId xmlns:a16="http://schemas.microsoft.com/office/drawing/2014/main" id="{21F524E0-2EED-4D18-931C-220020F33DE9}"/>
+                <a16:creationId xmlns:a16="http://schemas.microsoft.com/office/drawing/2014/main" id="{FABD9BB6-4FA1-4911-B03D-BEEBE352FF93}"/>
               </a:ext>
             </a:extLst>
           </p:cNvPr>
@@ -36177,7 +36297,7 @@
           <p:cNvPr id="128" name="">
             <a:extLst xmlns:a="http://schemas.openxmlformats.org/drawingml/2006/main">
               <a:ext uri="{FF2B5EF4-FFF2-40B4-BE49-F238E27FC236}">
-                <a16:creationId xmlns:a16="http://schemas.microsoft.com/office/drawing/2014/main" id="{8B5E0EA7-381E-48B0-9DF7-DF5A40F7B7A5}"/>
+                <a16:creationId xmlns:a16="http://schemas.microsoft.com/office/drawing/2014/main" id="{C09CBB75-8392-4D1D-B1D3-189A0615B830}"/>
               </a:ext>
             </a:extLst>
           </p:cNvPr>
@@ -36287,7 +36407,7 @@
           <p:cNvPr id="129" name="">
             <a:extLst xmlns:a="http://schemas.openxmlformats.org/drawingml/2006/main">
               <a:ext uri="{FF2B5EF4-FFF2-40B4-BE49-F238E27FC236}">
-                <a16:creationId xmlns:a16="http://schemas.microsoft.com/office/drawing/2014/main" id="{DBB90792-BEF2-4906-9F4D-5CC4447462A9}"/>
+                <a16:creationId xmlns:a16="http://schemas.microsoft.com/office/drawing/2014/main" id="{6CD1CB88-1DD8-4791-932F-BC6B1B21C308}"/>
               </a:ext>
             </a:extLst>
           </p:cNvPr>
@@ -36352,7 +36472,7 @@
     </p:spTree>
     <p:extLst>
       <p:ext uri="{BB962C8B-B14F-4D97-AF65-F5344CB8AC3E}">
-        <p14:creationId xmlns:p14="http://schemas.microsoft.com/office/powerpoint/2010/main" val="2112704824"/>
+        <p14:creationId xmlns:p14="http://schemas.microsoft.com/office/powerpoint/2010/main" val="71809283"/>
       </p:ext>
     </p:extLst>
   </p:cSld>
@@ -36376,7 +36496,7 @@
           <p:cNvPr id="120" name="">
             <a:extLst xmlns:a="http://schemas.openxmlformats.org/drawingml/2006/main">
               <a:ext uri="{FF2B5EF4-FFF2-40B4-BE49-F238E27FC236}">
-                <a16:creationId xmlns:a16="http://schemas.microsoft.com/office/drawing/2014/main" id="{BD919CFC-680A-4ED7-B654-0E0FF1B76715}"/>
+                <a16:creationId xmlns:a16="http://schemas.microsoft.com/office/drawing/2014/main" id="{8B8127A3-0CB8-4ECA-AAD1-5D5C7FE20989}"/>
               </a:ext>
             </a:extLst>
           </p:cNvPr>
@@ -36430,7 +36550,7 @@
           <p:cNvPr id="121" name="">
             <a:extLst xmlns:a="http://schemas.openxmlformats.org/drawingml/2006/main">
               <a:ext uri="{FF2B5EF4-FFF2-40B4-BE49-F238E27FC236}">
-                <a16:creationId xmlns:a16="http://schemas.microsoft.com/office/drawing/2014/main" id="{D4E2E49E-43A3-4331-818B-A89B369568F1}"/>
+                <a16:creationId xmlns:a16="http://schemas.microsoft.com/office/drawing/2014/main" id="{40E8F94A-D3EB-4F23-9BF9-F86B3D5276A6}"/>
               </a:ext>
             </a:extLst>
           </p:cNvPr>
@@ -36497,7 +36617,7 @@
           <p:cNvPr id="122" name="">
             <a:extLst xmlns:a="http://schemas.openxmlformats.org/drawingml/2006/main">
               <a:ext uri="{FF2B5EF4-FFF2-40B4-BE49-F238E27FC236}">
-                <a16:creationId xmlns:a16="http://schemas.microsoft.com/office/drawing/2014/main" id="{6ECF7E94-23CC-4344-A401-08C1B59BF937}"/>
+                <a16:creationId xmlns:a16="http://schemas.microsoft.com/office/drawing/2014/main" id="{54AA50D7-D24F-435B-B675-FD0F868F1B59}"/>
               </a:ext>
             </a:extLst>
           </p:cNvPr>
@@ -36889,7 +37009,7 @@
           <p:cNvPr id="123" name="">
             <a:extLst xmlns:a="http://schemas.openxmlformats.org/drawingml/2006/main">
               <a:ext uri="{FF2B5EF4-FFF2-40B4-BE49-F238E27FC236}">
-                <a16:creationId xmlns:a16="http://schemas.microsoft.com/office/drawing/2014/main" id="{C62D0D0A-0C2C-40F8-B02C-FD51CFB42E0A}"/>
+                <a16:creationId xmlns:a16="http://schemas.microsoft.com/office/drawing/2014/main" id="{14827209-21E1-4842-927C-D4A1A4016104}"/>
               </a:ext>
             </a:extLst>
           </p:cNvPr>
@@ -36964,7 +37084,7 @@
           <p:cNvPr id="124" name="">
             <a:extLst xmlns:a="http://schemas.openxmlformats.org/drawingml/2006/main">
               <a:ext uri="{FF2B5EF4-FFF2-40B4-BE49-F238E27FC236}">
-                <a16:creationId xmlns:a16="http://schemas.microsoft.com/office/drawing/2014/main" id="{71415566-453B-4DFD-99EF-C2F5720ED1AB}"/>
+                <a16:creationId xmlns:a16="http://schemas.microsoft.com/office/drawing/2014/main" id="{7B593D54-FB77-422A-B262-F18A03539D87}"/>
               </a:ext>
             </a:extLst>
           </p:cNvPr>
@@ -37074,7 +37194,7 @@
           <p:cNvPr id="125" name="">
             <a:extLst xmlns:a="http://schemas.openxmlformats.org/drawingml/2006/main">
               <a:ext uri="{FF2B5EF4-FFF2-40B4-BE49-F238E27FC236}">
-                <a16:creationId xmlns:a16="http://schemas.microsoft.com/office/drawing/2014/main" id="{5BAA69F5-116D-4B32-AC07-F3C642D0B2D3}"/>
+                <a16:creationId xmlns:a16="http://schemas.microsoft.com/office/drawing/2014/main" id="{A7959816-73EA-49D2-BCB2-F50515F535CF}"/>
               </a:ext>
             </a:extLst>
           </p:cNvPr>
@@ -37149,7 +37269,7 @@
           <p:cNvPr id="126" name="">
             <a:extLst xmlns:a="http://schemas.openxmlformats.org/drawingml/2006/main">
               <a:ext uri="{FF2B5EF4-FFF2-40B4-BE49-F238E27FC236}">
-                <a16:creationId xmlns:a16="http://schemas.microsoft.com/office/drawing/2014/main" id="{E68C548A-13C2-4939-B3BF-BB44B61F8F32}"/>
+                <a16:creationId xmlns:a16="http://schemas.microsoft.com/office/drawing/2014/main" id="{2162145B-3F9E-40E4-9EAF-31021B17E9AA}"/>
               </a:ext>
             </a:extLst>
           </p:cNvPr>
@@ -37259,7 +37379,7 @@
           <p:cNvPr id="127" name="">
             <a:extLst xmlns:a="http://schemas.openxmlformats.org/drawingml/2006/main">
               <a:ext uri="{FF2B5EF4-FFF2-40B4-BE49-F238E27FC236}">
-                <a16:creationId xmlns:a16="http://schemas.microsoft.com/office/drawing/2014/main" id="{21F524E0-2EED-4D18-931C-220020F33DE9}"/>
+                <a16:creationId xmlns:a16="http://schemas.microsoft.com/office/drawing/2014/main" id="{FABD9BB6-4FA1-4911-B03D-BEEBE352FF93}"/>
               </a:ext>
             </a:extLst>
           </p:cNvPr>
@@ -37334,7 +37454,7 @@
           <p:cNvPr id="128" name="">
             <a:extLst xmlns:a="http://schemas.openxmlformats.org/drawingml/2006/main">
               <a:ext uri="{FF2B5EF4-FFF2-40B4-BE49-F238E27FC236}">
-                <a16:creationId xmlns:a16="http://schemas.microsoft.com/office/drawing/2014/main" id="{8B5E0EA7-381E-48B0-9DF7-DF5A40F7B7A5}"/>
+                <a16:creationId xmlns:a16="http://schemas.microsoft.com/office/drawing/2014/main" id="{C09CBB75-8392-4D1D-B1D3-189A0615B830}"/>
               </a:ext>
             </a:extLst>
           </p:cNvPr>
@@ -37444,7 +37564,7 @@
           <p:cNvPr id="129" name="">
             <a:extLst xmlns:a="http://schemas.openxmlformats.org/drawingml/2006/main">
               <a:ext uri="{FF2B5EF4-FFF2-40B4-BE49-F238E27FC236}">
-                <a16:creationId xmlns:a16="http://schemas.microsoft.com/office/drawing/2014/main" id="{DBB90792-BEF2-4906-9F4D-5CC4447462A9}"/>
+                <a16:creationId xmlns:a16="http://schemas.microsoft.com/office/drawing/2014/main" id="{6CD1CB88-1DD8-4791-932F-BC6B1B21C308}"/>
               </a:ext>
             </a:extLst>
           </p:cNvPr>
@@ -37509,7 +37629,7 @@
     </p:spTree>
     <p:extLst>
       <p:ext uri="{BB962C8B-B14F-4D97-AF65-F5344CB8AC3E}">
-        <p14:creationId xmlns:p14="http://schemas.microsoft.com/office/powerpoint/2010/main" val="2112704824"/>
+        <p14:creationId xmlns:p14="http://schemas.microsoft.com/office/powerpoint/2010/main" val="71809283"/>
       </p:ext>
     </p:extLst>
   </p:cSld>
@@ -37533,7 +37653,7 @@
           <p:cNvPr id="120" name="">
             <a:extLst xmlns:a="http://schemas.openxmlformats.org/drawingml/2006/main">
               <a:ext uri="{FF2B5EF4-FFF2-40B4-BE49-F238E27FC236}">
-                <a16:creationId xmlns:a16="http://schemas.microsoft.com/office/drawing/2014/main" id="{BD919CFC-680A-4ED7-B654-0E0FF1B76715}"/>
+                <a16:creationId xmlns:a16="http://schemas.microsoft.com/office/drawing/2014/main" id="{8B8127A3-0CB8-4ECA-AAD1-5D5C7FE20989}"/>
               </a:ext>
             </a:extLst>
           </p:cNvPr>
@@ -37587,7 +37707,7 @@
           <p:cNvPr id="121" name="">
             <a:extLst xmlns:a="http://schemas.openxmlformats.org/drawingml/2006/main">
               <a:ext uri="{FF2B5EF4-FFF2-40B4-BE49-F238E27FC236}">
-                <a16:creationId xmlns:a16="http://schemas.microsoft.com/office/drawing/2014/main" id="{D4E2E49E-43A3-4331-818B-A89B369568F1}"/>
+                <a16:creationId xmlns:a16="http://schemas.microsoft.com/office/drawing/2014/main" id="{40E8F94A-D3EB-4F23-9BF9-F86B3D5276A6}"/>
               </a:ext>
             </a:extLst>
           </p:cNvPr>
@@ -37654,7 +37774,7 @@
           <p:cNvPr id="122" name="">
             <a:extLst xmlns:a="http://schemas.openxmlformats.org/drawingml/2006/main">
               <a:ext uri="{FF2B5EF4-FFF2-40B4-BE49-F238E27FC236}">
-                <a16:creationId xmlns:a16="http://schemas.microsoft.com/office/drawing/2014/main" id="{6ECF7E94-23CC-4344-A401-08C1B59BF937}"/>
+                <a16:creationId xmlns:a16="http://schemas.microsoft.com/office/drawing/2014/main" id="{54AA50D7-D24F-435B-B675-FD0F868F1B59}"/>
               </a:ext>
             </a:extLst>
           </p:cNvPr>
@@ -38396,7 +38516,7 @@
           <p:cNvPr id="123" name="">
             <a:extLst xmlns:a="http://schemas.openxmlformats.org/drawingml/2006/main">
               <a:ext uri="{FF2B5EF4-FFF2-40B4-BE49-F238E27FC236}">
-                <a16:creationId xmlns:a16="http://schemas.microsoft.com/office/drawing/2014/main" id="{C62D0D0A-0C2C-40F8-B02C-FD51CFB42E0A}"/>
+                <a16:creationId xmlns:a16="http://schemas.microsoft.com/office/drawing/2014/main" id="{14827209-21E1-4842-927C-D4A1A4016104}"/>
               </a:ext>
             </a:extLst>
           </p:cNvPr>
@@ -38471,7 +38591,7 @@
           <p:cNvPr id="124" name="">
             <a:extLst xmlns:a="http://schemas.openxmlformats.org/drawingml/2006/main">
               <a:ext uri="{FF2B5EF4-FFF2-40B4-BE49-F238E27FC236}">
-                <a16:creationId xmlns:a16="http://schemas.microsoft.com/office/drawing/2014/main" id="{71415566-453B-4DFD-99EF-C2F5720ED1AB}"/>
+                <a16:creationId xmlns:a16="http://schemas.microsoft.com/office/drawing/2014/main" id="{7B593D54-FB77-422A-B262-F18A03539D87}"/>
               </a:ext>
             </a:extLst>
           </p:cNvPr>
@@ -38581,7 +38701,7 @@
           <p:cNvPr id="125" name="">
             <a:extLst xmlns:a="http://schemas.openxmlformats.org/drawingml/2006/main">
               <a:ext uri="{FF2B5EF4-FFF2-40B4-BE49-F238E27FC236}">
-                <a16:creationId xmlns:a16="http://schemas.microsoft.com/office/drawing/2014/main" id="{5BAA69F5-116D-4B32-AC07-F3C642D0B2D3}"/>
+                <a16:creationId xmlns:a16="http://schemas.microsoft.com/office/drawing/2014/main" id="{A7959816-73EA-49D2-BCB2-F50515F535CF}"/>
               </a:ext>
             </a:extLst>
           </p:cNvPr>
@@ -38656,7 +38776,7 @@
           <p:cNvPr id="126" name="">
             <a:extLst xmlns:a="http://schemas.openxmlformats.org/drawingml/2006/main">
               <a:ext uri="{FF2B5EF4-FFF2-40B4-BE49-F238E27FC236}">
-                <a16:creationId xmlns:a16="http://schemas.microsoft.com/office/drawing/2014/main" id="{E68C548A-13C2-4939-B3BF-BB44B61F8F32}"/>
+                <a16:creationId xmlns:a16="http://schemas.microsoft.com/office/drawing/2014/main" id="{2162145B-3F9E-40E4-9EAF-31021B17E9AA}"/>
               </a:ext>
             </a:extLst>
           </p:cNvPr>
@@ -38766,7 +38886,7 @@
           <p:cNvPr id="127" name="">
             <a:extLst xmlns:a="http://schemas.openxmlformats.org/drawingml/2006/main">
               <a:ext uri="{FF2B5EF4-FFF2-40B4-BE49-F238E27FC236}">
-                <a16:creationId xmlns:a16="http://schemas.microsoft.com/office/drawing/2014/main" id="{21F524E0-2EED-4D18-931C-220020F33DE9}"/>
+                <a16:creationId xmlns:a16="http://schemas.microsoft.com/office/drawing/2014/main" id="{FABD9BB6-4FA1-4911-B03D-BEEBE352FF93}"/>
               </a:ext>
             </a:extLst>
           </p:cNvPr>
@@ -38841,7 +38961,7 @@
           <p:cNvPr id="128" name="">
             <a:extLst xmlns:a="http://schemas.openxmlformats.org/drawingml/2006/main">
               <a:ext uri="{FF2B5EF4-FFF2-40B4-BE49-F238E27FC236}">
-                <a16:creationId xmlns:a16="http://schemas.microsoft.com/office/drawing/2014/main" id="{8B5E0EA7-381E-48B0-9DF7-DF5A40F7B7A5}"/>
+                <a16:creationId xmlns:a16="http://schemas.microsoft.com/office/drawing/2014/main" id="{C09CBB75-8392-4D1D-B1D3-189A0615B830}"/>
               </a:ext>
             </a:extLst>
           </p:cNvPr>
@@ -38951,7 +39071,7 @@
           <p:cNvPr id="129" name="">
             <a:extLst xmlns:a="http://schemas.openxmlformats.org/drawingml/2006/main">
               <a:ext uri="{FF2B5EF4-FFF2-40B4-BE49-F238E27FC236}">
-                <a16:creationId xmlns:a16="http://schemas.microsoft.com/office/drawing/2014/main" id="{DBB90792-BEF2-4906-9F4D-5CC4447462A9}"/>
+                <a16:creationId xmlns:a16="http://schemas.microsoft.com/office/drawing/2014/main" id="{6CD1CB88-1DD8-4791-932F-BC6B1B21C308}"/>
               </a:ext>
             </a:extLst>
           </p:cNvPr>
@@ -39016,7 +39136,7 @@
     </p:spTree>
     <p:extLst>
       <p:ext uri="{BB962C8B-B14F-4D97-AF65-F5344CB8AC3E}">
-        <p14:creationId xmlns:p14="http://schemas.microsoft.com/office/powerpoint/2010/main" val="2112704824"/>
+        <p14:creationId xmlns:p14="http://schemas.microsoft.com/office/powerpoint/2010/main" val="71809283"/>
       </p:ext>
     </p:extLst>
   </p:cSld>
@@ -39040,7 +39160,7 @@
           <p:cNvPr id="120" name="">
             <a:extLst xmlns:a="http://schemas.openxmlformats.org/drawingml/2006/main">
               <a:ext uri="{FF2B5EF4-FFF2-40B4-BE49-F238E27FC236}">
-                <a16:creationId xmlns:a16="http://schemas.microsoft.com/office/drawing/2014/main" id="{BD919CFC-680A-4ED7-B654-0E0FF1B76715}"/>
+                <a16:creationId xmlns:a16="http://schemas.microsoft.com/office/drawing/2014/main" id="{8B8127A3-0CB8-4ECA-AAD1-5D5C7FE20989}"/>
               </a:ext>
             </a:extLst>
           </p:cNvPr>
@@ -39094,7 +39214,7 @@
           <p:cNvPr id="121" name="">
             <a:extLst xmlns:a="http://schemas.openxmlformats.org/drawingml/2006/main">
               <a:ext uri="{FF2B5EF4-FFF2-40B4-BE49-F238E27FC236}">
-                <a16:creationId xmlns:a16="http://schemas.microsoft.com/office/drawing/2014/main" id="{D4E2E49E-43A3-4331-818B-A89B369568F1}"/>
+                <a16:creationId xmlns:a16="http://schemas.microsoft.com/office/drawing/2014/main" id="{40E8F94A-D3EB-4F23-9BF9-F86B3D5276A6}"/>
               </a:ext>
             </a:extLst>
           </p:cNvPr>
@@ -39161,7 +39281,7 @@
           <p:cNvPr id="122" name="">
             <a:extLst xmlns:a="http://schemas.openxmlformats.org/drawingml/2006/main">
               <a:ext uri="{FF2B5EF4-FFF2-40B4-BE49-F238E27FC236}">
-                <a16:creationId xmlns:a16="http://schemas.microsoft.com/office/drawing/2014/main" id="{6ECF7E94-23CC-4344-A401-08C1B59BF937}"/>
+                <a16:creationId xmlns:a16="http://schemas.microsoft.com/office/drawing/2014/main" id="{54AA50D7-D24F-435B-B675-FD0F868F1B59}"/>
               </a:ext>
             </a:extLst>
           </p:cNvPr>
@@ -39413,7 +39533,7 @@
           <p:cNvPr id="123" name="">
             <a:extLst xmlns:a="http://schemas.openxmlformats.org/drawingml/2006/main">
               <a:ext uri="{FF2B5EF4-FFF2-40B4-BE49-F238E27FC236}">
-                <a16:creationId xmlns:a16="http://schemas.microsoft.com/office/drawing/2014/main" id="{C62D0D0A-0C2C-40F8-B02C-FD51CFB42E0A}"/>
+                <a16:creationId xmlns:a16="http://schemas.microsoft.com/office/drawing/2014/main" id="{14827209-21E1-4842-927C-D4A1A4016104}"/>
               </a:ext>
             </a:extLst>
           </p:cNvPr>
@@ -39488,7 +39608,7 @@
           <p:cNvPr id="124" name="">
             <a:extLst xmlns:a="http://schemas.openxmlformats.org/drawingml/2006/main">
               <a:ext uri="{FF2B5EF4-FFF2-40B4-BE49-F238E27FC236}">
-                <a16:creationId xmlns:a16="http://schemas.microsoft.com/office/drawing/2014/main" id="{71415566-453B-4DFD-99EF-C2F5720ED1AB}"/>
+                <a16:creationId xmlns:a16="http://schemas.microsoft.com/office/drawing/2014/main" id="{7B593D54-FB77-422A-B262-F18A03539D87}"/>
               </a:ext>
             </a:extLst>
           </p:cNvPr>
@@ -39598,7 +39718,7 @@
           <p:cNvPr id="125" name="">
             <a:extLst xmlns:a="http://schemas.openxmlformats.org/drawingml/2006/main">
               <a:ext uri="{FF2B5EF4-FFF2-40B4-BE49-F238E27FC236}">
-                <a16:creationId xmlns:a16="http://schemas.microsoft.com/office/drawing/2014/main" id="{5BAA69F5-116D-4B32-AC07-F3C642D0B2D3}"/>
+                <a16:creationId xmlns:a16="http://schemas.microsoft.com/office/drawing/2014/main" id="{A7959816-73EA-49D2-BCB2-F50515F535CF}"/>
               </a:ext>
             </a:extLst>
           </p:cNvPr>
@@ -39673,7 +39793,7 @@
           <p:cNvPr id="126" name="">
             <a:extLst xmlns:a="http://schemas.openxmlformats.org/drawingml/2006/main">
               <a:ext uri="{FF2B5EF4-FFF2-40B4-BE49-F238E27FC236}">
-                <a16:creationId xmlns:a16="http://schemas.microsoft.com/office/drawing/2014/main" id="{E68C548A-13C2-4939-B3BF-BB44B61F8F32}"/>
+                <a16:creationId xmlns:a16="http://schemas.microsoft.com/office/drawing/2014/main" id="{2162145B-3F9E-40E4-9EAF-31021B17E9AA}"/>
               </a:ext>
             </a:extLst>
           </p:cNvPr>
@@ -39783,7 +39903,7 @@
           <p:cNvPr id="127" name="">
             <a:extLst xmlns:a="http://schemas.openxmlformats.org/drawingml/2006/main">
               <a:ext uri="{FF2B5EF4-FFF2-40B4-BE49-F238E27FC236}">
-                <a16:creationId xmlns:a16="http://schemas.microsoft.com/office/drawing/2014/main" id="{21F524E0-2EED-4D18-931C-220020F33DE9}"/>
+                <a16:creationId xmlns:a16="http://schemas.microsoft.com/office/drawing/2014/main" id="{FABD9BB6-4FA1-4911-B03D-BEEBE352FF93}"/>
               </a:ext>
             </a:extLst>
           </p:cNvPr>
@@ -39858,7 +39978,7 @@
           <p:cNvPr id="128" name="">
             <a:extLst xmlns:a="http://schemas.openxmlformats.org/drawingml/2006/main">
               <a:ext uri="{FF2B5EF4-FFF2-40B4-BE49-F238E27FC236}">
-                <a16:creationId xmlns:a16="http://schemas.microsoft.com/office/drawing/2014/main" id="{8B5E0EA7-381E-48B0-9DF7-DF5A40F7B7A5}"/>
+                <a16:creationId xmlns:a16="http://schemas.microsoft.com/office/drawing/2014/main" id="{C09CBB75-8392-4D1D-B1D3-189A0615B830}"/>
               </a:ext>
             </a:extLst>
           </p:cNvPr>
@@ -39968,7 +40088,7 @@
           <p:cNvPr id="129" name="">
             <a:extLst xmlns:a="http://schemas.openxmlformats.org/drawingml/2006/main">
               <a:ext uri="{FF2B5EF4-FFF2-40B4-BE49-F238E27FC236}">
-                <a16:creationId xmlns:a16="http://schemas.microsoft.com/office/drawing/2014/main" id="{DBB90792-BEF2-4906-9F4D-5CC4447462A9}"/>
+                <a16:creationId xmlns:a16="http://schemas.microsoft.com/office/drawing/2014/main" id="{6CD1CB88-1DD8-4791-932F-BC6B1B21C308}"/>
               </a:ext>
             </a:extLst>
           </p:cNvPr>
@@ -40033,7 +40153,7 @@
     </p:spTree>
     <p:extLst>
       <p:ext uri="{BB962C8B-B14F-4D97-AF65-F5344CB8AC3E}">
-        <p14:creationId xmlns:p14="http://schemas.microsoft.com/office/powerpoint/2010/main" val="2112704824"/>
+        <p14:creationId xmlns:p14="http://schemas.microsoft.com/office/powerpoint/2010/main" val="71809283"/>
       </p:ext>
     </p:extLst>
   </p:cSld>
@@ -40064,7 +40184,7 @@
           <p:cNvPr id="26" name="">
             <a:extLst xmlns:a="http://schemas.openxmlformats.org/drawingml/2006/main">
               <a:ext uri="{FF2B5EF4-FFF2-40B4-BE49-F238E27FC236}">
-                <a16:creationId xmlns:a16="http://schemas.microsoft.com/office/drawing/2014/main" id="{CA0DC302-95CB-4BAD-AE2A-FCD32EEDDE73}"/>
+                <a16:creationId xmlns:a16="http://schemas.microsoft.com/office/drawing/2014/main" id="{1C5FD675-F338-4922-A4E9-88624148F862}"/>
               </a:ext>
             </a:extLst>
           </p:cNvPr>
@@ -40117,7 +40237,7 @@
           <p:cNvPr id="27" name="">
             <a:extLst xmlns:a="http://schemas.openxmlformats.org/drawingml/2006/main">
               <a:ext uri="{FF2B5EF4-FFF2-40B4-BE49-F238E27FC236}">
-                <a16:creationId xmlns:a16="http://schemas.microsoft.com/office/drawing/2014/main" id="{37E02159-8A9B-46C9-90D2-DA6DD62FD5A0}"/>
+                <a16:creationId xmlns:a16="http://schemas.microsoft.com/office/drawing/2014/main" id="{E235729A-8179-455E-AE97-E7669A11C106}"/>
               </a:ext>
             </a:extLst>
           </p:cNvPr>
@@ -40211,7 +40331,7 @@
           <p:cNvPr id="28" name="">
             <a:extLst xmlns:a="http://schemas.openxmlformats.org/drawingml/2006/main">
               <a:ext uri="{FF2B5EF4-FFF2-40B4-BE49-F238E27FC236}">
-                <a16:creationId xmlns:a16="http://schemas.microsoft.com/office/drawing/2014/main" id="{2F73CF55-F52D-48D6-B78A-5492562654B2}"/>
+                <a16:creationId xmlns:a16="http://schemas.microsoft.com/office/drawing/2014/main" id="{EDA8B2AE-A3AB-4B1C-8765-24524BE82A9E}"/>
               </a:ext>
             </a:extLst>
           </p:cNvPr>
@@ -40264,7 +40384,7 @@
           <p:cNvPr id="29" name="">
             <a:extLst xmlns:a="http://schemas.openxmlformats.org/drawingml/2006/main">
               <a:ext uri="{FF2B5EF4-FFF2-40B4-BE49-F238E27FC236}">
-                <a16:creationId xmlns:a16="http://schemas.microsoft.com/office/drawing/2014/main" id="{61BEA18A-3BE7-43A1-A769-B23089910F68}"/>
+                <a16:creationId xmlns:a16="http://schemas.microsoft.com/office/drawing/2014/main" id="{756C492C-5C59-4A26-B631-0520249CAC37}"/>
               </a:ext>
             </a:extLst>
           </p:cNvPr>
@@ -40329,7 +40449,7 @@
     </p:spTree>
     <p:extLst>
       <p:ext uri="{BB962C8B-B14F-4D97-AF65-F5344CB8AC3E}">
-        <p14:creationId xmlns:p14="http://schemas.microsoft.com/office/powerpoint/2010/main" val="1242354970"/>
+        <p14:creationId xmlns:p14="http://schemas.microsoft.com/office/powerpoint/2010/main" val="402919761"/>
       </p:ext>
     </p:extLst>
   </p:cSld>
@@ -40353,7 +40473,7 @@
           <p:cNvPr id="18" name="">
             <a:extLst xmlns:a="http://schemas.openxmlformats.org/drawingml/2006/main">
               <a:ext uri="{FF2B5EF4-FFF2-40B4-BE49-F238E27FC236}">
-                <a16:creationId xmlns:a16="http://schemas.microsoft.com/office/drawing/2014/main" id="{DB3468CF-76F2-433C-933D-C68C5A750ED4}"/>
+                <a16:creationId xmlns:a16="http://schemas.microsoft.com/office/drawing/2014/main" id="{48F7A261-E298-43B3-B7BE-2BC96C8FFFFE}"/>
               </a:ext>
             </a:extLst>
           </p:cNvPr>
@@ -40420,7 +40540,7 @@
           <p:cNvPr id="19" name="">
             <a:extLst xmlns:a="http://schemas.openxmlformats.org/drawingml/2006/main">
               <a:ext uri="{FF2B5EF4-FFF2-40B4-BE49-F238E27FC236}">
-                <a16:creationId xmlns:a16="http://schemas.microsoft.com/office/drawing/2014/main" id="{5BB074AA-DC89-43AB-B7D9-3ED093C9EC11}"/>
+                <a16:creationId xmlns:a16="http://schemas.microsoft.com/office/drawing/2014/main" id="{1A3B046C-F112-4063-9FD4-F3C5D2405852}"/>
               </a:ext>
             </a:extLst>
           </p:cNvPr>
@@ -40474,7 +40594,7 @@
           <p:cNvPr id="20" name="">
             <a:extLst xmlns:a="http://schemas.openxmlformats.org/drawingml/2006/main">
               <a:ext uri="{FF2B5EF4-FFF2-40B4-BE49-F238E27FC236}">
-                <a16:creationId xmlns:a16="http://schemas.microsoft.com/office/drawing/2014/main" id="{E60F0BB6-4136-4B6E-A0B9-09FB881DA509}"/>
+                <a16:creationId xmlns:a16="http://schemas.microsoft.com/office/drawing/2014/main" id="{338CD07F-42F7-4855-AA4C-4C684D7A5989}"/>
               </a:ext>
             </a:extLst>
           </p:cNvPr>
@@ -40541,7 +40661,7 @@
           <p:cNvPr id="21" name="">
             <a:extLst xmlns:a="http://schemas.openxmlformats.org/drawingml/2006/main">
               <a:ext uri="{FF2B5EF4-FFF2-40B4-BE49-F238E27FC236}">
-                <a16:creationId xmlns:a16="http://schemas.microsoft.com/office/drawing/2014/main" id="{590E161F-0F0C-40D8-B968-0AADECF44A12}"/>
+                <a16:creationId xmlns:a16="http://schemas.microsoft.com/office/drawing/2014/main" id="{AF6ABAC4-816A-4305-91CF-0EAB70AFC761}"/>
               </a:ext>
             </a:extLst>
           </p:cNvPr>
@@ -40608,7 +40728,7 @@
           <p:cNvPr id="22" name="">
             <a:extLst xmlns:a="http://schemas.openxmlformats.org/drawingml/2006/main">
               <a:ext uri="{FF2B5EF4-FFF2-40B4-BE49-F238E27FC236}">
-                <a16:creationId xmlns:a16="http://schemas.microsoft.com/office/drawing/2014/main" id="{A66EF35C-267A-4A2D-982E-8D307FBEF297}"/>
+                <a16:creationId xmlns:a16="http://schemas.microsoft.com/office/drawing/2014/main" id="{58F5FDB8-1994-442F-92B9-A2DCEF70836D}"/>
               </a:ext>
             </a:extLst>
           </p:cNvPr>
@@ -40675,7 +40795,7 @@
           <p:cNvPr id="23" name="">
             <a:extLst xmlns:a="http://schemas.openxmlformats.org/drawingml/2006/main">
               <a:ext uri="{FF2B5EF4-FFF2-40B4-BE49-F238E27FC236}">
-                <a16:creationId xmlns:a16="http://schemas.microsoft.com/office/drawing/2014/main" id="{AE372E29-AE30-4906-8909-70720AC41F24}"/>
+                <a16:creationId xmlns:a16="http://schemas.microsoft.com/office/drawing/2014/main" id="{6543A099-3097-47CB-A71E-15F350A5A379}"/>
               </a:ext>
             </a:extLst>
           </p:cNvPr>
@@ -40742,7 +40862,7 @@
           <p:cNvPr id="24" name="">
             <a:extLst xmlns:a="http://schemas.openxmlformats.org/drawingml/2006/main">
               <a:ext uri="{FF2B5EF4-FFF2-40B4-BE49-F238E27FC236}">
-                <a16:creationId xmlns:a16="http://schemas.microsoft.com/office/drawing/2014/main" id="{AC6163D7-4642-470C-A375-0AFEF395E5AC}"/>
+                <a16:creationId xmlns:a16="http://schemas.microsoft.com/office/drawing/2014/main" id="{30CFD0DA-D46C-4C74-98F5-C6480075FDB8}"/>
               </a:ext>
             </a:extLst>
           </p:cNvPr>
@@ -40809,7 +40929,7 @@
           <p:cNvPr id="25" name="">
             <a:extLst xmlns:a="http://schemas.openxmlformats.org/drawingml/2006/main">
               <a:ext uri="{FF2B5EF4-FFF2-40B4-BE49-F238E27FC236}">
-                <a16:creationId xmlns:a16="http://schemas.microsoft.com/office/drawing/2014/main" id="{92A3EAD1-7BBD-4822-83AF-20329F2A57B0}"/>
+                <a16:creationId xmlns:a16="http://schemas.microsoft.com/office/drawing/2014/main" id="{7CA8B79F-14CD-490E-B34C-64DBAAF84715}"/>
               </a:ext>
             </a:extLst>
           </p:cNvPr>
@@ -40874,7 +40994,7 @@
     </p:spTree>
     <p:extLst>
       <p:ext uri="{BB962C8B-B14F-4D97-AF65-F5344CB8AC3E}">
-        <p14:creationId xmlns:p14="http://schemas.microsoft.com/office/powerpoint/2010/main" val="757323168"/>
+        <p14:creationId xmlns:p14="http://schemas.microsoft.com/office/powerpoint/2010/main" val="1340780982"/>
       </p:ext>
     </p:extLst>
   </p:cSld>
@@ -40898,7 +41018,7 @@
           <p:cNvPr id="18" name="">
             <a:extLst xmlns:a="http://schemas.openxmlformats.org/drawingml/2006/main">
               <a:ext uri="{FF2B5EF4-FFF2-40B4-BE49-F238E27FC236}">
-                <a16:creationId xmlns:a16="http://schemas.microsoft.com/office/drawing/2014/main" id="{DB3468CF-76F2-433C-933D-C68C5A750ED4}"/>
+                <a16:creationId xmlns:a16="http://schemas.microsoft.com/office/drawing/2014/main" id="{48F7A261-E298-43B3-B7BE-2BC96C8FFFFE}"/>
               </a:ext>
             </a:extLst>
           </p:cNvPr>
@@ -40965,7 +41085,7 @@
           <p:cNvPr id="19" name="">
             <a:extLst xmlns:a="http://schemas.openxmlformats.org/drawingml/2006/main">
               <a:ext uri="{FF2B5EF4-FFF2-40B4-BE49-F238E27FC236}">
-                <a16:creationId xmlns:a16="http://schemas.microsoft.com/office/drawing/2014/main" id="{5BB074AA-DC89-43AB-B7D9-3ED093C9EC11}"/>
+                <a16:creationId xmlns:a16="http://schemas.microsoft.com/office/drawing/2014/main" id="{1A3B046C-F112-4063-9FD4-F3C5D2405852}"/>
               </a:ext>
             </a:extLst>
           </p:cNvPr>
@@ -41019,7 +41139,7 @@
           <p:cNvPr id="20" name="">
             <a:extLst xmlns:a="http://schemas.openxmlformats.org/drawingml/2006/main">
               <a:ext uri="{FF2B5EF4-FFF2-40B4-BE49-F238E27FC236}">
-                <a16:creationId xmlns:a16="http://schemas.microsoft.com/office/drawing/2014/main" id="{E60F0BB6-4136-4B6E-A0B9-09FB881DA509}"/>
+                <a16:creationId xmlns:a16="http://schemas.microsoft.com/office/drawing/2014/main" id="{338CD07F-42F7-4855-AA4C-4C684D7A5989}"/>
               </a:ext>
             </a:extLst>
           </p:cNvPr>
@@ -41086,7 +41206,7 @@
           <p:cNvPr id="21" name="">
             <a:extLst xmlns:a="http://schemas.openxmlformats.org/drawingml/2006/main">
               <a:ext uri="{FF2B5EF4-FFF2-40B4-BE49-F238E27FC236}">
-                <a16:creationId xmlns:a16="http://schemas.microsoft.com/office/drawing/2014/main" id="{590E161F-0F0C-40D8-B968-0AADECF44A12}"/>
+                <a16:creationId xmlns:a16="http://schemas.microsoft.com/office/drawing/2014/main" id="{AF6ABAC4-816A-4305-91CF-0EAB70AFC761}"/>
               </a:ext>
             </a:extLst>
           </p:cNvPr>
@@ -41153,7 +41273,7 @@
           <p:cNvPr id="22" name="">
             <a:extLst xmlns:a="http://schemas.openxmlformats.org/drawingml/2006/main">
               <a:ext uri="{FF2B5EF4-FFF2-40B4-BE49-F238E27FC236}">
-                <a16:creationId xmlns:a16="http://schemas.microsoft.com/office/drawing/2014/main" id="{A66EF35C-267A-4A2D-982E-8D307FBEF297}"/>
+                <a16:creationId xmlns:a16="http://schemas.microsoft.com/office/drawing/2014/main" id="{58F5FDB8-1994-442F-92B9-A2DCEF70836D}"/>
               </a:ext>
             </a:extLst>
           </p:cNvPr>
@@ -41220,7 +41340,7 @@
           <p:cNvPr id="23" name="">
             <a:extLst xmlns:a="http://schemas.openxmlformats.org/drawingml/2006/main">
               <a:ext uri="{FF2B5EF4-FFF2-40B4-BE49-F238E27FC236}">
-                <a16:creationId xmlns:a16="http://schemas.microsoft.com/office/drawing/2014/main" id="{AE372E29-AE30-4906-8909-70720AC41F24}"/>
+                <a16:creationId xmlns:a16="http://schemas.microsoft.com/office/drawing/2014/main" id="{6543A099-3097-47CB-A71E-15F350A5A379}"/>
               </a:ext>
             </a:extLst>
           </p:cNvPr>
@@ -41287,7 +41407,7 @@
           <p:cNvPr id="24" name="">
             <a:extLst xmlns:a="http://schemas.openxmlformats.org/drawingml/2006/main">
               <a:ext uri="{FF2B5EF4-FFF2-40B4-BE49-F238E27FC236}">
-                <a16:creationId xmlns:a16="http://schemas.microsoft.com/office/drawing/2014/main" id="{AC6163D7-4642-470C-A375-0AFEF395E5AC}"/>
+                <a16:creationId xmlns:a16="http://schemas.microsoft.com/office/drawing/2014/main" id="{30CFD0DA-D46C-4C74-98F5-C6480075FDB8}"/>
               </a:ext>
             </a:extLst>
           </p:cNvPr>
@@ -41354,7 +41474,7 @@
           <p:cNvPr id="25" name="">
             <a:extLst xmlns:a="http://schemas.openxmlformats.org/drawingml/2006/main">
               <a:ext uri="{FF2B5EF4-FFF2-40B4-BE49-F238E27FC236}">
-                <a16:creationId xmlns:a16="http://schemas.microsoft.com/office/drawing/2014/main" id="{92A3EAD1-7BBD-4822-83AF-20329F2A57B0}"/>
+                <a16:creationId xmlns:a16="http://schemas.microsoft.com/office/drawing/2014/main" id="{7CA8B79F-14CD-490E-B34C-64DBAAF84715}"/>
               </a:ext>
             </a:extLst>
           </p:cNvPr>
@@ -41419,7 +41539,7 @@
     </p:spTree>
     <p:extLst>
       <p:ext uri="{BB962C8B-B14F-4D97-AF65-F5344CB8AC3E}">
-        <p14:creationId xmlns:p14="http://schemas.microsoft.com/office/powerpoint/2010/main" val="757323168"/>
+        <p14:creationId xmlns:p14="http://schemas.microsoft.com/office/powerpoint/2010/main" val="1340780982"/>
       </p:ext>
     </p:extLst>
   </p:cSld>
@@ -41443,7 +41563,7 @@
           <p:cNvPr id="18" name="">
             <a:extLst xmlns:a="http://schemas.openxmlformats.org/drawingml/2006/main">
               <a:ext uri="{FF2B5EF4-FFF2-40B4-BE49-F238E27FC236}">
-                <a16:creationId xmlns:a16="http://schemas.microsoft.com/office/drawing/2014/main" id="{DB3468CF-76F2-433C-933D-C68C5A750ED4}"/>
+                <a16:creationId xmlns:a16="http://schemas.microsoft.com/office/drawing/2014/main" id="{48F7A261-E298-43B3-B7BE-2BC96C8FFFFE}"/>
               </a:ext>
             </a:extLst>
           </p:cNvPr>
@@ -41510,7 +41630,7 @@
           <p:cNvPr id="19" name="">
             <a:extLst xmlns:a="http://schemas.openxmlformats.org/drawingml/2006/main">
               <a:ext uri="{FF2B5EF4-FFF2-40B4-BE49-F238E27FC236}">
-                <a16:creationId xmlns:a16="http://schemas.microsoft.com/office/drawing/2014/main" id="{5BB074AA-DC89-43AB-B7D9-3ED093C9EC11}"/>
+                <a16:creationId xmlns:a16="http://schemas.microsoft.com/office/drawing/2014/main" id="{1A3B046C-F112-4063-9FD4-F3C5D2405852}"/>
               </a:ext>
             </a:extLst>
           </p:cNvPr>
@@ -41564,7 +41684,7 @@
           <p:cNvPr id="20" name="">
             <a:extLst xmlns:a="http://schemas.openxmlformats.org/drawingml/2006/main">
               <a:ext uri="{FF2B5EF4-FFF2-40B4-BE49-F238E27FC236}">
-                <a16:creationId xmlns:a16="http://schemas.microsoft.com/office/drawing/2014/main" id="{E60F0BB6-4136-4B6E-A0B9-09FB881DA509}"/>
+                <a16:creationId xmlns:a16="http://schemas.microsoft.com/office/drawing/2014/main" id="{338CD07F-42F7-4855-AA4C-4C684D7A5989}"/>
               </a:ext>
             </a:extLst>
           </p:cNvPr>
@@ -41631,7 +41751,7 @@
           <p:cNvPr id="21" name="">
             <a:extLst xmlns:a="http://schemas.openxmlformats.org/drawingml/2006/main">
               <a:ext uri="{FF2B5EF4-FFF2-40B4-BE49-F238E27FC236}">
-                <a16:creationId xmlns:a16="http://schemas.microsoft.com/office/drawing/2014/main" id="{590E161F-0F0C-40D8-B968-0AADECF44A12}"/>
+                <a16:creationId xmlns:a16="http://schemas.microsoft.com/office/drawing/2014/main" id="{AF6ABAC4-816A-4305-91CF-0EAB70AFC761}"/>
               </a:ext>
             </a:extLst>
           </p:cNvPr>
@@ -41698,7 +41818,7 @@
           <p:cNvPr id="22" name="">
             <a:extLst xmlns:a="http://schemas.openxmlformats.org/drawingml/2006/main">
               <a:ext uri="{FF2B5EF4-FFF2-40B4-BE49-F238E27FC236}">
-                <a16:creationId xmlns:a16="http://schemas.microsoft.com/office/drawing/2014/main" id="{A66EF35C-267A-4A2D-982E-8D307FBEF297}"/>
+                <a16:creationId xmlns:a16="http://schemas.microsoft.com/office/drawing/2014/main" id="{58F5FDB8-1994-442F-92B9-A2DCEF70836D}"/>
               </a:ext>
             </a:extLst>
           </p:cNvPr>
@@ -41765,7 +41885,7 @@
           <p:cNvPr id="23" name="">
             <a:extLst xmlns:a="http://schemas.openxmlformats.org/drawingml/2006/main">
               <a:ext uri="{FF2B5EF4-FFF2-40B4-BE49-F238E27FC236}">
-                <a16:creationId xmlns:a16="http://schemas.microsoft.com/office/drawing/2014/main" id="{AE372E29-AE30-4906-8909-70720AC41F24}"/>
+                <a16:creationId xmlns:a16="http://schemas.microsoft.com/office/drawing/2014/main" id="{6543A099-3097-47CB-A71E-15F350A5A379}"/>
               </a:ext>
             </a:extLst>
           </p:cNvPr>
@@ -41832,7 +41952,7 @@
           <p:cNvPr id="24" name="">
             <a:extLst xmlns:a="http://schemas.openxmlformats.org/drawingml/2006/main">
               <a:ext uri="{FF2B5EF4-FFF2-40B4-BE49-F238E27FC236}">
-                <a16:creationId xmlns:a16="http://schemas.microsoft.com/office/drawing/2014/main" id="{AC6163D7-4642-470C-A375-0AFEF395E5AC}"/>
+                <a16:creationId xmlns:a16="http://schemas.microsoft.com/office/drawing/2014/main" id="{30CFD0DA-D46C-4C74-98F5-C6480075FDB8}"/>
               </a:ext>
             </a:extLst>
           </p:cNvPr>
@@ -41899,7 +42019,7 @@
           <p:cNvPr id="25" name="">
             <a:extLst xmlns:a="http://schemas.openxmlformats.org/drawingml/2006/main">
               <a:ext uri="{FF2B5EF4-FFF2-40B4-BE49-F238E27FC236}">
-                <a16:creationId xmlns:a16="http://schemas.microsoft.com/office/drawing/2014/main" id="{92A3EAD1-7BBD-4822-83AF-20329F2A57B0}"/>
+                <a16:creationId xmlns:a16="http://schemas.microsoft.com/office/drawing/2014/main" id="{7CA8B79F-14CD-490E-B34C-64DBAAF84715}"/>
               </a:ext>
             </a:extLst>
           </p:cNvPr>
@@ -41964,14 +42084,14 @@
     </p:spTree>
     <p:extLst>
       <p:ext uri="{BB962C8B-B14F-4D97-AF65-F5344CB8AC3E}">
-        <p14:creationId xmlns:p14="http://schemas.microsoft.com/office/powerpoint/2010/main" val="757323168"/>
+        <p14:creationId xmlns:p14="http://schemas.microsoft.com/office/powerpoint/2010/main" val="1340780982"/>
       </p:ext>
     </p:extLst>
   </p:cSld>
 </p:sld>
 </file>
 
-<file path=ppt/slides/slide4.xml><?xml version="1.0" encoding="utf-8"?>
+<file path=ppt/slides/slide33.xml><?xml version="1.0" encoding="utf-8"?>
 <p:sld xmlns:p="http://schemas.openxmlformats.org/presentationml/2006/main">
   <p:cSld>
     <p:spTree>
@@ -41985,10 +42105,77 @@
       </p:grpSpPr>
       <p:sp>
         <p:nvSpPr>
-          <p:cNvPr id="120" name="">
+          <p:cNvPr id="18" name="">
             <a:extLst xmlns:a="http://schemas.openxmlformats.org/drawingml/2006/main">
               <a:ext uri="{FF2B5EF4-FFF2-40B4-BE49-F238E27FC236}">
-                <a16:creationId xmlns:a16="http://schemas.microsoft.com/office/drawing/2014/main" id="{BD919CFC-680A-4ED7-B654-0E0FF1B76715}"/>
+                <a16:creationId xmlns:a16="http://schemas.microsoft.com/office/drawing/2014/main" id="{48F7A261-E298-43B3-B7BE-2BC96C8FFFFE}"/>
+              </a:ext>
+            </a:extLst>
+          </p:cNvPr>
+          <p:cNvSpPr>
+            <a:spLocks xmlns:a="http://schemas.openxmlformats.org/drawingml/2006/main" noGrp="1"/>
+          </p:cNvSpPr>
+          <p:nvPr/>
+        </p:nvSpPr>
+        <p:spPr>
+          <a:xfrm xmlns:a="http://schemas.openxmlformats.org/drawingml/2006/main">
+            <a:off x="609480" y="781200"/>
+            <a:ext cx="10972440" cy="618840"/>
+          </a:xfrm>
+          <a:prstGeom xmlns:a="http://schemas.openxmlformats.org/drawingml/2006/main" prst="rect">
+            <a:avLst/>
+          </a:prstGeom>
+          <a:noFill xmlns:a="http://schemas.openxmlformats.org/drawingml/2006/main"/>
+          <a:ln xmlns:a="http://schemas.openxmlformats.org/drawingml/2006/main" w="0">
+            <a:noFill/>
+          </a:ln>
+        </p:spPr>
+        <p:style>
+          <a:lnRef xmlns:a="http://schemas.openxmlformats.org/drawingml/2006/main" idx="0"/>
+          <a:fillRef xmlns:a="http://schemas.openxmlformats.org/drawingml/2006/main" idx="0"/>
+          <a:effectRef xmlns:a="http://schemas.openxmlformats.org/drawingml/2006/main" idx="0"/>
+          <a:fontRef xmlns:a="http://schemas.openxmlformats.org/drawingml/2006/main" idx="minor"/>
+        </p:style>
+        <p:txBody>
+          <a:bodyPr xmlns:a="http://schemas.openxmlformats.org/drawingml/2006/main" lIns="0" tIns="0" rIns="0" bIns="0" anchor="t">
+            <a:noAutofit/>
+          </a:bodyPr>
+          <a:lstStyle xmlns:a="http://schemas.openxmlformats.org/drawingml/2006/main"/>
+          <a:p xmlns:a="http://schemas.openxmlformats.org/drawingml/2006/main">
+            <a:pPr>
+              <a:lnSpc>
+                <a:spcPct val="130000"/>
+              </a:lnSpc>
+              <a:buNone/>
+            </a:pPr>
+            <a:r>
+              <a:rPr sz="3300" b="1" u="none">
+                <a:solidFill>
+                  <a:srgbClr val="111111"/>
+                </a:solidFill>
+                <a:latin typeface="Noto Sans CJK KR"/>
+                <a:ea typeface="Noto Sans CJK KR"/>
+                <a:cs typeface="Noto Sans CJK KR"/>
+              </a:rPr>
+              <a:t>시간 함수의 위치 · kernel.org</a:t>
+            </a:r>
+            <a:endParaRPr sz="3300" b="0" u="none">
+              <a:solidFill>
+                <a:srgbClr val="000000"/>
+              </a:solidFill>
+              <a:latin typeface="Arial"/>
+              <a:ea typeface="Arial"/>
+              <a:cs typeface="Arial"/>
+            </a:endParaRPr>
+          </a:p>
+        </p:txBody>
+      </p:sp>
+      <p:sp>
+        <p:nvSpPr>
+          <p:cNvPr id="19" name="">
+            <a:extLst xmlns:a="http://schemas.openxmlformats.org/drawingml/2006/main">
+              <a:ext uri="{FF2B5EF4-FFF2-40B4-BE49-F238E27FC236}">
+                <a16:creationId xmlns:a16="http://schemas.microsoft.com/office/drawing/2014/main" id="{1A3B046C-F112-4063-9FD4-F3C5D2405852}"/>
               </a:ext>
             </a:extLst>
           </p:cNvPr>
@@ -42039,10 +42226,488 @@
       </p:sp>
       <p:sp>
         <p:nvSpPr>
+          <p:cNvPr id="20" name="">
+            <a:extLst xmlns:a="http://schemas.openxmlformats.org/drawingml/2006/main">
+              <a:ext uri="{FF2B5EF4-FFF2-40B4-BE49-F238E27FC236}">
+                <a16:creationId xmlns:a16="http://schemas.microsoft.com/office/drawing/2014/main" id="{338CD07F-42F7-4855-AA4C-4C684D7A5989}"/>
+              </a:ext>
+            </a:extLst>
+          </p:cNvPr>
+          <p:cNvSpPr>
+            <a:spLocks xmlns:a="http://schemas.openxmlformats.org/drawingml/2006/main" noGrp="1"/>
+          </p:cNvSpPr>
+          <p:nvPr/>
+        </p:nvSpPr>
+        <p:spPr>
+          <a:xfrm xmlns:a="http://schemas.openxmlformats.org/drawingml/2006/main">
+            <a:off x="630000" y="1764000"/>
+            <a:ext cx="10908000" cy="565560"/>
+          </a:xfrm>
+          <a:prstGeom xmlns:a="http://schemas.openxmlformats.org/drawingml/2006/main" prst="rect">
+            <a:avLst/>
+          </a:prstGeom>
+          <a:noFill xmlns:a="http://schemas.openxmlformats.org/drawingml/2006/main"/>
+          <a:ln xmlns:a="http://schemas.openxmlformats.org/drawingml/2006/main" w="38160">
+            <a:noFill/>
+          </a:ln>
+        </p:spPr>
+        <p:style>
+          <a:lnRef xmlns:a="http://schemas.openxmlformats.org/drawingml/2006/main" idx="0"/>
+          <a:fillRef xmlns:a="http://schemas.openxmlformats.org/drawingml/2006/main" idx="0"/>
+          <a:effectRef xmlns:a="http://schemas.openxmlformats.org/drawingml/2006/main" idx="0"/>
+          <a:fontRef xmlns:a="http://schemas.openxmlformats.org/drawingml/2006/main" idx="minor"/>
+        </p:style>
+        <p:txBody>
+          <a:bodyPr xmlns:a="http://schemas.openxmlformats.org/drawingml/2006/main" lIns="90000" tIns="45000" rIns="90000" bIns="45000" anchor="t">
+            <a:spAutoFit/>
+          </a:bodyPr>
+          <a:lstStyle xmlns:a="http://schemas.openxmlformats.org/drawingml/2006/main"/>
+          <a:p xmlns:a="http://schemas.openxmlformats.org/drawingml/2006/main">
+            <a:pPr>
+              <a:lnSpc>
+                <a:spcPct val="130000"/>
+              </a:lnSpc>
+              <a:buNone/>
+            </a:pPr>
+            <a:r>
+              <a:rPr sz="2400" b="0" u="none">
+                <a:solidFill>
+                  <a:srgbClr val="23384B"/>
+                </a:solidFill>
+                <a:latin typeface="Noto Sans CJK KR"/>
+                <a:ea typeface="Noto Sans CJK KR"/>
+                <a:cs typeface="Noto Sans CJK KR"/>
+              </a:rPr>
+              <a:t>달력 시각: time, localtime·gmtime, mktime, strftime, difftime.</a:t>
+            </a:r>
+            <a:endParaRPr sz="2400" b="0" u="none">
+              <a:solidFill>
+                <a:srgbClr val="000000"/>
+              </a:solidFill>
+              <a:latin typeface="Arial"/>
+              <a:ea typeface="Arial"/>
+              <a:cs typeface="Arial"/>
+            </a:endParaRPr>
+          </a:p>
+        </p:txBody>
+      </p:sp>
+      <p:sp>
+        <p:nvSpPr>
+          <p:cNvPr id="21" name="">
+            <a:extLst xmlns:a="http://schemas.openxmlformats.org/drawingml/2006/main">
+              <a:ext uri="{FF2B5EF4-FFF2-40B4-BE49-F238E27FC236}">
+                <a16:creationId xmlns:a16="http://schemas.microsoft.com/office/drawing/2014/main" id="{AF6ABAC4-816A-4305-91CF-0EAB70AFC761}"/>
+              </a:ext>
+            </a:extLst>
+          </p:cNvPr>
+          <p:cNvSpPr>
+            <a:spLocks xmlns:a="http://schemas.openxmlformats.org/drawingml/2006/main" noGrp="1"/>
+          </p:cNvSpPr>
+          <p:nvPr/>
+        </p:nvSpPr>
+        <p:spPr>
+          <a:xfrm xmlns:a="http://schemas.openxmlformats.org/drawingml/2006/main">
+            <a:off x="630000" y="2538000"/>
+            <a:ext cx="10908000" cy="565560"/>
+          </a:xfrm>
+          <a:prstGeom xmlns:a="http://schemas.openxmlformats.org/drawingml/2006/main" prst="rect">
+            <a:avLst/>
+          </a:prstGeom>
+          <a:noFill xmlns:a="http://schemas.openxmlformats.org/drawingml/2006/main"/>
+          <a:ln xmlns:a="http://schemas.openxmlformats.org/drawingml/2006/main" w="38160">
+            <a:noFill/>
+          </a:ln>
+        </p:spPr>
+        <p:style>
+          <a:lnRef xmlns:a="http://schemas.openxmlformats.org/drawingml/2006/main" idx="0"/>
+          <a:fillRef xmlns:a="http://schemas.openxmlformats.org/drawingml/2006/main" idx="0"/>
+          <a:effectRef xmlns:a="http://schemas.openxmlformats.org/drawingml/2006/main" idx="0"/>
+          <a:fontRef xmlns:a="http://schemas.openxmlformats.org/drawingml/2006/main" idx="minor"/>
+        </p:style>
+        <p:txBody>
+          <a:bodyPr xmlns:a="http://schemas.openxmlformats.org/drawingml/2006/main" lIns="90000" tIns="45000" rIns="90000" bIns="45000" anchor="t">
+            <a:spAutoFit/>
+          </a:bodyPr>
+          <a:lstStyle xmlns:a="http://schemas.openxmlformats.org/drawingml/2006/main"/>
+          <a:p xmlns:a="http://schemas.openxmlformats.org/drawingml/2006/main">
+            <a:pPr>
+              <a:lnSpc>
+                <a:spcPct val="130000"/>
+              </a:lnSpc>
+              <a:buNone/>
+            </a:pPr>
+            <a:r>
+              <a:rPr sz="2400" b="0" u="none">
+                <a:solidFill>
+                  <a:srgbClr val="23384B"/>
+                </a:solidFill>
+                <a:latin typeface="Noto Sans CJK KR"/>
+                <a:ea typeface="Noto Sans CJK KR"/>
+                <a:cs typeface="Noto Sans CJK KR"/>
+              </a:rPr>
+              <a:t>경과 시간: clock_gettime, clock_getres — 원형은 모두 &lt;time.h&gt;입니다.</a:t>
+            </a:r>
+            <a:endParaRPr sz="2400" b="0" u="none">
+              <a:solidFill>
+                <a:srgbClr val="000000"/>
+              </a:solidFill>
+              <a:latin typeface="Arial"/>
+              <a:ea typeface="Arial"/>
+              <a:cs typeface="Arial"/>
+            </a:endParaRPr>
+          </a:p>
+        </p:txBody>
+      </p:sp>
+      <p:sp>
+        <p:nvSpPr>
+          <p:cNvPr id="22" name="">
+            <a:extLst xmlns:a="http://schemas.openxmlformats.org/drawingml/2006/main">
+              <a:ext uri="{FF2B5EF4-FFF2-40B4-BE49-F238E27FC236}">
+                <a16:creationId xmlns:a16="http://schemas.microsoft.com/office/drawing/2014/main" id="{58F5FDB8-1994-442F-92B9-A2DCEF70836D}"/>
+              </a:ext>
+            </a:extLst>
+          </p:cNvPr>
+          <p:cNvSpPr>
+            <a:spLocks xmlns:a="http://schemas.openxmlformats.org/drawingml/2006/main" noGrp="1"/>
+          </p:cNvSpPr>
+          <p:nvPr/>
+        </p:nvSpPr>
+        <p:spPr>
+          <a:xfrm xmlns:a="http://schemas.openxmlformats.org/drawingml/2006/main">
+            <a:off x="630000" y="3312000"/>
+            <a:ext cx="10908000" cy="565560"/>
+          </a:xfrm>
+          <a:prstGeom xmlns:a="http://schemas.openxmlformats.org/drawingml/2006/main" prst="rect">
+            <a:avLst/>
+          </a:prstGeom>
+          <a:noFill xmlns:a="http://schemas.openxmlformats.org/drawingml/2006/main"/>
+          <a:ln xmlns:a="http://schemas.openxmlformats.org/drawingml/2006/main" w="38160">
+            <a:noFill/>
+          </a:ln>
+        </p:spPr>
+        <p:style>
+          <a:lnRef xmlns:a="http://schemas.openxmlformats.org/drawingml/2006/main" idx="0"/>
+          <a:fillRef xmlns:a="http://schemas.openxmlformats.org/drawingml/2006/main" idx="0"/>
+          <a:effectRef xmlns:a="http://schemas.openxmlformats.org/drawingml/2006/main" idx="0"/>
+          <a:fontRef xmlns:a="http://schemas.openxmlformats.org/drawingml/2006/main" idx="minor"/>
+        </p:style>
+        <p:txBody>
+          <a:bodyPr xmlns:a="http://schemas.openxmlformats.org/drawingml/2006/main" lIns="90000" tIns="45000" rIns="90000" bIns="45000" anchor="t">
+            <a:spAutoFit/>
+          </a:bodyPr>
+          <a:lstStyle xmlns:a="http://schemas.openxmlformats.org/drawingml/2006/main"/>
+          <a:p xmlns:a="http://schemas.openxmlformats.org/drawingml/2006/main">
+            <a:pPr>
+              <a:lnSpc>
+                <a:spcPct val="130000"/>
+              </a:lnSpc>
+              <a:buNone/>
+            </a:pPr>
+            <a:r>
+              <a:rPr sz="2400" b="0" u="none">
+                <a:solidFill>
+                  <a:srgbClr val="23384B"/>
+                </a:solidFill>
+                <a:latin typeface="Noto Sans CJK KR"/>
+                <a:ea typeface="Noto Sans CJK KR"/>
+                <a:cs typeface="Noto Sans CJK KR"/>
+              </a:rPr>
+              <a:t>time(2): glibc가 clock_gettime(CLOCK_REALTIME) 호출로 구현합니다.</a:t>
+            </a:r>
+            <a:endParaRPr sz="2400" b="0" u="none">
+              <a:solidFill>
+                <a:srgbClr val="000000"/>
+              </a:solidFill>
+              <a:latin typeface="Arial"/>
+              <a:ea typeface="Arial"/>
+              <a:cs typeface="Arial"/>
+            </a:endParaRPr>
+          </a:p>
+        </p:txBody>
+      </p:sp>
+      <p:sp>
+        <p:nvSpPr>
+          <p:cNvPr id="23" name="">
+            <a:extLst xmlns:a="http://schemas.openxmlformats.org/drawingml/2006/main">
+              <a:ext uri="{FF2B5EF4-FFF2-40B4-BE49-F238E27FC236}">
+                <a16:creationId xmlns:a16="http://schemas.microsoft.com/office/drawing/2014/main" id="{6543A099-3097-47CB-A71E-15F350A5A379}"/>
+              </a:ext>
+            </a:extLst>
+          </p:cNvPr>
+          <p:cNvSpPr>
+            <a:spLocks xmlns:a="http://schemas.openxmlformats.org/drawingml/2006/main" noGrp="1"/>
+          </p:cNvSpPr>
+          <p:nvPr/>
+        </p:nvSpPr>
+        <p:spPr>
+          <a:xfrm xmlns:a="http://schemas.openxmlformats.org/drawingml/2006/main">
+            <a:off x="630000" y="4086000"/>
+            <a:ext cx="10908000" cy="565560"/>
+          </a:xfrm>
+          <a:prstGeom xmlns:a="http://schemas.openxmlformats.org/drawingml/2006/main" prst="rect">
+            <a:avLst/>
+          </a:prstGeom>
+          <a:noFill xmlns:a="http://schemas.openxmlformats.org/drawingml/2006/main"/>
+          <a:ln xmlns:a="http://schemas.openxmlformats.org/drawingml/2006/main" w="38160">
+            <a:noFill/>
+          </a:ln>
+        </p:spPr>
+        <p:style>
+          <a:lnRef xmlns:a="http://schemas.openxmlformats.org/drawingml/2006/main" idx="0"/>
+          <a:fillRef xmlns:a="http://schemas.openxmlformats.org/drawingml/2006/main" idx="0"/>
+          <a:effectRef xmlns:a="http://schemas.openxmlformats.org/drawingml/2006/main" idx="0"/>
+          <a:fontRef xmlns:a="http://schemas.openxmlformats.org/drawingml/2006/main" idx="minor"/>
+        </p:style>
+        <p:txBody>
+          <a:bodyPr xmlns:a="http://schemas.openxmlformats.org/drawingml/2006/main" lIns="90000" tIns="45000" rIns="90000" bIns="45000" anchor="t">
+            <a:spAutoFit/>
+          </a:bodyPr>
+          <a:lstStyle xmlns:a="http://schemas.openxmlformats.org/drawingml/2006/main"/>
+          <a:p xmlns:a="http://schemas.openxmlformats.org/drawingml/2006/main">
+            <a:pPr>
+              <a:lnSpc>
+                <a:spcPct val="130000"/>
+              </a:lnSpc>
+              <a:buNone/>
+            </a:pPr>
+            <a:r>
+              <a:rPr sz="2400" b="0" u="none">
+                <a:solidFill>
+                  <a:srgbClr val="23384B"/>
+                </a:solidFill>
+                <a:latin typeface="Noto Sans CJK KR"/>
+                <a:ea typeface="Noto Sans CJK KR"/>
+                <a:cs typeface="Noto Sans CJK KR"/>
+              </a:rPr>
+              <a:t>clock_gettime(2): vDSO에서 바로 값을 돌려주고, 없으면 시스템 호출로 갑니다.</a:t>
+            </a:r>
+            <a:endParaRPr sz="2400" b="0" u="none">
+              <a:solidFill>
+                <a:srgbClr val="000000"/>
+              </a:solidFill>
+              <a:latin typeface="Arial"/>
+              <a:ea typeface="Arial"/>
+              <a:cs typeface="Arial"/>
+            </a:endParaRPr>
+          </a:p>
+        </p:txBody>
+      </p:sp>
+      <p:sp>
+        <p:nvSpPr>
+          <p:cNvPr id="24" name="">
+            <a:extLst xmlns:a="http://schemas.openxmlformats.org/drawingml/2006/main">
+              <a:ext uri="{FF2B5EF4-FFF2-40B4-BE49-F238E27FC236}">
+                <a16:creationId xmlns:a16="http://schemas.microsoft.com/office/drawing/2014/main" id="{30CFD0DA-D46C-4C74-98F5-C6480075FDB8}"/>
+              </a:ext>
+            </a:extLst>
+          </p:cNvPr>
+          <p:cNvSpPr>
+            <a:spLocks xmlns:a="http://schemas.openxmlformats.org/drawingml/2006/main" noGrp="1"/>
+          </p:cNvSpPr>
+          <p:nvPr/>
+        </p:nvSpPr>
+        <p:spPr>
+          <a:xfrm xmlns:a="http://schemas.openxmlformats.org/drawingml/2006/main">
+            <a:off x="630000" y="4860000"/>
+            <a:ext cx="10908000" cy="565560"/>
+          </a:xfrm>
+          <a:prstGeom xmlns:a="http://schemas.openxmlformats.org/drawingml/2006/main" prst="rect">
+            <a:avLst/>
+          </a:prstGeom>
+          <a:noFill xmlns:a="http://schemas.openxmlformats.org/drawingml/2006/main"/>
+          <a:ln xmlns:a="http://schemas.openxmlformats.org/drawingml/2006/main" w="38160">
+            <a:noFill/>
+          </a:ln>
+        </p:spPr>
+        <p:style>
+          <a:lnRef xmlns:a="http://schemas.openxmlformats.org/drawingml/2006/main" idx="0"/>
+          <a:fillRef xmlns:a="http://schemas.openxmlformats.org/drawingml/2006/main" idx="0"/>
+          <a:effectRef xmlns:a="http://schemas.openxmlformats.org/drawingml/2006/main" idx="0"/>
+          <a:fontRef xmlns:a="http://schemas.openxmlformats.org/drawingml/2006/main" idx="minor"/>
+        </p:style>
+        <p:txBody>
+          <a:bodyPr xmlns:a="http://schemas.openxmlformats.org/drawingml/2006/main" lIns="90000" tIns="45000" rIns="90000" bIns="45000" anchor="t">
+            <a:spAutoFit/>
+          </a:bodyPr>
+          <a:lstStyle xmlns:a="http://schemas.openxmlformats.org/drawingml/2006/main"/>
+          <a:p xmlns:a="http://schemas.openxmlformats.org/drawingml/2006/main">
+            <a:pPr>
+              <a:lnSpc>
+                <a:spcPct val="130000"/>
+              </a:lnSpc>
+              <a:buNone/>
+            </a:pPr>
+            <a:r>
+              <a:rPr sz="2400" b="0" u="none">
+                <a:solidFill>
+                  <a:srgbClr val="23384B"/>
+                </a:solidFill>
+                <a:latin typeface="Noto Sans CJK KR"/>
+                <a:ea typeface="Noto Sans CJK KR"/>
+                <a:cs typeface="Noto Sans CJK KR"/>
+              </a:rPr>
+              <a:t>localtime·strftime(3): 시간대 해석과 문자열 변환은 glibc 안에서 일어납니다.</a:t>
+            </a:r>
+            <a:endParaRPr sz="2400" b="0" u="none">
+              <a:solidFill>
+                <a:srgbClr val="000000"/>
+              </a:solidFill>
+              <a:latin typeface="Arial"/>
+              <a:ea typeface="Arial"/>
+              <a:cs typeface="Arial"/>
+            </a:endParaRPr>
+          </a:p>
+        </p:txBody>
+      </p:sp>
+      <p:sp>
+        <p:nvSpPr>
+          <p:cNvPr id="25" name="">
+            <a:extLst xmlns:a="http://schemas.openxmlformats.org/drawingml/2006/main">
+              <a:ext uri="{FF2B5EF4-FFF2-40B4-BE49-F238E27FC236}">
+                <a16:creationId xmlns:a16="http://schemas.microsoft.com/office/drawing/2014/main" id="{7CA8B79F-14CD-490E-B34C-64DBAAF84715}"/>
+              </a:ext>
+            </a:extLst>
+          </p:cNvPr>
+          <p:cNvSpPr>
+            <a:spLocks xmlns:a="http://schemas.openxmlformats.org/drawingml/2006/main" noGrp="1"/>
+          </p:cNvSpPr>
+          <p:nvPr/>
+        </p:nvSpPr>
+        <p:spPr>
+          <a:xfrm xmlns:a="http://schemas.openxmlformats.org/drawingml/2006/main">
+            <a:off x="628560" y="5924520"/>
+            <a:ext cx="10934280" cy="475920"/>
+          </a:xfrm>
+          <a:prstGeom xmlns:a="http://schemas.openxmlformats.org/drawingml/2006/main" prst="rect">
+            <a:avLst/>
+          </a:prstGeom>
+          <a:noFill xmlns:a="http://schemas.openxmlformats.org/drawingml/2006/main"/>
+          <a:ln xmlns:a="http://schemas.openxmlformats.org/drawingml/2006/main" w="0">
+            <a:noFill/>
+          </a:ln>
+        </p:spPr>
+        <p:style>
+          <a:lnRef xmlns:a="http://schemas.openxmlformats.org/drawingml/2006/main" idx="0"/>
+          <a:fillRef xmlns:a="http://schemas.openxmlformats.org/drawingml/2006/main" idx="0"/>
+          <a:effectRef xmlns:a="http://schemas.openxmlformats.org/drawingml/2006/main" idx="0"/>
+          <a:fontRef xmlns:a="http://schemas.openxmlformats.org/drawingml/2006/main" idx="minor"/>
+        </p:style>
+        <p:txBody>
+          <a:bodyPr xmlns:a="http://schemas.openxmlformats.org/drawingml/2006/main" lIns="0" tIns="0" rIns="0" bIns="0" anchor="t">
+            <a:noAutofit/>
+          </a:bodyPr>
+          <a:lstStyle xmlns:a="http://schemas.openxmlformats.org/drawingml/2006/main"/>
+          <a:p xmlns:a="http://schemas.openxmlformats.org/drawingml/2006/main">
+            <a:pPr>
+              <a:lnSpc>
+                <a:spcPct val="100000"/>
+              </a:lnSpc>
+              <a:buNone/>
+            </a:pPr>
+            <a:r>
+              <a:rPr sz="1580" b="0" u="none">
+                <a:solidFill>
+                  <a:srgbClr val="666666"/>
+                </a:solidFill>
+                <a:latin typeface="Noto Sans CJK KR"/>
+                <a:ea typeface="Noto Sans CJK KR"/>
+                <a:cs typeface="Noto Sans CJK KR"/>
+              </a:rPr>
+              <a:t>class02 예제가 사용하는 함수 · stable linux-7.2.y · 2026-09-28 확인</a:t>
+            </a:r>
+            <a:endParaRPr sz="1580" b="0" u="none">
+              <a:solidFill>
+                <a:srgbClr val="000000"/>
+              </a:solidFill>
+              <a:latin typeface="Arial"/>
+              <a:ea typeface="Arial"/>
+              <a:cs typeface="Arial"/>
+            </a:endParaRPr>
+          </a:p>
+        </p:txBody>
+      </p:sp>
+    </p:spTree>
+    <p:extLst>
+      <p:ext uri="{BB962C8B-B14F-4D97-AF65-F5344CB8AC3E}">
+        <p14:creationId xmlns:p14="http://schemas.microsoft.com/office/powerpoint/2010/main" val="1340780982"/>
+      </p:ext>
+    </p:extLst>
+  </p:cSld>
+</p:sld>
+</file>
+
+<file path=ppt/slides/slide4.xml><?xml version="1.0" encoding="utf-8"?>
+<p:sld xmlns:p="http://schemas.openxmlformats.org/presentationml/2006/main">
+  <p:cSld>
+    <p:spTree>
+      <p:nvGrpSpPr>
+        <p:cNvPr id="1" name=""/>
+        <p:cNvGrpSpPr/>
+        <p:nvPr/>
+      </p:nvGrpSpPr>
+      <p:grpSpPr>
+        <a:xfrm xmlns:a="http://schemas.openxmlformats.org/drawingml/2006/main"/>
+      </p:grpSpPr>
+      <p:sp>
+        <p:nvSpPr>
+          <p:cNvPr id="120" name="">
+            <a:extLst xmlns:a="http://schemas.openxmlformats.org/drawingml/2006/main">
+              <a:ext uri="{FF2B5EF4-FFF2-40B4-BE49-F238E27FC236}">
+                <a16:creationId xmlns:a16="http://schemas.microsoft.com/office/drawing/2014/main" id="{8B8127A3-0CB8-4ECA-AAD1-5D5C7FE20989}"/>
+              </a:ext>
+            </a:extLst>
+          </p:cNvPr>
+          <p:cNvSpPr>
+            <a:spLocks xmlns:a="http://schemas.openxmlformats.org/drawingml/2006/main" noGrp="1"/>
+          </p:cNvSpPr>
+          <p:nvPr/>
+        </p:nvSpPr>
+        <p:spPr>
+          <a:xfrm xmlns:a="http://schemas.openxmlformats.org/drawingml/2006/main">
+            <a:off x="360000" y="1620000"/>
+            <a:ext cx="11520000" cy="0"/>
+          </a:xfrm>
+          <a:prstGeom xmlns:a="http://schemas.openxmlformats.org/drawingml/2006/main" prst="line">
+            <a:avLst/>
+          </a:prstGeom>
+          <a:ln xmlns:a="http://schemas.openxmlformats.org/drawingml/2006/main" w="38160">
+            <a:solidFill>
+              <a:srgbClr val="FF8000"/>
+            </a:solidFill>
+          </a:ln>
+        </p:spPr>
+        <p:style>
+          <a:lnRef xmlns:a="http://schemas.openxmlformats.org/drawingml/2006/main" idx="0"/>
+          <a:fillRef xmlns:a="http://schemas.openxmlformats.org/drawingml/2006/main" idx="0"/>
+          <a:effectRef xmlns:a="http://schemas.openxmlformats.org/drawingml/2006/main" idx="0"/>
+          <a:fontRef xmlns:a="http://schemas.openxmlformats.org/drawingml/2006/main" idx="minor"/>
+        </p:style>
+        <p:txBody>
+          <a:bodyPr xmlns:a="http://schemas.openxmlformats.org/drawingml/2006/main" lIns="90000" tIns="-45000" rIns="90000" bIns="-45000" anchor="ctr">
+            <a:noAutofit/>
+          </a:bodyPr>
+          <a:lstStyle xmlns:a="http://schemas.openxmlformats.org/drawingml/2006/main"/>
+          <a:p xmlns:a="http://schemas.openxmlformats.org/drawingml/2006/main">
+            <a:pPr>
+              <a:buNone/>
+            </a:pPr>
+            <a:endParaRPr sz="1800" b="0" u="none">
+              <a:solidFill>
+                <a:srgbClr val="000000"/>
+              </a:solidFill>
+              <a:latin typeface="Arial"/>
+              <a:ea typeface="Arial"/>
+              <a:cs typeface="Arial"/>
+            </a:endParaRPr>
+          </a:p>
+        </p:txBody>
+      </p:sp>
+      <p:sp>
+        <p:nvSpPr>
           <p:cNvPr id="121" name="">
             <a:extLst xmlns:a="http://schemas.openxmlformats.org/drawingml/2006/main">
               <a:ext uri="{FF2B5EF4-FFF2-40B4-BE49-F238E27FC236}">
-                <a16:creationId xmlns:a16="http://schemas.microsoft.com/office/drawing/2014/main" id="{D4E2E49E-43A3-4331-818B-A89B369568F1}"/>
+                <a16:creationId xmlns:a16="http://schemas.microsoft.com/office/drawing/2014/main" id="{40E8F94A-D3EB-4F23-9BF9-F86B3D5276A6}"/>
               </a:ext>
             </a:extLst>
           </p:cNvPr>
@@ -42109,7 +42774,7 @@
           <p:cNvPr id="122" name="">
             <a:extLst xmlns:a="http://schemas.openxmlformats.org/drawingml/2006/main">
               <a:ext uri="{FF2B5EF4-FFF2-40B4-BE49-F238E27FC236}">
-                <a16:creationId xmlns:a16="http://schemas.microsoft.com/office/drawing/2014/main" id="{6ECF7E94-23CC-4344-A401-08C1B59BF937}"/>
+                <a16:creationId xmlns:a16="http://schemas.microsoft.com/office/drawing/2014/main" id="{54AA50D7-D24F-435B-B675-FD0F868F1B59}"/>
               </a:ext>
             </a:extLst>
           </p:cNvPr>
@@ -42711,7 +43376,7 @@
           <p:cNvPr id="123" name="">
             <a:extLst xmlns:a="http://schemas.openxmlformats.org/drawingml/2006/main">
               <a:ext uri="{FF2B5EF4-FFF2-40B4-BE49-F238E27FC236}">
-                <a16:creationId xmlns:a16="http://schemas.microsoft.com/office/drawing/2014/main" id="{C62D0D0A-0C2C-40F8-B02C-FD51CFB42E0A}"/>
+                <a16:creationId xmlns:a16="http://schemas.microsoft.com/office/drawing/2014/main" id="{14827209-21E1-4842-927C-D4A1A4016104}"/>
               </a:ext>
             </a:extLst>
           </p:cNvPr>
@@ -42786,7 +43451,7 @@
           <p:cNvPr id="124" name="">
             <a:extLst xmlns:a="http://schemas.openxmlformats.org/drawingml/2006/main">
               <a:ext uri="{FF2B5EF4-FFF2-40B4-BE49-F238E27FC236}">
-                <a16:creationId xmlns:a16="http://schemas.microsoft.com/office/drawing/2014/main" id="{71415566-453B-4DFD-99EF-C2F5720ED1AB}"/>
+                <a16:creationId xmlns:a16="http://schemas.microsoft.com/office/drawing/2014/main" id="{7B593D54-FB77-422A-B262-F18A03539D87}"/>
               </a:ext>
             </a:extLst>
           </p:cNvPr>
@@ -42896,7 +43561,7 @@
           <p:cNvPr id="125" name="">
             <a:extLst xmlns:a="http://schemas.openxmlformats.org/drawingml/2006/main">
               <a:ext uri="{FF2B5EF4-FFF2-40B4-BE49-F238E27FC236}">
-                <a16:creationId xmlns:a16="http://schemas.microsoft.com/office/drawing/2014/main" id="{5BAA69F5-116D-4B32-AC07-F3C642D0B2D3}"/>
+                <a16:creationId xmlns:a16="http://schemas.microsoft.com/office/drawing/2014/main" id="{A7959816-73EA-49D2-BCB2-F50515F535CF}"/>
               </a:ext>
             </a:extLst>
           </p:cNvPr>
@@ -42971,7 +43636,7 @@
           <p:cNvPr id="126" name="">
             <a:extLst xmlns:a="http://schemas.openxmlformats.org/drawingml/2006/main">
               <a:ext uri="{FF2B5EF4-FFF2-40B4-BE49-F238E27FC236}">
-                <a16:creationId xmlns:a16="http://schemas.microsoft.com/office/drawing/2014/main" id="{E68C548A-13C2-4939-B3BF-BB44B61F8F32}"/>
+                <a16:creationId xmlns:a16="http://schemas.microsoft.com/office/drawing/2014/main" id="{2162145B-3F9E-40E4-9EAF-31021B17E9AA}"/>
               </a:ext>
             </a:extLst>
           </p:cNvPr>
@@ -43081,7 +43746,7 @@
           <p:cNvPr id="127" name="">
             <a:extLst xmlns:a="http://schemas.openxmlformats.org/drawingml/2006/main">
               <a:ext uri="{FF2B5EF4-FFF2-40B4-BE49-F238E27FC236}">
-                <a16:creationId xmlns:a16="http://schemas.microsoft.com/office/drawing/2014/main" id="{21F524E0-2EED-4D18-931C-220020F33DE9}"/>
+                <a16:creationId xmlns:a16="http://schemas.microsoft.com/office/drawing/2014/main" id="{FABD9BB6-4FA1-4911-B03D-BEEBE352FF93}"/>
               </a:ext>
             </a:extLst>
           </p:cNvPr>
@@ -43156,7 +43821,7 @@
           <p:cNvPr id="128" name="">
             <a:extLst xmlns:a="http://schemas.openxmlformats.org/drawingml/2006/main">
               <a:ext uri="{FF2B5EF4-FFF2-40B4-BE49-F238E27FC236}">
-                <a16:creationId xmlns:a16="http://schemas.microsoft.com/office/drawing/2014/main" id="{8B5E0EA7-381E-48B0-9DF7-DF5A40F7B7A5}"/>
+                <a16:creationId xmlns:a16="http://schemas.microsoft.com/office/drawing/2014/main" id="{C09CBB75-8392-4D1D-B1D3-189A0615B830}"/>
               </a:ext>
             </a:extLst>
           </p:cNvPr>
@@ -43266,7 +43931,7 @@
           <p:cNvPr id="129" name="">
             <a:extLst xmlns:a="http://schemas.openxmlformats.org/drawingml/2006/main">
               <a:ext uri="{FF2B5EF4-FFF2-40B4-BE49-F238E27FC236}">
-                <a16:creationId xmlns:a16="http://schemas.microsoft.com/office/drawing/2014/main" id="{DBB90792-BEF2-4906-9F4D-5CC4447462A9}"/>
+                <a16:creationId xmlns:a16="http://schemas.microsoft.com/office/drawing/2014/main" id="{6CD1CB88-1DD8-4791-932F-BC6B1B21C308}"/>
               </a:ext>
             </a:extLst>
           </p:cNvPr>
@@ -43331,7 +43996,7 @@
     </p:spTree>
     <p:extLst>
       <p:ext uri="{BB962C8B-B14F-4D97-AF65-F5344CB8AC3E}">
-        <p14:creationId xmlns:p14="http://schemas.microsoft.com/office/powerpoint/2010/main" val="2112704824"/>
+        <p14:creationId xmlns:p14="http://schemas.microsoft.com/office/powerpoint/2010/main" val="71809283"/>
       </p:ext>
     </p:extLst>
   </p:cSld>
@@ -43355,7 +44020,7 @@
           <p:cNvPr id="120" name="">
             <a:extLst xmlns:a="http://schemas.openxmlformats.org/drawingml/2006/main">
               <a:ext uri="{FF2B5EF4-FFF2-40B4-BE49-F238E27FC236}">
-                <a16:creationId xmlns:a16="http://schemas.microsoft.com/office/drawing/2014/main" id="{BD919CFC-680A-4ED7-B654-0E0FF1B76715}"/>
+                <a16:creationId xmlns:a16="http://schemas.microsoft.com/office/drawing/2014/main" id="{8B8127A3-0CB8-4ECA-AAD1-5D5C7FE20989}"/>
               </a:ext>
             </a:extLst>
           </p:cNvPr>
@@ -43409,7 +44074,7 @@
           <p:cNvPr id="121" name="">
             <a:extLst xmlns:a="http://schemas.openxmlformats.org/drawingml/2006/main">
               <a:ext uri="{FF2B5EF4-FFF2-40B4-BE49-F238E27FC236}">
-                <a16:creationId xmlns:a16="http://schemas.microsoft.com/office/drawing/2014/main" id="{D4E2E49E-43A3-4331-818B-A89B369568F1}"/>
+                <a16:creationId xmlns:a16="http://schemas.microsoft.com/office/drawing/2014/main" id="{40E8F94A-D3EB-4F23-9BF9-F86B3D5276A6}"/>
               </a:ext>
             </a:extLst>
           </p:cNvPr>
@@ -43476,7 +44141,7 @@
           <p:cNvPr id="122" name="">
             <a:extLst xmlns:a="http://schemas.openxmlformats.org/drawingml/2006/main">
               <a:ext uri="{FF2B5EF4-FFF2-40B4-BE49-F238E27FC236}">
-                <a16:creationId xmlns:a16="http://schemas.microsoft.com/office/drawing/2014/main" id="{6ECF7E94-23CC-4344-A401-08C1B59BF937}"/>
+                <a16:creationId xmlns:a16="http://schemas.microsoft.com/office/drawing/2014/main" id="{54AA50D7-D24F-435B-B675-FD0F868F1B59}"/>
               </a:ext>
             </a:extLst>
           </p:cNvPr>
@@ -44078,7 +44743,7 @@
           <p:cNvPr id="123" name="">
             <a:extLst xmlns:a="http://schemas.openxmlformats.org/drawingml/2006/main">
               <a:ext uri="{FF2B5EF4-FFF2-40B4-BE49-F238E27FC236}">
-                <a16:creationId xmlns:a16="http://schemas.microsoft.com/office/drawing/2014/main" id="{C62D0D0A-0C2C-40F8-B02C-FD51CFB42E0A}"/>
+                <a16:creationId xmlns:a16="http://schemas.microsoft.com/office/drawing/2014/main" id="{14827209-21E1-4842-927C-D4A1A4016104}"/>
               </a:ext>
             </a:extLst>
           </p:cNvPr>
@@ -44153,7 +44818,7 @@
           <p:cNvPr id="124" name="">
             <a:extLst xmlns:a="http://schemas.openxmlformats.org/drawingml/2006/main">
               <a:ext uri="{FF2B5EF4-FFF2-40B4-BE49-F238E27FC236}">
-                <a16:creationId xmlns:a16="http://schemas.microsoft.com/office/drawing/2014/main" id="{71415566-453B-4DFD-99EF-C2F5720ED1AB}"/>
+                <a16:creationId xmlns:a16="http://schemas.microsoft.com/office/drawing/2014/main" id="{7B593D54-FB77-422A-B262-F18A03539D87}"/>
               </a:ext>
             </a:extLst>
           </p:cNvPr>
@@ -44263,7 +44928,7 @@
           <p:cNvPr id="125" name="">
             <a:extLst xmlns:a="http://schemas.openxmlformats.org/drawingml/2006/main">
               <a:ext uri="{FF2B5EF4-FFF2-40B4-BE49-F238E27FC236}">
-                <a16:creationId xmlns:a16="http://schemas.microsoft.com/office/drawing/2014/main" id="{5BAA69F5-116D-4B32-AC07-F3C642D0B2D3}"/>
+                <a16:creationId xmlns:a16="http://schemas.microsoft.com/office/drawing/2014/main" id="{A7959816-73EA-49D2-BCB2-F50515F535CF}"/>
               </a:ext>
             </a:extLst>
           </p:cNvPr>
@@ -44338,7 +45003,7 @@
           <p:cNvPr id="126" name="">
             <a:extLst xmlns:a="http://schemas.openxmlformats.org/drawingml/2006/main">
               <a:ext uri="{FF2B5EF4-FFF2-40B4-BE49-F238E27FC236}">
-                <a16:creationId xmlns:a16="http://schemas.microsoft.com/office/drawing/2014/main" id="{E68C548A-13C2-4939-B3BF-BB44B61F8F32}"/>
+                <a16:creationId xmlns:a16="http://schemas.microsoft.com/office/drawing/2014/main" id="{2162145B-3F9E-40E4-9EAF-31021B17E9AA}"/>
               </a:ext>
             </a:extLst>
           </p:cNvPr>
@@ -44448,7 +45113,7 @@
           <p:cNvPr id="127" name="">
             <a:extLst xmlns:a="http://schemas.openxmlformats.org/drawingml/2006/main">
               <a:ext uri="{FF2B5EF4-FFF2-40B4-BE49-F238E27FC236}">
-                <a16:creationId xmlns:a16="http://schemas.microsoft.com/office/drawing/2014/main" id="{21F524E0-2EED-4D18-931C-220020F33DE9}"/>
+                <a16:creationId xmlns:a16="http://schemas.microsoft.com/office/drawing/2014/main" id="{FABD9BB6-4FA1-4911-B03D-BEEBE352FF93}"/>
               </a:ext>
             </a:extLst>
           </p:cNvPr>
@@ -44523,7 +45188,7 @@
           <p:cNvPr id="128" name="">
             <a:extLst xmlns:a="http://schemas.openxmlformats.org/drawingml/2006/main">
               <a:ext uri="{FF2B5EF4-FFF2-40B4-BE49-F238E27FC236}">
-                <a16:creationId xmlns:a16="http://schemas.microsoft.com/office/drawing/2014/main" id="{8B5E0EA7-381E-48B0-9DF7-DF5A40F7B7A5}"/>
+                <a16:creationId xmlns:a16="http://schemas.microsoft.com/office/drawing/2014/main" id="{C09CBB75-8392-4D1D-B1D3-189A0615B830}"/>
               </a:ext>
             </a:extLst>
           </p:cNvPr>
@@ -44633,7 +45298,7 @@
           <p:cNvPr id="129" name="">
             <a:extLst xmlns:a="http://schemas.openxmlformats.org/drawingml/2006/main">
               <a:ext uri="{FF2B5EF4-FFF2-40B4-BE49-F238E27FC236}">
-                <a16:creationId xmlns:a16="http://schemas.microsoft.com/office/drawing/2014/main" id="{DBB90792-BEF2-4906-9F4D-5CC4447462A9}"/>
+                <a16:creationId xmlns:a16="http://schemas.microsoft.com/office/drawing/2014/main" id="{6CD1CB88-1DD8-4791-932F-BC6B1B21C308}"/>
               </a:ext>
             </a:extLst>
           </p:cNvPr>
@@ -44698,7 +45363,7 @@
     </p:spTree>
     <p:extLst>
       <p:ext uri="{BB962C8B-B14F-4D97-AF65-F5344CB8AC3E}">
-        <p14:creationId xmlns:p14="http://schemas.microsoft.com/office/powerpoint/2010/main" val="2112704824"/>
+        <p14:creationId xmlns:p14="http://schemas.microsoft.com/office/powerpoint/2010/main" val="71809283"/>
       </p:ext>
     </p:extLst>
   </p:cSld>
@@ -44722,7 +45387,7 @@
           <p:cNvPr id="120" name="">
             <a:extLst xmlns:a="http://schemas.openxmlformats.org/drawingml/2006/main">
               <a:ext uri="{FF2B5EF4-FFF2-40B4-BE49-F238E27FC236}">
-                <a16:creationId xmlns:a16="http://schemas.microsoft.com/office/drawing/2014/main" id="{BD919CFC-680A-4ED7-B654-0E0FF1B76715}"/>
+                <a16:creationId xmlns:a16="http://schemas.microsoft.com/office/drawing/2014/main" id="{8B8127A3-0CB8-4ECA-AAD1-5D5C7FE20989}"/>
               </a:ext>
             </a:extLst>
           </p:cNvPr>
@@ -44776,7 +45441,7 @@
           <p:cNvPr id="121" name="">
             <a:extLst xmlns:a="http://schemas.openxmlformats.org/drawingml/2006/main">
               <a:ext uri="{FF2B5EF4-FFF2-40B4-BE49-F238E27FC236}">
-                <a16:creationId xmlns:a16="http://schemas.microsoft.com/office/drawing/2014/main" id="{D4E2E49E-43A3-4331-818B-A89B369568F1}"/>
+                <a16:creationId xmlns:a16="http://schemas.microsoft.com/office/drawing/2014/main" id="{40E8F94A-D3EB-4F23-9BF9-F86B3D5276A6}"/>
               </a:ext>
             </a:extLst>
           </p:cNvPr>
@@ -44843,7 +45508,7 @@
           <p:cNvPr id="122" name="">
             <a:extLst xmlns:a="http://schemas.openxmlformats.org/drawingml/2006/main">
               <a:ext uri="{FF2B5EF4-FFF2-40B4-BE49-F238E27FC236}">
-                <a16:creationId xmlns:a16="http://schemas.microsoft.com/office/drawing/2014/main" id="{6ECF7E94-23CC-4344-A401-08C1B59BF937}"/>
+                <a16:creationId xmlns:a16="http://schemas.microsoft.com/office/drawing/2014/main" id="{54AA50D7-D24F-435B-B675-FD0F868F1B59}"/>
               </a:ext>
             </a:extLst>
           </p:cNvPr>
@@ -45515,7 +46180,7 @@
           <p:cNvPr id="123" name="">
             <a:extLst xmlns:a="http://schemas.openxmlformats.org/drawingml/2006/main">
               <a:ext uri="{FF2B5EF4-FFF2-40B4-BE49-F238E27FC236}">
-                <a16:creationId xmlns:a16="http://schemas.microsoft.com/office/drawing/2014/main" id="{C62D0D0A-0C2C-40F8-B02C-FD51CFB42E0A}"/>
+                <a16:creationId xmlns:a16="http://schemas.microsoft.com/office/drawing/2014/main" id="{14827209-21E1-4842-927C-D4A1A4016104}"/>
               </a:ext>
             </a:extLst>
           </p:cNvPr>
@@ -45590,7 +46255,7 @@
           <p:cNvPr id="124" name="">
             <a:extLst xmlns:a="http://schemas.openxmlformats.org/drawingml/2006/main">
               <a:ext uri="{FF2B5EF4-FFF2-40B4-BE49-F238E27FC236}">
-                <a16:creationId xmlns:a16="http://schemas.microsoft.com/office/drawing/2014/main" id="{71415566-453B-4DFD-99EF-C2F5720ED1AB}"/>
+                <a16:creationId xmlns:a16="http://schemas.microsoft.com/office/drawing/2014/main" id="{7B593D54-FB77-422A-B262-F18A03539D87}"/>
               </a:ext>
             </a:extLst>
           </p:cNvPr>
@@ -45700,7 +46365,7 @@
           <p:cNvPr id="125" name="">
             <a:extLst xmlns:a="http://schemas.openxmlformats.org/drawingml/2006/main">
               <a:ext uri="{FF2B5EF4-FFF2-40B4-BE49-F238E27FC236}">
-                <a16:creationId xmlns:a16="http://schemas.microsoft.com/office/drawing/2014/main" id="{5BAA69F5-116D-4B32-AC07-F3C642D0B2D3}"/>
+                <a16:creationId xmlns:a16="http://schemas.microsoft.com/office/drawing/2014/main" id="{A7959816-73EA-49D2-BCB2-F50515F535CF}"/>
               </a:ext>
             </a:extLst>
           </p:cNvPr>
@@ -45775,7 +46440,7 @@
           <p:cNvPr id="126" name="">
             <a:extLst xmlns:a="http://schemas.openxmlformats.org/drawingml/2006/main">
               <a:ext uri="{FF2B5EF4-FFF2-40B4-BE49-F238E27FC236}">
-                <a16:creationId xmlns:a16="http://schemas.microsoft.com/office/drawing/2014/main" id="{E68C548A-13C2-4939-B3BF-BB44B61F8F32}"/>
+                <a16:creationId xmlns:a16="http://schemas.microsoft.com/office/drawing/2014/main" id="{2162145B-3F9E-40E4-9EAF-31021B17E9AA}"/>
               </a:ext>
             </a:extLst>
           </p:cNvPr>
@@ -45885,7 +46550,7 @@
           <p:cNvPr id="127" name="">
             <a:extLst xmlns:a="http://schemas.openxmlformats.org/drawingml/2006/main">
               <a:ext uri="{FF2B5EF4-FFF2-40B4-BE49-F238E27FC236}">
-                <a16:creationId xmlns:a16="http://schemas.microsoft.com/office/drawing/2014/main" id="{21F524E0-2EED-4D18-931C-220020F33DE9}"/>
+                <a16:creationId xmlns:a16="http://schemas.microsoft.com/office/drawing/2014/main" id="{FABD9BB6-4FA1-4911-B03D-BEEBE352FF93}"/>
               </a:ext>
             </a:extLst>
           </p:cNvPr>
@@ -45960,7 +46625,7 @@
           <p:cNvPr id="128" name="">
             <a:extLst xmlns:a="http://schemas.openxmlformats.org/drawingml/2006/main">
               <a:ext uri="{FF2B5EF4-FFF2-40B4-BE49-F238E27FC236}">
-                <a16:creationId xmlns:a16="http://schemas.microsoft.com/office/drawing/2014/main" id="{8B5E0EA7-381E-48B0-9DF7-DF5A40F7B7A5}"/>
+                <a16:creationId xmlns:a16="http://schemas.microsoft.com/office/drawing/2014/main" id="{C09CBB75-8392-4D1D-B1D3-189A0615B830}"/>
               </a:ext>
             </a:extLst>
           </p:cNvPr>
@@ -46070,7 +46735,7 @@
           <p:cNvPr id="129" name="">
             <a:extLst xmlns:a="http://schemas.openxmlformats.org/drawingml/2006/main">
               <a:ext uri="{FF2B5EF4-FFF2-40B4-BE49-F238E27FC236}">
-                <a16:creationId xmlns:a16="http://schemas.microsoft.com/office/drawing/2014/main" id="{DBB90792-BEF2-4906-9F4D-5CC4447462A9}"/>
+                <a16:creationId xmlns:a16="http://schemas.microsoft.com/office/drawing/2014/main" id="{6CD1CB88-1DD8-4791-932F-BC6B1B21C308}"/>
               </a:ext>
             </a:extLst>
           </p:cNvPr>
@@ -46135,7 +46800,7 @@
     </p:spTree>
     <p:extLst>
       <p:ext uri="{BB962C8B-B14F-4D97-AF65-F5344CB8AC3E}">
-        <p14:creationId xmlns:p14="http://schemas.microsoft.com/office/powerpoint/2010/main" val="2112704824"/>
+        <p14:creationId xmlns:p14="http://schemas.microsoft.com/office/powerpoint/2010/main" val="71809283"/>
       </p:ext>
     </p:extLst>
   </p:cSld>
@@ -46159,7 +46824,7 @@
           <p:cNvPr id="120" name="">
             <a:extLst xmlns:a="http://schemas.openxmlformats.org/drawingml/2006/main">
               <a:ext uri="{FF2B5EF4-FFF2-40B4-BE49-F238E27FC236}">
-                <a16:creationId xmlns:a16="http://schemas.microsoft.com/office/drawing/2014/main" id="{BD919CFC-680A-4ED7-B654-0E0FF1B76715}"/>
+                <a16:creationId xmlns:a16="http://schemas.microsoft.com/office/drawing/2014/main" id="{8B8127A3-0CB8-4ECA-AAD1-5D5C7FE20989}"/>
               </a:ext>
             </a:extLst>
           </p:cNvPr>
@@ -46213,7 +46878,7 @@
           <p:cNvPr id="121" name="">
             <a:extLst xmlns:a="http://schemas.openxmlformats.org/drawingml/2006/main">
               <a:ext uri="{FF2B5EF4-FFF2-40B4-BE49-F238E27FC236}">
-                <a16:creationId xmlns:a16="http://schemas.microsoft.com/office/drawing/2014/main" id="{D4E2E49E-43A3-4331-818B-A89B369568F1}"/>
+                <a16:creationId xmlns:a16="http://schemas.microsoft.com/office/drawing/2014/main" id="{40E8F94A-D3EB-4F23-9BF9-F86B3D5276A6}"/>
               </a:ext>
             </a:extLst>
           </p:cNvPr>
@@ -46280,7 +46945,7 @@
           <p:cNvPr id="122" name="">
             <a:extLst xmlns:a="http://schemas.openxmlformats.org/drawingml/2006/main">
               <a:ext uri="{FF2B5EF4-FFF2-40B4-BE49-F238E27FC236}">
-                <a16:creationId xmlns:a16="http://schemas.microsoft.com/office/drawing/2014/main" id="{6ECF7E94-23CC-4344-A401-08C1B59BF937}"/>
+                <a16:creationId xmlns:a16="http://schemas.microsoft.com/office/drawing/2014/main" id="{54AA50D7-D24F-435B-B675-FD0F868F1B59}"/>
               </a:ext>
             </a:extLst>
           </p:cNvPr>
@@ -46742,7 +47407,7 @@
           <p:cNvPr id="123" name="">
             <a:extLst xmlns:a="http://schemas.openxmlformats.org/drawingml/2006/main">
               <a:ext uri="{FF2B5EF4-FFF2-40B4-BE49-F238E27FC236}">
-                <a16:creationId xmlns:a16="http://schemas.microsoft.com/office/drawing/2014/main" id="{C62D0D0A-0C2C-40F8-B02C-FD51CFB42E0A}"/>
+                <a16:creationId xmlns:a16="http://schemas.microsoft.com/office/drawing/2014/main" id="{14827209-21E1-4842-927C-D4A1A4016104}"/>
               </a:ext>
             </a:extLst>
           </p:cNvPr>
@@ -46817,7 +47482,7 @@
           <p:cNvPr id="124" name="">
             <a:extLst xmlns:a="http://schemas.openxmlformats.org/drawingml/2006/main">
               <a:ext uri="{FF2B5EF4-FFF2-40B4-BE49-F238E27FC236}">
-                <a16:creationId xmlns:a16="http://schemas.microsoft.com/office/drawing/2014/main" id="{71415566-453B-4DFD-99EF-C2F5720ED1AB}"/>
+                <a16:creationId xmlns:a16="http://schemas.microsoft.com/office/drawing/2014/main" id="{7B593D54-FB77-422A-B262-F18A03539D87}"/>
               </a:ext>
             </a:extLst>
           </p:cNvPr>
@@ -46927,7 +47592,7 @@
           <p:cNvPr id="125" name="">
             <a:extLst xmlns:a="http://schemas.openxmlformats.org/drawingml/2006/main">
               <a:ext uri="{FF2B5EF4-FFF2-40B4-BE49-F238E27FC236}">
-                <a16:creationId xmlns:a16="http://schemas.microsoft.com/office/drawing/2014/main" id="{5BAA69F5-116D-4B32-AC07-F3C642D0B2D3}"/>
+                <a16:creationId xmlns:a16="http://schemas.microsoft.com/office/drawing/2014/main" id="{A7959816-73EA-49D2-BCB2-F50515F535CF}"/>
               </a:ext>
             </a:extLst>
           </p:cNvPr>
@@ -47002,7 +47667,7 @@
           <p:cNvPr id="126" name="">
             <a:extLst xmlns:a="http://schemas.openxmlformats.org/drawingml/2006/main">
               <a:ext uri="{FF2B5EF4-FFF2-40B4-BE49-F238E27FC236}">
-                <a16:creationId xmlns:a16="http://schemas.microsoft.com/office/drawing/2014/main" id="{E68C548A-13C2-4939-B3BF-BB44B61F8F32}"/>
+                <a16:creationId xmlns:a16="http://schemas.microsoft.com/office/drawing/2014/main" id="{2162145B-3F9E-40E4-9EAF-31021B17E9AA}"/>
               </a:ext>
             </a:extLst>
           </p:cNvPr>
@@ -47112,7 +47777,7 @@
           <p:cNvPr id="127" name="">
             <a:extLst xmlns:a="http://schemas.openxmlformats.org/drawingml/2006/main">
               <a:ext uri="{FF2B5EF4-FFF2-40B4-BE49-F238E27FC236}">
-                <a16:creationId xmlns:a16="http://schemas.microsoft.com/office/drawing/2014/main" id="{21F524E0-2EED-4D18-931C-220020F33DE9}"/>
+                <a16:creationId xmlns:a16="http://schemas.microsoft.com/office/drawing/2014/main" id="{FABD9BB6-4FA1-4911-B03D-BEEBE352FF93}"/>
               </a:ext>
             </a:extLst>
           </p:cNvPr>
@@ -47187,7 +47852,7 @@
           <p:cNvPr id="128" name="">
             <a:extLst xmlns:a="http://schemas.openxmlformats.org/drawingml/2006/main">
               <a:ext uri="{FF2B5EF4-FFF2-40B4-BE49-F238E27FC236}">
-                <a16:creationId xmlns:a16="http://schemas.microsoft.com/office/drawing/2014/main" id="{8B5E0EA7-381E-48B0-9DF7-DF5A40F7B7A5}"/>
+                <a16:creationId xmlns:a16="http://schemas.microsoft.com/office/drawing/2014/main" id="{C09CBB75-8392-4D1D-B1D3-189A0615B830}"/>
               </a:ext>
             </a:extLst>
           </p:cNvPr>
@@ -47297,7 +47962,7 @@
           <p:cNvPr id="129" name="">
             <a:extLst xmlns:a="http://schemas.openxmlformats.org/drawingml/2006/main">
               <a:ext uri="{FF2B5EF4-FFF2-40B4-BE49-F238E27FC236}">
-                <a16:creationId xmlns:a16="http://schemas.microsoft.com/office/drawing/2014/main" id="{DBB90792-BEF2-4906-9F4D-5CC4447462A9}"/>
+                <a16:creationId xmlns:a16="http://schemas.microsoft.com/office/drawing/2014/main" id="{6CD1CB88-1DD8-4791-932F-BC6B1B21C308}"/>
               </a:ext>
             </a:extLst>
           </p:cNvPr>
@@ -47362,7 +48027,7 @@
     </p:spTree>
     <p:extLst>
       <p:ext uri="{BB962C8B-B14F-4D97-AF65-F5344CB8AC3E}">
-        <p14:creationId xmlns:p14="http://schemas.microsoft.com/office/powerpoint/2010/main" val="2112704824"/>
+        <p14:creationId xmlns:p14="http://schemas.microsoft.com/office/powerpoint/2010/main" val="71809283"/>
       </p:ext>
     </p:extLst>
   </p:cSld>
@@ -47393,7 +48058,7 @@
           <p:cNvPr id="26" name="">
             <a:extLst xmlns:a="http://schemas.openxmlformats.org/drawingml/2006/main">
               <a:ext uri="{FF2B5EF4-FFF2-40B4-BE49-F238E27FC236}">
-                <a16:creationId xmlns:a16="http://schemas.microsoft.com/office/drawing/2014/main" id="{CA0DC302-95CB-4BAD-AE2A-FCD32EEDDE73}"/>
+                <a16:creationId xmlns:a16="http://schemas.microsoft.com/office/drawing/2014/main" id="{1C5FD675-F338-4922-A4E9-88624148F862}"/>
               </a:ext>
             </a:extLst>
           </p:cNvPr>
@@ -47446,7 +48111,7 @@
           <p:cNvPr id="27" name="">
             <a:extLst xmlns:a="http://schemas.openxmlformats.org/drawingml/2006/main">
               <a:ext uri="{FF2B5EF4-FFF2-40B4-BE49-F238E27FC236}">
-                <a16:creationId xmlns:a16="http://schemas.microsoft.com/office/drawing/2014/main" id="{37E02159-8A9B-46C9-90D2-DA6DD62FD5A0}"/>
+                <a16:creationId xmlns:a16="http://schemas.microsoft.com/office/drawing/2014/main" id="{E235729A-8179-455E-AE97-E7669A11C106}"/>
               </a:ext>
             </a:extLst>
           </p:cNvPr>
@@ -47540,7 +48205,7 @@
           <p:cNvPr id="28" name="">
             <a:extLst xmlns:a="http://schemas.openxmlformats.org/drawingml/2006/main">
               <a:ext uri="{FF2B5EF4-FFF2-40B4-BE49-F238E27FC236}">
-                <a16:creationId xmlns:a16="http://schemas.microsoft.com/office/drawing/2014/main" id="{2F73CF55-F52D-48D6-B78A-5492562654B2}"/>
+                <a16:creationId xmlns:a16="http://schemas.microsoft.com/office/drawing/2014/main" id="{EDA8B2AE-A3AB-4B1C-8765-24524BE82A9E}"/>
               </a:ext>
             </a:extLst>
           </p:cNvPr>
@@ -47593,7 +48258,7 @@
           <p:cNvPr id="29" name="">
             <a:extLst xmlns:a="http://schemas.openxmlformats.org/drawingml/2006/main">
               <a:ext uri="{FF2B5EF4-FFF2-40B4-BE49-F238E27FC236}">
-                <a16:creationId xmlns:a16="http://schemas.microsoft.com/office/drawing/2014/main" id="{61BEA18A-3BE7-43A1-A769-B23089910F68}"/>
+                <a16:creationId xmlns:a16="http://schemas.microsoft.com/office/drawing/2014/main" id="{756C492C-5C59-4A26-B631-0520249CAC37}"/>
               </a:ext>
             </a:extLst>
           </p:cNvPr>
@@ -47658,7 +48323,7 @@
     </p:spTree>
     <p:extLst>
       <p:ext uri="{BB962C8B-B14F-4D97-AF65-F5344CB8AC3E}">
-        <p14:creationId xmlns:p14="http://schemas.microsoft.com/office/powerpoint/2010/main" val="1242354970"/>
+        <p14:creationId xmlns:p14="http://schemas.microsoft.com/office/powerpoint/2010/main" val="402919761"/>
       </p:ext>
     </p:extLst>
   </p:cSld>
@@ -47682,7 +48347,7 @@
           <p:cNvPr id="120" name="">
             <a:extLst xmlns:a="http://schemas.openxmlformats.org/drawingml/2006/main">
               <a:ext uri="{FF2B5EF4-FFF2-40B4-BE49-F238E27FC236}">
-                <a16:creationId xmlns:a16="http://schemas.microsoft.com/office/drawing/2014/main" id="{BD919CFC-680A-4ED7-B654-0E0FF1B76715}"/>
+                <a16:creationId xmlns:a16="http://schemas.microsoft.com/office/drawing/2014/main" id="{8B8127A3-0CB8-4ECA-AAD1-5D5C7FE20989}"/>
               </a:ext>
             </a:extLst>
           </p:cNvPr>
@@ -47736,7 +48401,7 @@
           <p:cNvPr id="121" name="">
             <a:extLst xmlns:a="http://schemas.openxmlformats.org/drawingml/2006/main">
               <a:ext uri="{FF2B5EF4-FFF2-40B4-BE49-F238E27FC236}">
-                <a16:creationId xmlns:a16="http://schemas.microsoft.com/office/drawing/2014/main" id="{D4E2E49E-43A3-4331-818B-A89B369568F1}"/>
+                <a16:creationId xmlns:a16="http://schemas.microsoft.com/office/drawing/2014/main" id="{40E8F94A-D3EB-4F23-9BF9-F86B3D5276A6}"/>
               </a:ext>
             </a:extLst>
           </p:cNvPr>
@@ -47803,7 +48468,7 @@
           <p:cNvPr id="122" name="">
             <a:extLst xmlns:a="http://schemas.openxmlformats.org/drawingml/2006/main">
               <a:ext uri="{FF2B5EF4-FFF2-40B4-BE49-F238E27FC236}">
-                <a16:creationId xmlns:a16="http://schemas.microsoft.com/office/drawing/2014/main" id="{6ECF7E94-23CC-4344-A401-08C1B59BF937}"/>
+                <a16:creationId xmlns:a16="http://schemas.microsoft.com/office/drawing/2014/main" id="{54AA50D7-D24F-435B-B675-FD0F868F1B59}"/>
               </a:ext>
             </a:extLst>
           </p:cNvPr>
@@ -48265,7 +48930,7 @@
           <p:cNvPr id="123" name="">
             <a:extLst xmlns:a="http://schemas.openxmlformats.org/drawingml/2006/main">
               <a:ext uri="{FF2B5EF4-FFF2-40B4-BE49-F238E27FC236}">
-                <a16:creationId xmlns:a16="http://schemas.microsoft.com/office/drawing/2014/main" id="{C62D0D0A-0C2C-40F8-B02C-FD51CFB42E0A}"/>
+                <a16:creationId xmlns:a16="http://schemas.microsoft.com/office/drawing/2014/main" id="{14827209-21E1-4842-927C-D4A1A4016104}"/>
               </a:ext>
             </a:extLst>
           </p:cNvPr>
@@ -48340,7 +49005,7 @@
           <p:cNvPr id="124" name="">
             <a:extLst xmlns:a="http://schemas.openxmlformats.org/drawingml/2006/main">
               <a:ext uri="{FF2B5EF4-FFF2-40B4-BE49-F238E27FC236}">
-                <a16:creationId xmlns:a16="http://schemas.microsoft.com/office/drawing/2014/main" id="{71415566-453B-4DFD-99EF-C2F5720ED1AB}"/>
+                <a16:creationId xmlns:a16="http://schemas.microsoft.com/office/drawing/2014/main" id="{7B593D54-FB77-422A-B262-F18A03539D87}"/>
               </a:ext>
             </a:extLst>
           </p:cNvPr>
@@ -48450,7 +49115,7 @@
           <p:cNvPr id="125" name="">
             <a:extLst xmlns:a="http://schemas.openxmlformats.org/drawingml/2006/main">
               <a:ext uri="{FF2B5EF4-FFF2-40B4-BE49-F238E27FC236}">
-                <a16:creationId xmlns:a16="http://schemas.microsoft.com/office/drawing/2014/main" id="{5BAA69F5-116D-4B32-AC07-F3C642D0B2D3}"/>
+                <a16:creationId xmlns:a16="http://schemas.microsoft.com/office/drawing/2014/main" id="{A7959816-73EA-49D2-BCB2-F50515F535CF}"/>
               </a:ext>
             </a:extLst>
           </p:cNvPr>
@@ -48525,7 +49190,7 @@
           <p:cNvPr id="126" name="">
             <a:extLst xmlns:a="http://schemas.openxmlformats.org/drawingml/2006/main">
               <a:ext uri="{FF2B5EF4-FFF2-40B4-BE49-F238E27FC236}">
-                <a16:creationId xmlns:a16="http://schemas.microsoft.com/office/drawing/2014/main" id="{E68C548A-13C2-4939-B3BF-BB44B61F8F32}"/>
+                <a16:creationId xmlns:a16="http://schemas.microsoft.com/office/drawing/2014/main" id="{2162145B-3F9E-40E4-9EAF-31021B17E9AA}"/>
               </a:ext>
             </a:extLst>
           </p:cNvPr>
@@ -48635,7 +49300,7 @@
           <p:cNvPr id="127" name="">
             <a:extLst xmlns:a="http://schemas.openxmlformats.org/drawingml/2006/main">
               <a:ext uri="{FF2B5EF4-FFF2-40B4-BE49-F238E27FC236}">
-                <a16:creationId xmlns:a16="http://schemas.microsoft.com/office/drawing/2014/main" id="{21F524E0-2EED-4D18-931C-220020F33DE9}"/>
+                <a16:creationId xmlns:a16="http://schemas.microsoft.com/office/drawing/2014/main" id="{FABD9BB6-4FA1-4911-B03D-BEEBE352FF93}"/>
               </a:ext>
             </a:extLst>
           </p:cNvPr>
@@ -48710,7 +49375,7 @@
           <p:cNvPr id="128" name="">
             <a:extLst xmlns:a="http://schemas.openxmlformats.org/drawingml/2006/main">
               <a:ext uri="{FF2B5EF4-FFF2-40B4-BE49-F238E27FC236}">
-                <a16:creationId xmlns:a16="http://schemas.microsoft.com/office/drawing/2014/main" id="{8B5E0EA7-381E-48B0-9DF7-DF5A40F7B7A5}"/>
+                <a16:creationId xmlns:a16="http://schemas.microsoft.com/office/drawing/2014/main" id="{C09CBB75-8392-4D1D-B1D3-189A0615B830}"/>
               </a:ext>
             </a:extLst>
           </p:cNvPr>
@@ -48820,7 +49485,7 @@
           <p:cNvPr id="129" name="">
             <a:extLst xmlns:a="http://schemas.openxmlformats.org/drawingml/2006/main">
               <a:ext uri="{FF2B5EF4-FFF2-40B4-BE49-F238E27FC236}">
-                <a16:creationId xmlns:a16="http://schemas.microsoft.com/office/drawing/2014/main" id="{DBB90792-BEF2-4906-9F4D-5CC4447462A9}"/>
+                <a16:creationId xmlns:a16="http://schemas.microsoft.com/office/drawing/2014/main" id="{6CD1CB88-1DD8-4791-932F-BC6B1B21C308}"/>
               </a:ext>
             </a:extLst>
           </p:cNvPr>
@@ -48885,7 +49550,7 @@
     </p:spTree>
     <p:extLst>
       <p:ext uri="{BB962C8B-B14F-4D97-AF65-F5344CB8AC3E}">
-        <p14:creationId xmlns:p14="http://schemas.microsoft.com/office/powerpoint/2010/main" val="2112704824"/>
+        <p14:creationId xmlns:p14="http://schemas.microsoft.com/office/powerpoint/2010/main" val="71809283"/>
       </p:ext>
     </p:extLst>
   </p:cSld>

</xml_diff>